<commit_message>
select the impeccable poster as the final deliverable
</commit_message>
<xml_diff>
--- a/prj_fin/deliverables/poster.pptx
+++ b/prj_fin/deliverables/poster.pptx
@@ -3084,7 +3084,7 @@
     <p:bg>
       <p:bgPr>
         <a:solidFill>
-          <a:srgbClr val="F4EFE6"/>
+          <a:srgbClr val="FFFFFF"/>
         </a:solidFill>
         <a:effectLst/>
       </p:bgPr>
@@ -3098,150 +3098,25 @@
       <p:grpSpPr/>
       <p:sp>
         <p:nvSpPr>
-          <p:cNvPr id="2" name="TextBox 1"/>
-          <p:cNvSpPr txBox="1"/>
+          <p:cNvPr id="2" name="Rectangle 1"/>
+          <p:cNvSpPr/>
           <p:nvPr/>
         </p:nvSpPr>
         <p:spPr>
           <a:xfrm>
-            <a:off x="502920" y="301752"/>
-            <a:ext cx="4480560" cy="182880"/>
+            <a:off x="0" y="0"/>
+            <a:ext cx="7560259" cy="2240280"/>
           </a:xfrm>
           <a:prstGeom prst="rect">
             <a:avLst/>
           </a:prstGeom>
-          <a:noFill/>
-        </p:spPr>
-        <p:txBody>
-          <a:bodyPr wrap="square" lIns="0" rIns="0" tIns="0" bIns="0" anchor="t">
-            <a:spAutoFit/>
-          </a:bodyPr>
-          <a:lstStyle/>
-          <a:p>
-            <a:pPr algn="l">
-              <a:lnSpc>
-                <a:spcPct val="100000"/>
-              </a:lnSpc>
-              <a:spcAft>
-                <a:spcPts val="0"/>
-              </a:spcAft>
-            </a:pPr>
-            <a:r>
-              <a:rPr sz="750" b="1" i="0">
-                <a:solidFill>
-                  <a:srgbClr val="1C1917"/>
-                </a:solidFill>
-                <a:latin typeface="Segoe UI"/>
-              </a:rPr>
-              <a:t>AMD FPGA INNOVATION DESIGN COMPETITION</a:t>
-            </a:r>
-          </a:p>
-        </p:txBody>
-      </p:sp>
-      <p:sp>
-        <p:nvSpPr>
-          <p:cNvPr id="3" name="TextBox 2"/>
-          <p:cNvSpPr txBox="1"/>
-          <p:nvPr/>
-        </p:nvSpPr>
-        <p:spPr>
-          <a:xfrm>
-            <a:off x="4572000" y="310896"/>
-            <a:ext cx="2057400" cy="182880"/>
-          </a:xfrm>
-          <a:prstGeom prst="rect">
-            <a:avLst/>
-          </a:prstGeom>
-          <a:noFill/>
-        </p:spPr>
-        <p:txBody>
-          <a:bodyPr wrap="square" lIns="0" rIns="0" tIns="0" bIns="0" anchor="t">
-            <a:spAutoFit/>
-          </a:bodyPr>
-          <a:lstStyle/>
-          <a:p>
-            <a:pPr algn="r">
-              <a:lnSpc>
-                <a:spcPct val="100000"/>
-              </a:lnSpc>
-              <a:spcAft>
-                <a:spcPts val="0"/>
-              </a:spcAft>
-            </a:pPr>
-            <a:r>
-              <a:rPr sz="680" b="0" i="0">
-                <a:solidFill>
-                  <a:srgbClr val="57534E"/>
-                </a:solidFill>
-                <a:latin typeface="Segoe UI"/>
-              </a:rPr>
-              <a:t>PRIMARY GROUP   ·   SELF-DEFINED TRACK</a:t>
-            </a:r>
-          </a:p>
-        </p:txBody>
-      </p:sp>
-      <p:sp>
-        <p:nvSpPr>
-          <p:cNvPr id="4" name="TextBox 3"/>
-          <p:cNvSpPr txBox="1"/>
-          <p:nvPr/>
-        </p:nvSpPr>
-        <p:spPr>
-          <a:xfrm>
-            <a:off x="6711696" y="246888"/>
-            <a:ext cx="585216" cy="274320"/>
-          </a:xfrm>
-          <a:prstGeom prst="rect">
-            <a:avLst/>
-          </a:prstGeom>
-          <a:noFill/>
-        </p:spPr>
-        <p:txBody>
-          <a:bodyPr wrap="square" lIns="0" rIns="0" tIns="0" bIns="0" anchor="t">
-            <a:spAutoFit/>
-          </a:bodyPr>
-          <a:lstStyle/>
-          <a:p>
-            <a:pPr algn="l">
-              <a:lnSpc>
-                <a:spcPct val="100000"/>
-              </a:lnSpc>
-              <a:spcAft>
-                <a:spcPts val="0"/>
-              </a:spcAft>
-            </a:pPr>
-            <a:r>
-              <a:rPr sz="1700" b="1" i="0">
-                <a:solidFill>
-                  <a:srgbClr val="1C1917"/>
-                </a:solidFill>
-                <a:latin typeface="Segoe UI"/>
-              </a:rPr>
-              <a:t>AMD</a:t>
-            </a:r>
-          </a:p>
-        </p:txBody>
-      </p:sp>
-      <p:sp>
-        <p:nvSpPr>
-          <p:cNvPr id="5" name="Isosceles Triangle 4"/>
-          <p:cNvSpPr/>
-          <p:nvPr/>
-        </p:nvSpPr>
-        <p:spPr>
-          <a:xfrm rot="5400000">
-            <a:off x="7260336" y="292608"/>
-            <a:ext cx="146304" cy="114117"/>
-          </a:xfrm>
-          <a:prstGeom prst="triangle">
-            <a:avLst/>
-          </a:prstGeom>
           <a:solidFill>
-            <a:srgbClr val="1C1917"/>
+            <a:srgbClr val="F3EBDD"/>
           </a:solidFill>
           <a:ln>
             <a:noFill/>
           </a:ln>
+          <a:effectLst/>
         </p:spPr>
         <p:style>
           <a:lnRef idx="1">
@@ -3267,25 +3142,141 @@
       </p:sp>
       <p:sp>
         <p:nvSpPr>
-          <p:cNvPr id="6" name="Rectangle 5"/>
-          <p:cNvSpPr/>
+          <p:cNvPr id="3" name="TextBox 2"/>
+          <p:cNvSpPr txBox="1"/>
           <p:nvPr/>
         </p:nvSpPr>
         <p:spPr>
           <a:xfrm>
-            <a:off x="502920" y="512064"/>
-            <a:ext cx="6556248" cy="7315"/>
+            <a:off x="475488" y="274320"/>
+            <a:ext cx="4389120" cy="182880"/>
           </a:xfrm>
           <a:prstGeom prst="rect">
             <a:avLst/>
           </a:prstGeom>
+          <a:noFill/>
+        </p:spPr>
+        <p:txBody>
+          <a:bodyPr wrap="square" lIns="0" rIns="0" tIns="0" bIns="0" anchor="t">
+            <a:spAutoFit/>
+          </a:bodyPr>
+          <a:lstStyle/>
+          <a:p>
+            <a:pPr algn="l">
+              <a:lnSpc>
+                <a:spcPct val="100000"/>
+              </a:lnSpc>
+            </a:pPr>
+            <a:r>
+              <a:rPr sz="740" b="1" i="0">
+                <a:solidFill>
+                  <a:srgbClr val="111827"/>
+                </a:solidFill>
+                <a:latin typeface="Bahnschrift"/>
+              </a:rPr>
+              <a:t>AMD FPGA INNOVATION DESIGN COMPETITION</a:t>
+            </a:r>
+          </a:p>
+        </p:txBody>
+      </p:sp>
+      <p:sp>
+        <p:nvSpPr>
+          <p:cNvPr id="4" name="TextBox 3"/>
+          <p:cNvSpPr txBox="1"/>
+          <p:nvPr/>
+        </p:nvSpPr>
+        <p:spPr>
+          <a:xfrm>
+            <a:off x="4526280" y="283464"/>
+            <a:ext cx="2148840" cy="182880"/>
+          </a:xfrm>
+          <a:prstGeom prst="rect">
+            <a:avLst/>
+          </a:prstGeom>
+          <a:noFill/>
+        </p:spPr>
+        <p:txBody>
+          <a:bodyPr wrap="square" lIns="0" rIns="0" tIns="0" bIns="0" anchor="t">
+            <a:spAutoFit/>
+          </a:bodyPr>
+          <a:lstStyle/>
+          <a:p>
+            <a:pPr algn="r">
+              <a:lnSpc>
+                <a:spcPct val="100000"/>
+              </a:lnSpc>
+            </a:pPr>
+            <a:r>
+              <a:rPr sz="660" b="0" i="0">
+                <a:solidFill>
+                  <a:srgbClr val="4B5563"/>
+                </a:solidFill>
+                <a:latin typeface="Bahnschrift"/>
+              </a:rPr>
+              <a:t>PRIMARY GROUP   ·   SELF-DEFINED TRACK</a:t>
+            </a:r>
+          </a:p>
+        </p:txBody>
+      </p:sp>
+      <p:sp>
+        <p:nvSpPr>
+          <p:cNvPr id="5" name="TextBox 4"/>
+          <p:cNvSpPr txBox="1"/>
+          <p:nvPr/>
+        </p:nvSpPr>
+        <p:spPr>
+          <a:xfrm>
+            <a:off x="6711696" y="228600"/>
+            <a:ext cx="585216" cy="256032"/>
+          </a:xfrm>
+          <a:prstGeom prst="rect">
+            <a:avLst/>
+          </a:prstGeom>
+          <a:noFill/>
+        </p:spPr>
+        <p:txBody>
+          <a:bodyPr wrap="square" lIns="0" rIns="0" tIns="0" bIns="0" anchor="t">
+            <a:spAutoFit/>
+          </a:bodyPr>
+          <a:lstStyle/>
+          <a:p>
+            <a:pPr algn="l">
+              <a:lnSpc>
+                <a:spcPct val="100000"/>
+              </a:lnSpc>
+            </a:pPr>
+            <a:r>
+              <a:rPr sz="1700" b="1" i="0">
+                <a:solidFill>
+                  <a:srgbClr val="111827"/>
+                </a:solidFill>
+                <a:latin typeface="Bahnschrift"/>
+              </a:rPr>
+              <a:t>AMD</a:t>
+            </a:r>
+          </a:p>
+        </p:txBody>
+      </p:sp>
+      <p:sp>
+        <p:nvSpPr>
+          <p:cNvPr id="6" name="Isosceles Triangle 5"/>
+          <p:cNvSpPr/>
+          <p:nvPr/>
+        </p:nvSpPr>
+        <p:spPr>
+          <a:xfrm rot="5400000">
+            <a:off x="7260336" y="274320"/>
+            <a:ext cx="137160" cy="106984"/>
+          </a:xfrm>
+          <a:prstGeom prst="triangle">
+            <a:avLst/>
+          </a:prstGeom>
           <a:solidFill>
-            <a:srgbClr val="D8CFC1"/>
+            <a:srgbClr val="111827"/>
           </a:solidFill>
           <a:ln>
             <a:noFill/>
           </a:ln>
-          <a:effectLst/>
         </p:spPr>
         <p:style>
           <a:lnRef idx="1">
@@ -3311,254 +3302,20 @@
       </p:sp>
       <p:sp>
         <p:nvSpPr>
-          <p:cNvPr id="7" name="TextBox 6"/>
-          <p:cNvSpPr txBox="1"/>
-          <p:nvPr/>
-        </p:nvSpPr>
-        <p:spPr>
-          <a:xfrm>
-            <a:off x="502920" y="640080"/>
-            <a:ext cx="5486400" cy="182880"/>
-          </a:xfrm>
-          <a:prstGeom prst="rect">
-            <a:avLst/>
-          </a:prstGeom>
-          <a:noFill/>
-        </p:spPr>
-        <p:txBody>
-          <a:bodyPr wrap="square" lIns="0" rIns="0" tIns="0" bIns="0" anchor="t">
-            <a:spAutoFit/>
-          </a:bodyPr>
-          <a:lstStyle/>
-          <a:p>
-            <a:pPr algn="l">
-              <a:lnSpc>
-                <a:spcPct val="100000"/>
-              </a:lnSpc>
-              <a:spcAft>
-                <a:spcPts val="0"/>
-              </a:spcAft>
-            </a:pPr>
-            <a:r>
-              <a:rPr sz="800" b="1" i="0">
-                <a:solidFill>
-                  <a:srgbClr val="B45309"/>
-                </a:solidFill>
-                <a:latin typeface="Segoe UI"/>
-              </a:rPr>
-              <a:t>ZYNQ-7020   ·   A FULLY HARDWARE VIDEO NODE</a:t>
-            </a:r>
-          </a:p>
-        </p:txBody>
-      </p:sp>
-      <p:sp>
-        <p:nvSpPr>
-          <p:cNvPr id="8" name="TextBox 7"/>
-          <p:cNvSpPr txBox="1"/>
-          <p:nvPr/>
-        </p:nvSpPr>
-        <p:spPr>
-          <a:xfrm>
-            <a:off x="502920" y="859536"/>
-            <a:ext cx="6492240" cy="603504"/>
-          </a:xfrm>
-          <a:prstGeom prst="rect">
-            <a:avLst/>
-          </a:prstGeom>
-          <a:noFill/>
-        </p:spPr>
-        <p:txBody>
-          <a:bodyPr wrap="square" lIns="0" rIns="0" tIns="0" bIns="0" anchor="t">
-            <a:spAutoFit/>
-          </a:bodyPr>
-          <a:lstStyle/>
-          <a:p>
-            <a:pPr algn="l">
-              <a:lnSpc>
-                <a:spcPct val="100000"/>
-              </a:lnSpc>
-              <a:spcAft>
-                <a:spcPts val="0"/>
-              </a:spcAft>
-            </a:pPr>
-            <a:r>
-              <a:rPr sz="4000" b="1" i="0">
-                <a:solidFill>
-                  <a:srgbClr val="1C1917"/>
-                </a:solidFill>
-                <a:latin typeface="Georgia"/>
-              </a:rPr>
-              <a:t>One frame.</a:t>
-            </a:r>
-          </a:p>
-        </p:txBody>
-      </p:sp>
-      <p:sp>
-        <p:nvSpPr>
-          <p:cNvPr id="9" name="TextBox 8"/>
-          <p:cNvSpPr txBox="1"/>
-          <p:nvPr/>
-        </p:nvSpPr>
-        <p:spPr>
-          <a:xfrm>
-            <a:off x="502920" y="1399032"/>
-            <a:ext cx="6492240" cy="603504"/>
-          </a:xfrm>
-          <a:prstGeom prst="rect">
-            <a:avLst/>
-          </a:prstGeom>
-          <a:noFill/>
-        </p:spPr>
-        <p:txBody>
-          <a:bodyPr wrap="square" lIns="0" rIns="0" tIns="0" bIns="0" anchor="t">
-            <a:spAutoFit/>
-          </a:bodyPr>
-          <a:lstStyle/>
-          <a:p>
-            <a:pPr algn="l">
-              <a:lnSpc>
-                <a:spcPct val="100000"/>
-              </a:lnSpc>
-              <a:spcAft>
-                <a:spcPts val="0"/>
-              </a:spcAft>
-            </a:pPr>
-            <a:r>
-              <a:rPr sz="4000" b="0" i="1">
-                <a:solidFill>
-                  <a:srgbClr val="B45309"/>
-                </a:solidFill>
-                <a:latin typeface="Georgia"/>
-              </a:rPr>
-              <a:t>Two truths.</a:t>
-            </a:r>
-          </a:p>
-        </p:txBody>
-      </p:sp>
-      <p:sp>
-        <p:nvSpPr>
-          <p:cNvPr id="10" name="TextBox 9"/>
-          <p:cNvSpPr txBox="1"/>
-          <p:nvPr/>
-        </p:nvSpPr>
-        <p:spPr>
-          <a:xfrm>
-            <a:off x="502920" y="2084831"/>
-            <a:ext cx="6446520" cy="603504"/>
-          </a:xfrm>
-          <a:prstGeom prst="rect">
-            <a:avLst/>
-          </a:prstGeom>
-          <a:noFill/>
-        </p:spPr>
-        <p:txBody>
-          <a:bodyPr wrap="square" lIns="0" rIns="0" tIns="0" bIns="0" anchor="t">
-            <a:spAutoFit/>
-          </a:bodyPr>
-          <a:lstStyle/>
-          <a:p>
-            <a:pPr algn="l">
-              <a:lnSpc>
-                <a:spcPct val="112000"/>
-              </a:lnSpc>
-              <a:spcAft>
-                <a:spcPts val="0"/>
-              </a:spcAft>
-            </a:pPr>
-            <a:r>
-              <a:rPr sz="1050" b="0" i="0">
-                <a:solidFill>
-                  <a:srgbClr val="57534E"/>
-                </a:solidFill>
-                <a:latin typeface="Segoe UI"/>
-              </a:rPr>
-              <a:t>Original and processed pixels leave one frame buffer in the same clock, so the split screen compares content rather than screenshots. The node reports what it did on the wire at 1 Hz.</a:t>
-            </a:r>
-          </a:p>
-        </p:txBody>
-      </p:sp>
-      <p:pic>
-        <p:nvPicPr>
-          <p:cNvPr id="11" name="Picture 10" descr="poster_frame_split.png"/>
-          <p:cNvPicPr>
-            <a:picLocks noChangeAspect="1"/>
-          </p:cNvPicPr>
-          <p:nvPr/>
-        </p:nvPicPr>
-        <p:blipFill>
-          <a:blip r:embed="rId2"/>
-          <a:stretch>
-            <a:fillRect/>
-          </a:stretch>
-        </p:blipFill>
-        <p:spPr>
-          <a:xfrm>
-            <a:off x="502920" y="2761488"/>
-            <a:ext cx="6554419" cy="3840480"/>
-          </a:xfrm>
-          <a:prstGeom prst="rect">
-            <a:avLst/>
-          </a:prstGeom>
-        </p:spPr>
-      </p:pic>
-      <p:sp>
-        <p:nvSpPr>
-          <p:cNvPr id="12" name="TextBox 11"/>
-          <p:cNvSpPr txBox="1"/>
-          <p:nvPr/>
-        </p:nvSpPr>
-        <p:spPr>
-          <a:xfrm>
-            <a:off x="502920" y="6647688"/>
-            <a:ext cx="6492240" cy="146304"/>
-          </a:xfrm>
-          <a:prstGeom prst="rect">
-            <a:avLst/>
-          </a:prstGeom>
-          <a:noFill/>
-        </p:spPr>
-        <p:txBody>
-          <a:bodyPr wrap="square" lIns="0" rIns="0" tIns="0" bIns="0" anchor="t">
-            <a:spAutoFit/>
-          </a:bodyPr>
-          <a:lstStyle/>
-          <a:p>
-            <a:pPr algn="l">
-              <a:lnSpc>
-                <a:spcPct val="100000"/>
-              </a:lnSpc>
-              <a:spcAft>
-                <a:spcPts val="0"/>
-              </a:spcAft>
-            </a:pPr>
-            <a:r>
-              <a:rPr sz="680" b="0" i="1">
-                <a:solidFill>
-                  <a:srgbClr val="57534E"/>
-                </a:solidFill>
-                <a:latin typeface="Segoe UI"/>
-              </a:rPr>
-              <a:t>Rendered from the same 512×300 test frame through the implemented Sobel chain at 0°, no rotation.</a:t>
-            </a:r>
-          </a:p>
-        </p:txBody>
-      </p:sp>
-      <p:sp>
-        <p:nvSpPr>
-          <p:cNvPr id="13" name="Rectangle 12"/>
+          <p:cNvPr id="7" name="Rectangle 6"/>
           <p:cNvSpPr/>
           <p:nvPr/>
         </p:nvSpPr>
         <p:spPr>
           <a:xfrm>
-            <a:off x="502920" y="6903720"/>
-            <a:ext cx="2048256" cy="7315"/>
+            <a:off x="475488" y="493776"/>
+            <a:ext cx="6601968" cy="7315"/>
           </a:xfrm>
           <a:prstGeom prst="rect">
             <a:avLst/>
           </a:prstGeom>
           <a:solidFill>
-            <a:srgbClr val="1C1917"/>
+            <a:srgbClr val="C55221"/>
           </a:solidFill>
           <a:ln>
             <a:noFill/>
@@ -3589,14 +3346,14 @@
       </p:sp>
       <p:sp>
         <p:nvSpPr>
-          <p:cNvPr id="14" name="TextBox 13"/>
+          <p:cNvPr id="8" name="TextBox 7"/>
           <p:cNvSpPr txBox="1"/>
           <p:nvPr/>
         </p:nvSpPr>
         <p:spPr>
           <a:xfrm>
-            <a:off x="502920" y="6986016"/>
-            <a:ext cx="2048256" cy="164592"/>
+            <a:off x="475488" y="621792"/>
+            <a:ext cx="5852160" cy="182880"/>
           </a:xfrm>
           <a:prstGeom prst="rect">
             <a:avLst/>
@@ -3613,32 +3370,29 @@
               <a:lnSpc>
                 <a:spcPct val="100000"/>
               </a:lnSpc>
-              <a:spcAft>
-                <a:spcPts val="0"/>
-              </a:spcAft>
             </a:pPr>
             <a:r>
-              <a:rPr sz="819" b="1" i="0">
-                <a:solidFill>
-                  <a:srgbClr val="B45309"/>
-                </a:solidFill>
-                <a:latin typeface="Segoe UI"/>
+              <a:rPr sz="1000" b="1" i="0">
+                <a:solidFill>
+                  <a:srgbClr val="C55221"/>
+                </a:solidFill>
+                <a:latin typeface="Bahnschrift"/>
               </a:rPr>
-              <a:t>01   SAME-FRAME A/B</a:t>
-            </a:r>
-          </a:p>
-        </p:txBody>
-      </p:sp>
-      <p:sp>
-        <p:nvSpPr>
-          <p:cNvPr id="15" name="TextBox 14"/>
+              <a:t>ZYNQ-7020   ·   A FULLY HARDWARE VIDEO NODE</a:t>
+            </a:r>
+          </a:p>
+        </p:txBody>
+      </p:sp>
+      <p:sp>
+        <p:nvSpPr>
+          <p:cNvPr id="9" name="TextBox 8"/>
           <p:cNvSpPr txBox="1"/>
           <p:nvPr/>
         </p:nvSpPr>
         <p:spPr>
           <a:xfrm>
-            <a:off x="502920" y="7178040"/>
-            <a:ext cx="2048256" cy="868680"/>
+            <a:off x="475488" y="859536"/>
+            <a:ext cx="6583680" cy="502920"/>
           </a:xfrm>
           <a:prstGeom prst="rect">
             <a:avLst/>
@@ -3653,40 +3407,115 @@
           <a:p>
             <a:pPr algn="l">
               <a:lnSpc>
-                <a:spcPct val="114000"/>
+                <a:spcPct val="100000"/>
               </a:lnSpc>
-              <a:spcAft>
-                <a:spcPts val="0"/>
-              </a:spcAft>
             </a:pPr>
             <a:r>
-              <a:rPr sz="800" b="0" i="0">
-                <a:solidFill>
-                  <a:srgbClr val="57534E"/>
-                </a:solidFill>
-                <a:latin typeface="Segoe UI"/>
+              <a:rPr sz="3200" b="0" i="0">
+                <a:solidFill>
+                  <a:srgbClr val="111827"/>
+                </a:solidFill>
+                <a:latin typeface="Bahnschrift"/>
               </a:rPr>
-              <a:t>A fixed 15-cycle effect chain sits behind both halves. The seam is a pixel decision, not a compositing trick.</a:t>
-            </a:r>
-          </a:p>
-        </p:txBody>
-      </p:sp>
-      <p:sp>
-        <p:nvSpPr>
-          <p:cNvPr id="16" name="Rectangle 15"/>
+              <a:t>ONE FRAME.</a:t>
+            </a:r>
+          </a:p>
+        </p:txBody>
+      </p:sp>
+      <p:sp>
+        <p:nvSpPr>
+          <p:cNvPr id="10" name="TextBox 9"/>
+          <p:cNvSpPr txBox="1"/>
+          <p:nvPr/>
+        </p:nvSpPr>
+        <p:spPr>
+          <a:xfrm>
+            <a:off x="475488" y="1243584"/>
+            <a:ext cx="6583680" cy="502920"/>
+          </a:xfrm>
+          <a:prstGeom prst="rect">
+            <a:avLst/>
+          </a:prstGeom>
+          <a:noFill/>
+        </p:spPr>
+        <p:txBody>
+          <a:bodyPr wrap="square" lIns="0" rIns="0" tIns="0" bIns="0" anchor="t">
+            <a:spAutoFit/>
+          </a:bodyPr>
+          <a:lstStyle/>
+          <a:p>
+            <a:pPr algn="l">
+              <a:lnSpc>
+                <a:spcPct val="100000"/>
+              </a:lnSpc>
+            </a:pPr>
+            <a:r>
+              <a:rPr sz="3200" b="0" i="0">
+                <a:solidFill>
+                  <a:srgbClr val="C55221"/>
+                </a:solidFill>
+                <a:latin typeface="Bahnschrift"/>
+              </a:rPr>
+              <a:t>TWO TRUTHS.</a:t>
+            </a:r>
+          </a:p>
+        </p:txBody>
+      </p:sp>
+      <p:sp>
+        <p:nvSpPr>
+          <p:cNvPr id="11" name="TextBox 10"/>
+          <p:cNvSpPr txBox="1"/>
+          <p:nvPr/>
+        </p:nvSpPr>
+        <p:spPr>
+          <a:xfrm>
+            <a:off x="475488" y="1700784"/>
+            <a:ext cx="6400800" cy="420624"/>
+          </a:xfrm>
+          <a:prstGeom prst="rect">
+            <a:avLst/>
+          </a:prstGeom>
+          <a:noFill/>
+        </p:spPr>
+        <p:txBody>
+          <a:bodyPr wrap="square" lIns="0" rIns="0" tIns="0" bIns="0" anchor="t">
+            <a:spAutoFit/>
+          </a:bodyPr>
+          <a:lstStyle/>
+          <a:p>
+            <a:pPr algn="l">
+              <a:lnSpc>
+                <a:spcPct val="106000"/>
+              </a:lnSpc>
+            </a:pPr>
+            <a:r>
+              <a:rPr sz="1100" b="0" i="0">
+                <a:solidFill>
+                  <a:srgbClr val="4B5563"/>
+                </a:solidFill>
+                <a:latin typeface="Bahnschrift"/>
+              </a:rPr>
+              <a:t>Original and processed pixels leave one frame buffer in the same clock; the seam compares content, not screenshots. The node reports what it did on the wire at 1 Hz.</a:t>
+            </a:r>
+          </a:p>
+        </p:txBody>
+      </p:sp>
+      <p:sp>
+        <p:nvSpPr>
+          <p:cNvPr id="12" name="Rectangle 11"/>
           <p:cNvSpPr/>
           <p:nvPr/>
         </p:nvSpPr>
         <p:spPr>
           <a:xfrm>
-            <a:off x="2756916" y="6903720"/>
-            <a:ext cx="2048256" cy="7315"/>
+            <a:off x="0" y="2240280"/>
+            <a:ext cx="7560259" cy="365760"/>
           </a:xfrm>
           <a:prstGeom prst="rect">
             <a:avLst/>
           </a:prstGeom>
           <a:solidFill>
-            <a:srgbClr val="1C1917"/>
+            <a:srgbClr val="C55221"/>
           </a:solidFill>
           <a:ln>
             <a:noFill/>
@@ -3717,14 +3546,14 @@
       </p:sp>
       <p:sp>
         <p:nvSpPr>
-          <p:cNvPr id="17" name="TextBox 16"/>
+          <p:cNvPr id="13" name="TextBox 12"/>
           <p:cNvSpPr txBox="1"/>
           <p:nvPr/>
         </p:nvSpPr>
         <p:spPr>
           <a:xfrm>
-            <a:off x="2756916" y="6986016"/>
-            <a:ext cx="2048256" cy="164592"/>
+            <a:off x="475488" y="2313432"/>
+            <a:ext cx="6583680" cy="182880"/>
           </a:xfrm>
           <a:prstGeom prst="rect">
             <a:avLst/>
@@ -3741,83 +3570,62 @@
               <a:lnSpc>
                 <a:spcPct val="100000"/>
               </a:lnSpc>
-              <a:spcAft>
-                <a:spcPts val="0"/>
-              </a:spcAft>
             </a:pPr>
             <a:r>
-              <a:rPr sz="819" b="1" i="0">
-                <a:solidFill>
-                  <a:srgbClr val="B45309"/>
-                </a:solidFill>
-                <a:latin typeface="Segoe UI"/>
+              <a:rPr sz="1200" b="1" i="0">
+                <a:solidFill>
+                  <a:srgbClr val="FFFFFF"/>
+                </a:solidFill>
+                <a:latin typeface="Consolas"/>
               </a:rPr>
-              <a:t>02   CAUSE-BEARING TELEMETRY</a:t>
-            </a:r>
-          </a:p>
-        </p:txBody>
-      </p:sp>
-      <p:sp>
-        <p:nvSpPr>
-          <p:cNvPr id="18" name="TextBox 17"/>
-          <p:cNvSpPr txBox="1"/>
+              <a:t>SAME 512×300 FRAME   /   SOBEL   /   0°   /   NO ROTATION</a:t>
+            </a:r>
+          </a:p>
+        </p:txBody>
+      </p:sp>
+      <p:pic>
+        <p:nvPicPr>
+          <p:cNvPr id="14" name="Picture 13" descr="poster_frame_split.png"/>
+          <p:cNvPicPr>
+            <a:picLocks noChangeAspect="1"/>
+          </p:cNvPicPr>
           <p:nvPr/>
-        </p:nvSpPr>
-        <p:spPr>
-          <a:xfrm>
-            <a:off x="2756916" y="7178040"/>
-            <a:ext cx="2048256" cy="868680"/>
+        </p:nvPicPr>
+        <p:blipFill>
+          <a:blip r:embed="rId2"/>
+          <a:stretch>
+            <a:fillRect/>
+          </a:stretch>
+        </p:blipFill>
+        <p:spPr>
+          <a:xfrm>
+            <a:off x="475488" y="2724912"/>
+            <a:ext cx="6601968" cy="3867912"/>
+          </a:xfrm>
+          <a:prstGeom prst="rect">
+            <a:avLst/>
+          </a:prstGeom>
+        </p:spPr>
+      </p:pic>
+      <p:sp>
+        <p:nvSpPr>
+          <p:cNvPr id="15" name="Rectangle 14"/>
+          <p:cNvSpPr/>
+          <p:nvPr/>
+        </p:nvSpPr>
+        <p:spPr>
+          <a:xfrm>
+            <a:off x="475488" y="2724912"/>
+            <a:ext cx="6601968" cy="3867912"/>
           </a:xfrm>
           <a:prstGeom prst="rect">
             <a:avLst/>
           </a:prstGeom>
           <a:noFill/>
-        </p:spPr>
-        <p:txBody>
-          <a:bodyPr wrap="square" lIns="0" rIns="0" tIns="0" bIns="0" anchor="t">
-            <a:spAutoFit/>
-          </a:bodyPr>
-          <a:lstStyle/>
-          <a:p>
-            <a:pPr algn="l">
-              <a:lnSpc>
-                <a:spcPct val="114000"/>
-              </a:lnSpc>
-              <a:spcAft>
-                <a:spcPts val="0"/>
-              </a:spcAft>
-            </a:pPr>
-            <a:r>
-              <a:rPr sz="800" b="0" i="0">
-                <a:solidFill>
-                  <a:srgbClr val="57534E"/>
-                </a:solidFill>
-                <a:latin typeface="Segoe UI"/>
-              </a:rPr>
-              <a:t>Frames, aborts, missing rows, PL latency, pane integrity and frame gaps arrive as a 1 Hz UDP beacon, not just FPS.</a:t>
-            </a:r>
-          </a:p>
-        </p:txBody>
-      </p:sp>
-      <p:sp>
-        <p:nvSpPr>
-          <p:cNvPr id="19" name="Rectangle 18"/>
-          <p:cNvSpPr/>
-          <p:nvPr/>
-        </p:nvSpPr>
-        <p:spPr>
-          <a:xfrm>
-            <a:off x="5010912" y="6903720"/>
-            <a:ext cx="2048256" cy="7315"/>
-          </a:xfrm>
-          <a:prstGeom prst="rect">
-            <a:avLst/>
-          </a:prstGeom>
-          <a:solidFill>
-            <a:srgbClr val="1C1917"/>
-          </a:solidFill>
-          <a:ln>
-            <a:noFill/>
+          <a:ln w="10160">
+            <a:solidFill>
+              <a:srgbClr val="C55221"/>
+            </a:solidFill>
           </a:ln>
           <a:effectLst/>
         </p:spPr>
@@ -3845,14 +3653,14 @@
       </p:sp>
       <p:sp>
         <p:nvSpPr>
-          <p:cNvPr id="20" name="TextBox 19"/>
+          <p:cNvPr id="16" name="TextBox 15"/>
           <p:cNvSpPr txBox="1"/>
           <p:nvPr/>
         </p:nvSpPr>
         <p:spPr>
           <a:xfrm>
-            <a:off x="5010912" y="6986016"/>
-            <a:ext cx="2048256" cy="164592"/>
+            <a:off x="475488" y="6656832"/>
+            <a:ext cx="6583680" cy="146304"/>
           </a:xfrm>
           <a:prstGeom prst="rect">
             <a:avLst/>
@@ -3869,80 +3677,35 @@
               <a:lnSpc>
                 <a:spcPct val="100000"/>
               </a:lnSpc>
-              <a:spcAft>
-                <a:spcPts val="0"/>
-              </a:spcAft>
             </a:pPr>
             <a:r>
-              <a:rPr sz="819" b="1" i="0">
-                <a:solidFill>
-                  <a:srgbClr val="B45309"/>
-                </a:solidFill>
-                <a:latin typeface="Segoe UI"/>
+              <a:rPr sz="1000" b="0" i="1">
+                <a:solidFill>
+                  <a:srgbClr val="4B5563"/>
+                </a:solidFill>
+                <a:latin typeface="Bahnschrift"/>
               </a:rPr>
-              <a:t>03   CALIBRATED BY FAULT INJECTION</a:t>
-            </a:r>
-          </a:p>
-        </p:txBody>
-      </p:sp>
-      <p:sp>
-        <p:nvSpPr>
-          <p:cNvPr id="21" name="TextBox 20"/>
-          <p:cNvSpPr txBox="1"/>
-          <p:nvPr/>
-        </p:nvSpPr>
-        <p:spPr>
-          <a:xfrm>
-            <a:off x="5010912" y="7178040"/>
-            <a:ext cx="2048256" cy="868680"/>
-          </a:xfrm>
-          <a:prstGeom prst="rect">
-            <a:avLst/>
-          </a:prstGeom>
-          <a:noFill/>
-        </p:spPr>
-        <p:txBody>
-          <a:bodyPr wrap="square" lIns="0" rIns="0" tIns="0" bIns="0" anchor="t">
-            <a:spAutoFit/>
-          </a:bodyPr>
-          <a:lstStyle/>
-          <a:p>
-            <a:pPr algn="l">
-              <a:lnSpc>
-                <a:spcPct val="114000"/>
-              </a:lnSpc>
-              <a:spcAft>
-                <a:spcPts val="0"/>
-              </a:spcAft>
-            </a:pPr>
-            <a:r>
-              <a:rPr sz="800" b="0" i="0">
-                <a:solidFill>
-                  <a:srgbClr val="57534E"/>
-                </a:solidFill>
-                <a:latin typeface="Segoe UI"/>
-              </a:rPr>
-              <a:t>Inject 1-in-100 packet loss: aborts and missed rows must move, FPS must fall, recovery must return to baseline.</a:t>
-            </a:r>
-          </a:p>
-        </p:txBody>
-      </p:sp>
-      <p:sp>
-        <p:nvSpPr>
-          <p:cNvPr id="22" name="Rectangle 21"/>
+              <a:t>Rendered from the same test frame; two panes, one frame identity.</a:t>
+            </a:r>
+          </a:p>
+        </p:txBody>
+      </p:sp>
+      <p:sp>
+        <p:nvSpPr>
+          <p:cNvPr id="17" name="Rectangle 16"/>
           <p:cNvSpPr/>
           <p:nvPr/>
         </p:nvSpPr>
         <p:spPr>
           <a:xfrm>
-            <a:off x="502920" y="8183879"/>
-            <a:ext cx="6556248" cy="7315"/>
+            <a:off x="0" y="6784848"/>
+            <a:ext cx="7560259" cy="1536192"/>
           </a:xfrm>
           <a:prstGeom prst="rect">
             <a:avLst/>
           </a:prstGeom>
           <a:solidFill>
-            <a:srgbClr val="D8CFC1"/>
+            <a:srgbClr val="F3EBDD"/>
           </a:solidFill>
           <a:ln>
             <a:noFill/>
@@ -3973,14 +3736,14 @@
       </p:sp>
       <p:sp>
         <p:nvSpPr>
-          <p:cNvPr id="23" name="TextBox 22"/>
+          <p:cNvPr id="18" name="TextBox 17"/>
           <p:cNvSpPr txBox="1"/>
           <p:nvPr/>
         </p:nvSpPr>
         <p:spPr>
           <a:xfrm>
-            <a:off x="502920" y="8247888"/>
-            <a:ext cx="5486400" cy="146304"/>
+            <a:off x="475488" y="6912864"/>
+            <a:ext cx="365760" cy="182880"/>
           </a:xfrm>
           <a:prstGeom prst="rect">
             <a:avLst/>
@@ -3997,32 +3760,29 @@
               <a:lnSpc>
                 <a:spcPct val="100000"/>
               </a:lnSpc>
-              <a:spcAft>
-                <a:spcPts val="0"/>
-              </a:spcAft>
             </a:pPr>
             <a:r>
-              <a:rPr sz="720" b="1" i="0">
-                <a:solidFill>
-                  <a:srgbClr val="57534E"/>
-                </a:solidFill>
-                <a:latin typeface="Segoe UI"/>
+              <a:rPr sz="1200" b="1" i="0">
+                <a:solidFill>
+                  <a:srgbClr val="C55221"/>
+                </a:solidFill>
+                <a:latin typeface="Bahnschrift"/>
               </a:rPr>
-              <a:t>THE NUMBERS   ·   ROUTED BUILD</a:t>
-            </a:r>
-          </a:p>
-        </p:txBody>
-      </p:sp>
-      <p:sp>
-        <p:nvSpPr>
-          <p:cNvPr id="24" name="TextBox 23"/>
+              <a:t>01</a:t>
+            </a:r>
+          </a:p>
+        </p:txBody>
+      </p:sp>
+      <p:sp>
+        <p:nvSpPr>
+          <p:cNvPr id="19" name="TextBox 18"/>
           <p:cNvSpPr txBox="1"/>
           <p:nvPr/>
         </p:nvSpPr>
         <p:spPr>
           <a:xfrm>
-            <a:off x="502920" y="8430768"/>
-            <a:ext cx="1572768" cy="384048"/>
+            <a:off x="859536" y="6912864"/>
+            <a:ext cx="1783080" cy="182880"/>
           </a:xfrm>
           <a:prstGeom prst="rect">
             <a:avLst/>
@@ -4030,41 +3790,38 @@
           <a:noFill/>
         </p:spPr>
         <p:txBody>
-          <a:bodyPr wrap="square" lIns="0" rIns="0" tIns="0" bIns="0" anchor="ctr">
+          <a:bodyPr wrap="square" lIns="0" rIns="0" tIns="0" bIns="0" anchor="t">
             <a:spAutoFit/>
           </a:bodyPr>
           <a:lstStyle/>
           <a:p>
-            <a:pPr algn="ctr">
+            <a:pPr algn="l">
               <a:lnSpc>
                 <a:spcPct val="100000"/>
               </a:lnSpc>
-              <a:spcAft>
-                <a:spcPts val="0"/>
-              </a:spcAft>
             </a:pPr>
             <a:r>
-              <a:rPr sz="2000" b="1" i="0">
-                <a:solidFill>
-                  <a:srgbClr val="1C1917"/>
-                </a:solidFill>
-                <a:latin typeface="Georgia"/>
+              <a:rPr sz="1400" b="1" i="0">
+                <a:solidFill>
+                  <a:srgbClr val="111827"/>
+                </a:solidFill>
+                <a:latin typeface="Bahnschrift"/>
               </a:rPr>
-              <a:t>1.341 ns</a:t>
-            </a:r>
-          </a:p>
-        </p:txBody>
-      </p:sp>
-      <p:sp>
-        <p:nvSpPr>
-          <p:cNvPr id="25" name="TextBox 24"/>
+              <a:t>SAME-FRAME A/B</a:t>
+            </a:r>
+          </a:p>
+        </p:txBody>
+      </p:sp>
+      <p:sp>
+        <p:nvSpPr>
+          <p:cNvPr id="20" name="TextBox 19"/>
           <p:cNvSpPr txBox="1"/>
           <p:nvPr/>
         </p:nvSpPr>
         <p:spPr>
           <a:xfrm>
-            <a:off x="502920" y="8851392"/>
-            <a:ext cx="1572768" cy="274320"/>
+            <a:off x="475488" y="7205472"/>
+            <a:ext cx="1993392" cy="777240"/>
           </a:xfrm>
           <a:prstGeom prst="rect">
             <a:avLst/>
@@ -4072,41 +3829,38 @@
           <a:noFill/>
         </p:spPr>
         <p:txBody>
-          <a:bodyPr wrap="square" lIns="0" rIns="0" tIns="0" bIns="0" anchor="ctr">
+          <a:bodyPr wrap="square" lIns="0" rIns="0" tIns="0" bIns="0" anchor="t">
             <a:spAutoFit/>
           </a:bodyPr>
           <a:lstStyle/>
           <a:p>
-            <a:pPr algn="ctr">
+            <a:pPr algn="l">
               <a:lnSpc>
-                <a:spcPct val="105000"/>
+                <a:spcPct val="110000"/>
               </a:lnSpc>
-              <a:spcAft>
-                <a:spcPts val="0"/>
-              </a:spcAft>
             </a:pPr>
             <a:r>
-              <a:rPr sz="680" b="0" i="0">
-                <a:solidFill>
-                  <a:srgbClr val="57534E"/>
-                </a:solidFill>
-                <a:latin typeface="Segoe UI"/>
+              <a:rPr sz="1200" b="0" i="0">
+                <a:solidFill>
+                  <a:srgbClr val="4B5563"/>
+                </a:solidFill>
+                <a:latin typeface="Bahnschrift"/>
               </a:rPr>
-              <a:t>setup WNS · 0 failing endpoints</a:t>
-            </a:r>
-          </a:p>
-        </p:txBody>
-      </p:sp>
-      <p:sp>
-        <p:nvSpPr>
-          <p:cNvPr id="26" name="TextBox 25"/>
+              <a:t>Fixed 15-cycle chain; the seam is a pixel decision.</a:t>
+            </a:r>
+          </a:p>
+        </p:txBody>
+      </p:sp>
+      <p:sp>
+        <p:nvSpPr>
+          <p:cNvPr id="21" name="TextBox 20"/>
           <p:cNvSpPr txBox="1"/>
           <p:nvPr/>
         </p:nvSpPr>
         <p:spPr>
           <a:xfrm>
-            <a:off x="2139696" y="8430768"/>
-            <a:ext cx="1572768" cy="384048"/>
+            <a:off x="2706624" y="6912864"/>
+            <a:ext cx="365760" cy="182880"/>
           </a:xfrm>
           <a:prstGeom prst="rect">
             <a:avLst/>
@@ -4114,41 +3868,38 @@
           <a:noFill/>
         </p:spPr>
         <p:txBody>
-          <a:bodyPr wrap="square" lIns="0" rIns="0" tIns="0" bIns="0" anchor="ctr">
+          <a:bodyPr wrap="square" lIns="0" rIns="0" tIns="0" bIns="0" anchor="t">
             <a:spAutoFit/>
           </a:bodyPr>
           <a:lstStyle/>
           <a:p>
-            <a:pPr algn="ctr">
+            <a:pPr algn="l">
               <a:lnSpc>
                 <a:spcPct val="100000"/>
               </a:lnSpc>
-              <a:spcAft>
-                <a:spcPts val="0"/>
-              </a:spcAft>
             </a:pPr>
             <a:r>
-              <a:rPr sz="2000" b="1" i="0">
-                <a:solidFill>
-                  <a:srgbClr val="3F6212"/>
-                </a:solidFill>
-                <a:latin typeface="Georgia"/>
+              <a:rPr sz="1200" b="1" i="0">
+                <a:solidFill>
+                  <a:srgbClr val="C55221"/>
+                </a:solidFill>
+                <a:latin typeface="Bahnschrift"/>
               </a:rPr>
-              <a:t>0.025 ns</a:t>
-            </a:r>
-          </a:p>
-        </p:txBody>
-      </p:sp>
-      <p:sp>
-        <p:nvSpPr>
-          <p:cNvPr id="27" name="TextBox 26"/>
+              <a:t>02</a:t>
+            </a:r>
+          </a:p>
+        </p:txBody>
+      </p:sp>
+      <p:sp>
+        <p:nvSpPr>
+          <p:cNvPr id="22" name="TextBox 21"/>
           <p:cNvSpPr txBox="1"/>
           <p:nvPr/>
         </p:nvSpPr>
         <p:spPr>
           <a:xfrm>
-            <a:off x="2139696" y="8851392"/>
-            <a:ext cx="1572768" cy="274320"/>
+            <a:off x="3090672" y="6912864"/>
+            <a:ext cx="1783080" cy="182880"/>
           </a:xfrm>
           <a:prstGeom prst="rect">
             <a:avLst/>
@@ -4156,41 +3907,38 @@
           <a:noFill/>
         </p:spPr>
         <p:txBody>
-          <a:bodyPr wrap="square" lIns="0" rIns="0" tIns="0" bIns="0" anchor="ctr">
+          <a:bodyPr wrap="square" lIns="0" rIns="0" tIns="0" bIns="0" anchor="t">
             <a:spAutoFit/>
           </a:bodyPr>
           <a:lstStyle/>
           <a:p>
-            <a:pPr algn="ctr">
+            <a:pPr algn="l">
               <a:lnSpc>
-                <a:spcPct val="105000"/>
+                <a:spcPct val="100000"/>
               </a:lnSpc>
-              <a:spcAft>
-                <a:spcPts val="0"/>
-              </a:spcAft>
             </a:pPr>
             <a:r>
-              <a:rPr sz="680" b="0" i="0">
-                <a:solidFill>
-                  <a:srgbClr val="57534E"/>
-                </a:solidFill>
-                <a:latin typeface="Segoe UI"/>
+              <a:rPr sz="1400" b="1" i="0">
+                <a:solidFill>
+                  <a:srgbClr val="111827"/>
+                </a:solidFill>
+                <a:latin typeface="Bahnschrift"/>
               </a:rPr>
-              <a:t>hold WHS · tightest path</a:t>
-            </a:r>
-          </a:p>
-        </p:txBody>
-      </p:sp>
-      <p:sp>
-        <p:nvSpPr>
-          <p:cNvPr id="28" name="TextBox 27"/>
+              <a:t>TELEMETRY</a:t>
+            </a:r>
+          </a:p>
+        </p:txBody>
+      </p:sp>
+      <p:sp>
+        <p:nvSpPr>
+          <p:cNvPr id="23" name="TextBox 22"/>
           <p:cNvSpPr txBox="1"/>
           <p:nvPr/>
         </p:nvSpPr>
         <p:spPr>
           <a:xfrm>
-            <a:off x="3776472" y="8430768"/>
-            <a:ext cx="1572768" cy="384048"/>
+            <a:off x="2706624" y="7205472"/>
+            <a:ext cx="1993392" cy="777240"/>
           </a:xfrm>
           <a:prstGeom prst="rect">
             <a:avLst/>
@@ -4198,41 +3946,38 @@
           <a:noFill/>
         </p:spPr>
         <p:txBody>
-          <a:bodyPr wrap="square" lIns="0" rIns="0" tIns="0" bIns="0" anchor="ctr">
+          <a:bodyPr wrap="square" lIns="0" rIns="0" tIns="0" bIns="0" anchor="t">
             <a:spAutoFit/>
           </a:bodyPr>
           <a:lstStyle/>
           <a:p>
-            <a:pPr algn="ctr">
+            <a:pPr algn="l">
               <a:lnSpc>
-                <a:spcPct val="100000"/>
+                <a:spcPct val="110000"/>
               </a:lnSpc>
-              <a:spcAft>
-                <a:spcPts val="0"/>
-              </a:spcAft>
             </a:pPr>
             <a:r>
-              <a:rPr sz="2000" b="1" i="0">
-                <a:solidFill>
-                  <a:srgbClr val="1C1917"/>
-                </a:solidFill>
-                <a:latin typeface="Georgia"/>
+              <a:rPr sz="1200" b="0" i="0">
+                <a:solidFill>
+                  <a:srgbClr val="4B5563"/>
+                </a:solidFill>
+                <a:latin typeface="Bahnschrift"/>
               </a:rPr>
-              <a:t>70.00%</a:t>
-            </a:r>
-          </a:p>
-        </p:txBody>
-      </p:sp>
-      <p:sp>
-        <p:nvSpPr>
-          <p:cNvPr id="29" name="TextBox 28"/>
+              <a:t>Frames, aborts, rows, latency, pane and gaps at 1 Hz.</a:t>
+            </a:r>
+          </a:p>
+        </p:txBody>
+      </p:sp>
+      <p:sp>
+        <p:nvSpPr>
+          <p:cNvPr id="24" name="TextBox 23"/>
           <p:cNvSpPr txBox="1"/>
           <p:nvPr/>
         </p:nvSpPr>
         <p:spPr>
           <a:xfrm>
-            <a:off x="3776472" y="8851392"/>
-            <a:ext cx="1572768" cy="274320"/>
+            <a:off x="4937760" y="6912864"/>
+            <a:ext cx="365760" cy="182880"/>
           </a:xfrm>
           <a:prstGeom prst="rect">
             <a:avLst/>
@@ -4240,41 +3985,38 @@
           <a:noFill/>
         </p:spPr>
         <p:txBody>
-          <a:bodyPr wrap="square" lIns="0" rIns="0" tIns="0" bIns="0" anchor="ctr">
+          <a:bodyPr wrap="square" lIns="0" rIns="0" tIns="0" bIns="0" anchor="t">
             <a:spAutoFit/>
           </a:bodyPr>
           <a:lstStyle/>
           <a:p>
-            <a:pPr algn="ctr">
+            <a:pPr algn="l">
               <a:lnSpc>
-                <a:spcPct val="105000"/>
+                <a:spcPct val="100000"/>
               </a:lnSpc>
-              <a:spcAft>
-                <a:spcPts val="0"/>
-              </a:spcAft>
             </a:pPr>
             <a:r>
-              <a:rPr sz="680" b="0" i="0">
-                <a:solidFill>
-                  <a:srgbClr val="57534E"/>
-                </a:solidFill>
-                <a:latin typeface="Segoe UI"/>
+              <a:rPr sz="1200" b="1" i="0">
+                <a:solidFill>
+                  <a:srgbClr val="C55221"/>
+                </a:solidFill>
+                <a:latin typeface="Bahnschrift"/>
               </a:rPr>
-              <a:t>BRAM · 98 of 140 tiles</a:t>
-            </a:r>
-          </a:p>
-        </p:txBody>
-      </p:sp>
-      <p:sp>
-        <p:nvSpPr>
-          <p:cNvPr id="30" name="TextBox 29"/>
+              <a:t>03</a:t>
+            </a:r>
+          </a:p>
+        </p:txBody>
+      </p:sp>
+      <p:sp>
+        <p:nvSpPr>
+          <p:cNvPr id="25" name="TextBox 24"/>
           <p:cNvSpPr txBox="1"/>
           <p:nvPr/>
         </p:nvSpPr>
         <p:spPr>
           <a:xfrm>
-            <a:off x="5413248" y="8430768"/>
-            <a:ext cx="1572768" cy="384048"/>
+            <a:off x="5321808" y="6912864"/>
+            <a:ext cx="1783080" cy="182880"/>
           </a:xfrm>
           <a:prstGeom prst="rect">
             <a:avLst/>
@@ -4282,41 +4024,38 @@
           <a:noFill/>
         </p:spPr>
         <p:txBody>
-          <a:bodyPr wrap="square" lIns="0" rIns="0" tIns="0" bIns="0" anchor="ctr">
+          <a:bodyPr wrap="square" lIns="0" rIns="0" tIns="0" bIns="0" anchor="t">
             <a:spAutoFit/>
           </a:bodyPr>
           <a:lstStyle/>
           <a:p>
-            <a:pPr algn="ctr">
+            <a:pPr algn="l">
               <a:lnSpc>
                 <a:spcPct val="100000"/>
               </a:lnSpc>
-              <a:spcAft>
-                <a:spcPts val="0"/>
-              </a:spcAft>
             </a:pPr>
             <a:r>
-              <a:rPr sz="2000" b="1" i="0">
-                <a:solidFill>
-                  <a:srgbClr val="1C1917"/>
-                </a:solidFill>
-                <a:latin typeface="Georgia"/>
+              <a:rPr sz="1400" b="1" i="0">
+                <a:solidFill>
+                  <a:srgbClr val="111827"/>
+                </a:solidFill>
+                <a:latin typeface="Bahnschrift"/>
               </a:rPr>
-              <a:t>15 cycles</a:t>
-            </a:r>
-          </a:p>
-        </p:txBody>
-      </p:sp>
-      <p:sp>
-        <p:nvSpPr>
-          <p:cNvPr id="31" name="TextBox 30"/>
+              <a:t>FAULT INJECTION</a:t>
+            </a:r>
+          </a:p>
+        </p:txBody>
+      </p:sp>
+      <p:sp>
+        <p:nvSpPr>
+          <p:cNvPr id="26" name="TextBox 25"/>
           <p:cNvSpPr txBox="1"/>
           <p:nvPr/>
         </p:nvSpPr>
         <p:spPr>
           <a:xfrm>
-            <a:off x="5413248" y="8851392"/>
-            <a:ext cx="1572768" cy="274320"/>
+            <a:off x="4937760" y="7205472"/>
+            <a:ext cx="1993392" cy="777240"/>
           </a:xfrm>
           <a:prstGeom prst="rect">
             <a:avLst/>
@@ -4324,48 +4063,6 @@
           <a:noFill/>
         </p:spPr>
         <p:txBody>
-          <a:bodyPr wrap="square" lIns="0" rIns="0" tIns="0" bIns="0" anchor="ctr">
-            <a:spAutoFit/>
-          </a:bodyPr>
-          <a:lstStyle/>
-          <a:p>
-            <a:pPr algn="ctr">
-              <a:lnSpc>
-                <a:spcPct val="105000"/>
-              </a:lnSpc>
-              <a:spcAft>
-                <a:spcPts val="0"/>
-              </a:spcAft>
-            </a:pPr>
-            <a:r>
-              <a:rPr sz="680" b="0" i="0">
-                <a:solidFill>
-                  <a:srgbClr val="57534E"/>
-                </a:solidFill>
-                <a:latin typeface="Segoe UI"/>
-              </a:rPr>
-              <a:t>fixed effect latency</a:t>
-            </a:r>
-          </a:p>
-        </p:txBody>
-      </p:sp>
-      <p:sp>
-        <p:nvSpPr>
-          <p:cNvPr id="32" name="TextBox 31"/>
-          <p:cNvSpPr txBox="1"/>
-          <p:nvPr/>
-        </p:nvSpPr>
-        <p:spPr>
-          <a:xfrm>
-            <a:off x="502920" y="9235440"/>
-            <a:ext cx="6556248" cy="182880"/>
-          </a:xfrm>
-          <a:prstGeom prst="rect">
-            <a:avLst/>
-          </a:prstGeom>
-          <a:noFill/>
-        </p:spPr>
-        <p:txBody>
           <a:bodyPr wrap="square" lIns="0" rIns="0" tIns="0" bIns="0" anchor="t">
             <a:spAutoFit/>
           </a:bodyPr>
@@ -4373,82 +4070,37 @@
           <a:p>
             <a:pPr algn="l">
               <a:lnSpc>
-                <a:spcPct val="100000"/>
+                <a:spcPct val="110000"/>
               </a:lnSpc>
-              <a:spcAft>
-                <a:spcPts val="0"/>
-              </a:spcAft>
             </a:pPr>
             <a:r>
-              <a:rPr sz="720" b="1" i="0">
-                <a:solidFill>
-                  <a:srgbClr val="B45309"/>
-                </a:solidFill>
-                <a:latin typeface="Segoe UI"/>
+              <a:rPr sz="1200" b="0" i="0">
+                <a:solidFill>
+                  <a:srgbClr val="4B5563"/>
+                </a:solidFill>
+                <a:latin typeface="Bahnschrift"/>
               </a:rPr>
-              <a:t>RGMII  →  MAC  →  UDP  →  DDR  →  GEOMETRY  →  6-STAGE EFFECTS  →  A/B SEAM  →  HDMI</a:t>
-            </a:r>
-          </a:p>
-        </p:txBody>
-      </p:sp>
-      <p:sp>
-        <p:nvSpPr>
-          <p:cNvPr id="33" name="TextBox 32"/>
-          <p:cNvSpPr txBox="1"/>
-          <p:nvPr/>
-        </p:nvSpPr>
-        <p:spPr>
-          <a:xfrm>
-            <a:off x="502920" y="9418320"/>
-            <a:ext cx="6556248" cy="182880"/>
-          </a:xfrm>
-          <a:prstGeom prst="rect">
-            <a:avLst/>
-          </a:prstGeom>
-          <a:noFill/>
-        </p:spPr>
-        <p:txBody>
-          <a:bodyPr wrap="square" lIns="0" rIns="0" tIns="0" bIns="0" anchor="t">
-            <a:spAutoFit/>
-          </a:bodyPr>
-          <a:lstStyle/>
-          <a:p>
-            <a:pPr algn="l">
-              <a:lnSpc>
-                <a:spcPct val="100000"/>
-              </a:lnSpc>
-              <a:spcAft>
-                <a:spcPts val="0"/>
-              </a:spcAft>
-            </a:pPr>
-            <a:r>
-              <a:rPr sz="680" b="0" i="0">
-                <a:solidFill>
-                  <a:srgbClr val="57534E"/>
-                </a:solidFill>
-                <a:latin typeface="Segoe UI"/>
-              </a:rPr>
-              <a:t>512×300 RGB565 at 30 fps  →  1024×600 at 59.5 Hz   ·   xc7z020clg484-2   ·   1 GbE UDP ingest   ·   SD and test-pattern fallback</a:t>
-            </a:r>
-          </a:p>
-        </p:txBody>
-      </p:sp>
-      <p:sp>
-        <p:nvSpPr>
-          <p:cNvPr id="34" name="Rectangle 33"/>
+              <a:t>Drop 1 in 100; aborts move; recovery returns.</a:t>
+            </a:r>
+          </a:p>
+        </p:txBody>
+      </p:sp>
+      <p:sp>
+        <p:nvSpPr>
+          <p:cNvPr id="27" name="Rectangle 26"/>
           <p:cNvSpPr/>
           <p:nvPr/>
         </p:nvSpPr>
         <p:spPr>
           <a:xfrm>
-            <a:off x="502920" y="10332720"/>
-            <a:ext cx="6556248" cy="7315"/>
+            <a:off x="0" y="8321040"/>
+            <a:ext cx="7560259" cy="987552"/>
           </a:xfrm>
           <a:prstGeom prst="rect">
             <a:avLst/>
           </a:prstGeom>
           <a:solidFill>
-            <a:srgbClr val="D8CFC1"/>
+            <a:srgbClr val="C55221"/>
           </a:solidFill>
           <a:ln>
             <a:noFill/>
@@ -4479,14 +4131,14 @@
       </p:sp>
       <p:sp>
         <p:nvSpPr>
-          <p:cNvPr id="35" name="TextBox 34"/>
+          <p:cNvPr id="28" name="TextBox 27"/>
           <p:cNvSpPr txBox="1"/>
           <p:nvPr/>
         </p:nvSpPr>
         <p:spPr>
           <a:xfrm>
-            <a:off x="502920" y="10387584"/>
-            <a:ext cx="5394960" cy="274320"/>
+            <a:off x="475488" y="8439912"/>
+            <a:ext cx="1481328" cy="365760"/>
           </a:xfrm>
           <a:prstGeom prst="rect">
             <a:avLst/>
@@ -4501,34 +4153,31 @@
           <a:p>
             <a:pPr algn="l">
               <a:lnSpc>
-                <a:spcPct val="105000"/>
+                <a:spcPct val="100000"/>
               </a:lnSpc>
-              <a:spcAft>
-                <a:spcPts val="0"/>
-              </a:spcAft>
             </a:pPr>
             <a:r>
-              <a:rPr sz="560" b="0" i="0">
-                <a:solidFill>
-                  <a:srgbClr val="57534E"/>
-                </a:solidFill>
-                <a:latin typeface="Segoe UI"/>
+              <a:rPr sz="2400" b="0" i="0">
+                <a:solidFill>
+                  <a:srgbClr val="FFFFFF"/>
+                </a:solidFill>
+                <a:latin typeface="Bahnschrift Light"/>
               </a:rPr>
-              <a:t>AMD, the AMD Arrow logo and combinations thereof are trademarks of Advanced Micro Devices, Inc. Zynq is a trademark of AMD. All other trademarks are the property of their respective owners.</a:t>
-            </a:r>
-          </a:p>
-        </p:txBody>
-      </p:sp>
-      <p:sp>
-        <p:nvSpPr>
-          <p:cNvPr id="36" name="TextBox 35"/>
+              <a:t>1.341 ns</a:t>
+            </a:r>
+          </a:p>
+        </p:txBody>
+      </p:sp>
+      <p:sp>
+        <p:nvSpPr>
+          <p:cNvPr id="29" name="TextBox 28"/>
           <p:cNvSpPr txBox="1"/>
           <p:nvPr/>
         </p:nvSpPr>
         <p:spPr>
           <a:xfrm>
-            <a:off x="5394960" y="10387584"/>
-            <a:ext cx="1645920" cy="182880"/>
+            <a:off x="475488" y="8860536"/>
+            <a:ext cx="1463040" cy="228600"/>
           </a:xfrm>
           <a:prstGeom prst="rect">
             <a:avLst/>
@@ -4541,20 +4190,490 @@
           </a:bodyPr>
           <a:lstStyle/>
           <a:p>
+            <a:pPr algn="l">
+              <a:lnSpc>
+                <a:spcPct val="100000"/>
+              </a:lnSpc>
+            </a:pPr>
+            <a:r>
+              <a:rPr sz="1200" b="0" i="0">
+                <a:solidFill>
+                  <a:srgbClr val="FFF7ED"/>
+                </a:solidFill>
+                <a:latin typeface="Bahnschrift"/>
+              </a:rPr>
+              <a:t>setup WNS · 0 failing endpoints</a:t>
+            </a:r>
+          </a:p>
+        </p:txBody>
+      </p:sp>
+      <p:sp>
+        <p:nvSpPr>
+          <p:cNvPr id="30" name="TextBox 29"/>
+          <p:cNvSpPr txBox="1"/>
+          <p:nvPr/>
+        </p:nvSpPr>
+        <p:spPr>
+          <a:xfrm>
+            <a:off x="2103120" y="8439912"/>
+            <a:ext cx="1481328" cy="365760"/>
+          </a:xfrm>
+          <a:prstGeom prst="rect">
+            <a:avLst/>
+          </a:prstGeom>
+          <a:noFill/>
+        </p:spPr>
+        <p:txBody>
+          <a:bodyPr wrap="square" lIns="0" rIns="0" tIns="0" bIns="0" anchor="t">
+            <a:spAutoFit/>
+          </a:bodyPr>
+          <a:lstStyle/>
+          <a:p>
+            <a:pPr algn="l">
+              <a:lnSpc>
+                <a:spcPct val="100000"/>
+              </a:lnSpc>
+            </a:pPr>
+            <a:r>
+              <a:rPr sz="2400" b="0" i="0">
+                <a:solidFill>
+                  <a:srgbClr val="FFFFFF"/>
+                </a:solidFill>
+                <a:latin typeface="Bahnschrift Light"/>
+              </a:rPr>
+              <a:t>0.025 ns</a:t>
+            </a:r>
+          </a:p>
+        </p:txBody>
+      </p:sp>
+      <p:sp>
+        <p:nvSpPr>
+          <p:cNvPr id="31" name="TextBox 30"/>
+          <p:cNvSpPr txBox="1"/>
+          <p:nvPr/>
+        </p:nvSpPr>
+        <p:spPr>
+          <a:xfrm>
+            <a:off x="2103120" y="8860536"/>
+            <a:ext cx="1463040" cy="228600"/>
+          </a:xfrm>
+          <a:prstGeom prst="rect">
+            <a:avLst/>
+          </a:prstGeom>
+          <a:noFill/>
+        </p:spPr>
+        <p:txBody>
+          <a:bodyPr wrap="square" lIns="0" rIns="0" tIns="0" bIns="0" anchor="t">
+            <a:spAutoFit/>
+          </a:bodyPr>
+          <a:lstStyle/>
+          <a:p>
+            <a:pPr algn="l">
+              <a:lnSpc>
+                <a:spcPct val="100000"/>
+              </a:lnSpc>
+            </a:pPr>
+            <a:r>
+              <a:rPr sz="1200" b="0" i="0">
+                <a:solidFill>
+                  <a:srgbClr val="FFF7ED"/>
+                </a:solidFill>
+                <a:latin typeface="Bahnschrift"/>
+              </a:rPr>
+              <a:t>hold WHS · tightest path</a:t>
+            </a:r>
+          </a:p>
+        </p:txBody>
+      </p:sp>
+      <p:sp>
+        <p:nvSpPr>
+          <p:cNvPr id="32" name="TextBox 31"/>
+          <p:cNvSpPr txBox="1"/>
+          <p:nvPr/>
+        </p:nvSpPr>
+        <p:spPr>
+          <a:xfrm>
+            <a:off x="3730752" y="8439912"/>
+            <a:ext cx="1481328" cy="365760"/>
+          </a:xfrm>
+          <a:prstGeom prst="rect">
+            <a:avLst/>
+          </a:prstGeom>
+          <a:noFill/>
+        </p:spPr>
+        <p:txBody>
+          <a:bodyPr wrap="square" lIns="0" rIns="0" tIns="0" bIns="0" anchor="t">
+            <a:spAutoFit/>
+          </a:bodyPr>
+          <a:lstStyle/>
+          <a:p>
+            <a:pPr algn="l">
+              <a:lnSpc>
+                <a:spcPct val="100000"/>
+              </a:lnSpc>
+            </a:pPr>
+            <a:r>
+              <a:rPr sz="2400" b="0" i="0">
+                <a:solidFill>
+                  <a:srgbClr val="FFFFFF"/>
+                </a:solidFill>
+                <a:latin typeface="Bahnschrift Light"/>
+              </a:rPr>
+              <a:t>70.00%</a:t>
+            </a:r>
+          </a:p>
+        </p:txBody>
+      </p:sp>
+      <p:sp>
+        <p:nvSpPr>
+          <p:cNvPr id="33" name="TextBox 32"/>
+          <p:cNvSpPr txBox="1"/>
+          <p:nvPr/>
+        </p:nvSpPr>
+        <p:spPr>
+          <a:xfrm>
+            <a:off x="3730752" y="8860536"/>
+            <a:ext cx="1463040" cy="228600"/>
+          </a:xfrm>
+          <a:prstGeom prst="rect">
+            <a:avLst/>
+          </a:prstGeom>
+          <a:noFill/>
+        </p:spPr>
+        <p:txBody>
+          <a:bodyPr wrap="square" lIns="0" rIns="0" tIns="0" bIns="0" anchor="t">
+            <a:spAutoFit/>
+          </a:bodyPr>
+          <a:lstStyle/>
+          <a:p>
+            <a:pPr algn="l">
+              <a:lnSpc>
+                <a:spcPct val="100000"/>
+              </a:lnSpc>
+            </a:pPr>
+            <a:r>
+              <a:rPr sz="1200" b="0" i="0">
+                <a:solidFill>
+                  <a:srgbClr val="FFF7ED"/>
+                </a:solidFill>
+                <a:latin typeface="Bahnschrift"/>
+              </a:rPr>
+              <a:t>BRAM · 98 of 140 tiles</a:t>
+            </a:r>
+          </a:p>
+        </p:txBody>
+      </p:sp>
+      <p:sp>
+        <p:nvSpPr>
+          <p:cNvPr id="34" name="TextBox 33"/>
+          <p:cNvSpPr txBox="1"/>
+          <p:nvPr/>
+        </p:nvSpPr>
+        <p:spPr>
+          <a:xfrm>
+            <a:off x="5358383" y="8439912"/>
+            <a:ext cx="1481328" cy="365760"/>
+          </a:xfrm>
+          <a:prstGeom prst="rect">
+            <a:avLst/>
+          </a:prstGeom>
+          <a:noFill/>
+        </p:spPr>
+        <p:txBody>
+          <a:bodyPr wrap="square" lIns="0" rIns="0" tIns="0" bIns="0" anchor="t">
+            <a:spAutoFit/>
+          </a:bodyPr>
+          <a:lstStyle/>
+          <a:p>
+            <a:pPr algn="l">
+              <a:lnSpc>
+                <a:spcPct val="100000"/>
+              </a:lnSpc>
+            </a:pPr>
+            <a:r>
+              <a:rPr sz="2200" b="0" i="0">
+                <a:solidFill>
+                  <a:srgbClr val="FFFFFF"/>
+                </a:solidFill>
+                <a:latin typeface="Bahnschrift Light"/>
+              </a:rPr>
+              <a:t>15 cycles</a:t>
+            </a:r>
+          </a:p>
+        </p:txBody>
+      </p:sp>
+      <p:sp>
+        <p:nvSpPr>
+          <p:cNvPr id="35" name="TextBox 34"/>
+          <p:cNvSpPr txBox="1"/>
+          <p:nvPr/>
+        </p:nvSpPr>
+        <p:spPr>
+          <a:xfrm>
+            <a:off x="5358383" y="8860536"/>
+            <a:ext cx="1463040" cy="228600"/>
+          </a:xfrm>
+          <a:prstGeom prst="rect">
+            <a:avLst/>
+          </a:prstGeom>
+          <a:noFill/>
+        </p:spPr>
+        <p:txBody>
+          <a:bodyPr wrap="square" lIns="0" rIns="0" tIns="0" bIns="0" anchor="t">
+            <a:spAutoFit/>
+          </a:bodyPr>
+          <a:lstStyle/>
+          <a:p>
+            <a:pPr algn="l">
+              <a:lnSpc>
+                <a:spcPct val="100000"/>
+              </a:lnSpc>
+            </a:pPr>
+            <a:r>
+              <a:rPr sz="1200" b="0" i="0">
+                <a:solidFill>
+                  <a:srgbClr val="FFF7ED"/>
+                </a:solidFill>
+                <a:latin typeface="Bahnschrift"/>
+              </a:rPr>
+              <a:t>fixed effect latency</a:t>
+            </a:r>
+          </a:p>
+        </p:txBody>
+      </p:sp>
+      <p:sp>
+        <p:nvSpPr>
+          <p:cNvPr id="36" name="TextBox 35"/>
+          <p:cNvSpPr txBox="1"/>
+          <p:nvPr/>
+        </p:nvSpPr>
+        <p:spPr>
+          <a:xfrm>
+            <a:off x="475488" y="9491472"/>
+            <a:ext cx="6601968" cy="182880"/>
+          </a:xfrm>
+          <a:prstGeom prst="rect">
+            <a:avLst/>
+          </a:prstGeom>
+          <a:noFill/>
+        </p:spPr>
+        <p:txBody>
+          <a:bodyPr wrap="square" lIns="0" rIns="0" tIns="0" bIns="0" anchor="t">
+            <a:spAutoFit/>
+          </a:bodyPr>
+          <a:lstStyle/>
+          <a:p>
+            <a:pPr algn="l">
+              <a:lnSpc>
+                <a:spcPct val="100000"/>
+              </a:lnSpc>
+            </a:pPr>
+            <a:r>
+              <a:rPr sz="1000" b="1" i="0">
+                <a:solidFill>
+                  <a:srgbClr val="CC8800"/>
+                </a:solidFill>
+                <a:latin typeface="Consolas"/>
+              </a:rPr>
+              <a:t>RGMII  →  MAC  →  UDP  →  DDR  →  GEOMETRY  →  6-STAGE EFFECTS  →  A/B SEAM  →  HDMI</a:t>
+            </a:r>
+          </a:p>
+        </p:txBody>
+      </p:sp>
+      <p:sp>
+        <p:nvSpPr>
+          <p:cNvPr id="37" name="TextBox 36"/>
+          <p:cNvSpPr txBox="1"/>
+          <p:nvPr/>
+        </p:nvSpPr>
+        <p:spPr>
+          <a:xfrm>
+            <a:off x="475488" y="9692640"/>
+            <a:ext cx="6601968" cy="182880"/>
+          </a:xfrm>
+          <a:prstGeom prst="rect">
+            <a:avLst/>
+          </a:prstGeom>
+          <a:noFill/>
+        </p:spPr>
+        <p:txBody>
+          <a:bodyPr wrap="square" lIns="0" rIns="0" tIns="0" bIns="0" anchor="t">
+            <a:spAutoFit/>
+          </a:bodyPr>
+          <a:lstStyle/>
+          <a:p>
+            <a:pPr algn="l">
+              <a:lnSpc>
+                <a:spcPct val="100000"/>
+              </a:lnSpc>
+            </a:pPr>
+            <a:r>
+              <a:rPr sz="900" b="0" i="0">
+                <a:solidFill>
+                  <a:srgbClr val="4B5563"/>
+                </a:solidFill>
+                <a:latin typeface="Bahnschrift"/>
+              </a:rPr>
+              <a:t>512×300 RGB565 at 30 fps  →  1024×600 at 59.5 Hz   ·   xc7z020clg484-2   ·   1 GbE UDP ingest   ·   SD and test-pattern fallback</a:t>
+            </a:r>
+          </a:p>
+        </p:txBody>
+      </p:sp>
+      <p:sp>
+        <p:nvSpPr>
+          <p:cNvPr id="38" name="TextBox 37"/>
+          <p:cNvSpPr txBox="1"/>
+          <p:nvPr/>
+        </p:nvSpPr>
+        <p:spPr>
+          <a:xfrm>
+            <a:off x="475488" y="9948672"/>
+            <a:ext cx="6601968" cy="164592"/>
+          </a:xfrm>
+          <a:prstGeom prst="rect">
+            <a:avLst/>
+          </a:prstGeom>
+          <a:noFill/>
+        </p:spPr>
+        <p:txBody>
+          <a:bodyPr wrap="square" lIns="0" rIns="0" tIns="0" bIns="0" anchor="t">
+            <a:spAutoFit/>
+          </a:bodyPr>
+          <a:lstStyle/>
+          <a:p>
+            <a:pPr algn="l">
+              <a:lnSpc>
+                <a:spcPct val="100000"/>
+              </a:lnSpc>
+            </a:pPr>
+            <a:r>
+              <a:rPr sz="1000" b="1" i="0">
+                <a:solidFill>
+                  <a:srgbClr val="111827"/>
+                </a:solidFill>
+                <a:latin typeface="Consolas"/>
+              </a:rPr>
+              <a:t>29.95 FPS   ·   PANE_BAD=0   ·   QSPI COLD BOOT</a:t>
+            </a:r>
+          </a:p>
+        </p:txBody>
+      </p:sp>
+      <p:sp>
+        <p:nvSpPr>
+          <p:cNvPr id="39" name="Rectangle 38"/>
+          <p:cNvSpPr/>
+          <p:nvPr/>
+        </p:nvSpPr>
+        <p:spPr>
+          <a:xfrm>
+            <a:off x="475488" y="10323576"/>
+            <a:ext cx="6601968" cy="5486"/>
+          </a:xfrm>
+          <a:prstGeom prst="rect">
+            <a:avLst/>
+          </a:prstGeom>
+          <a:solidFill>
+            <a:srgbClr val="C55221"/>
+          </a:solidFill>
+          <a:ln>
+            <a:noFill/>
+          </a:ln>
+          <a:effectLst/>
+        </p:spPr>
+        <p:style>
+          <a:lnRef idx="1">
+            <a:schemeClr val="accent1"/>
+          </a:lnRef>
+          <a:fillRef idx="3">
+            <a:schemeClr val="accent1"/>
+          </a:fillRef>
+          <a:effectRef idx="2">
+            <a:schemeClr val="accent1"/>
+          </a:effectRef>
+          <a:fontRef idx="minor">
+            <a:schemeClr val="lt1"/>
+          </a:fontRef>
+        </p:style>
+        <p:txBody>
+          <a:bodyPr rtlCol="0" anchor="ctr"/>
+          <a:lstStyle/>
+          <a:p>
+            <a:pPr algn="ctr"/>
+          </a:p>
+        </p:txBody>
+      </p:sp>
+      <p:sp>
+        <p:nvSpPr>
+          <p:cNvPr id="40" name="TextBox 39"/>
+          <p:cNvSpPr txBox="1"/>
+          <p:nvPr/>
+        </p:nvSpPr>
+        <p:spPr>
+          <a:xfrm>
+            <a:off x="475488" y="10387584"/>
+            <a:ext cx="5349240" cy="274320"/>
+          </a:xfrm>
+          <a:prstGeom prst="rect">
+            <a:avLst/>
+          </a:prstGeom>
+          <a:noFill/>
+        </p:spPr>
+        <p:txBody>
+          <a:bodyPr wrap="square" lIns="0" rIns="0" tIns="0" bIns="0" anchor="t">
+            <a:spAutoFit/>
+          </a:bodyPr>
+          <a:lstStyle/>
+          <a:p>
+            <a:pPr algn="l">
+              <a:lnSpc>
+                <a:spcPct val="103000"/>
+              </a:lnSpc>
+            </a:pPr>
+            <a:r>
+              <a:rPr sz="550" b="0" i="0">
+                <a:solidFill>
+                  <a:srgbClr val="4B5563"/>
+                </a:solidFill>
+                <a:latin typeface="Bahnschrift"/>
+              </a:rPr>
+              <a:t>AMD, the AMD Arrow logo and combinations thereof are trademarks of Advanced Micro Devices, Inc. Zynq is a trademark of AMD. All other trademarks are the property of their respective owners.</a:t>
+            </a:r>
+          </a:p>
+        </p:txBody>
+      </p:sp>
+      <p:sp>
+        <p:nvSpPr>
+          <p:cNvPr id="41" name="TextBox 40"/>
+          <p:cNvSpPr txBox="1"/>
+          <p:nvPr/>
+        </p:nvSpPr>
+        <p:spPr>
+          <a:xfrm>
+            <a:off x="5349240" y="10387584"/>
+            <a:ext cx="1737360" cy="182880"/>
+          </a:xfrm>
+          <a:prstGeom prst="rect">
+            <a:avLst/>
+          </a:prstGeom>
+          <a:noFill/>
+        </p:spPr>
+        <p:txBody>
+          <a:bodyPr wrap="square" lIns="0" rIns="0" tIns="0" bIns="0" anchor="t">
+            <a:spAutoFit/>
+          </a:bodyPr>
+          <a:lstStyle/>
+          <a:p>
             <a:pPr algn="r">
               <a:lnSpc>
                 <a:spcPct val="100000"/>
               </a:lnSpc>
-              <a:spcAft>
-                <a:spcPts val="0"/>
-              </a:spcAft>
             </a:pPr>
             <a:r>
-              <a:rPr sz="580" b="0" i="0">
-                <a:solidFill>
-                  <a:srgbClr val="57534E"/>
-                </a:solidFill>
-                <a:latin typeface="Segoe UI"/>
+              <a:rPr sz="560" b="0" i="0">
+                <a:solidFill>
+                  <a:srgbClr val="4B5563"/>
+                </a:solidFill>
+                <a:latin typeface="Bahnschrift"/>
               </a:rPr>
               <a:t>Zynq-7020  ·  1024×600 HDMI</a:t>
             </a:r>

</xml_diff>

<commit_message>
publish complete documentation snapshot with learning archive
</commit_message>
<xml_diff>
--- a/prj_fin/deliverables/poster.pptx
+++ b/prj_fin/deliverables/poster.pptx
@@ -3840,7 +3840,7 @@
               </a:lnSpc>
             </a:pPr>
             <a:r>
-              <a:rPr sz="1200" b="0" i="0">
+              <a:rPr sz="1100" b="0" i="0">
                 <a:solidFill>
                   <a:srgbClr val="4B5563"/>
                 </a:solidFill>
@@ -3957,13 +3957,13 @@
               </a:lnSpc>
             </a:pPr>
             <a:r>
-              <a:rPr sz="1200" b="0" i="0">
+              <a:rPr sz="1100" b="0" i="0">
                 <a:solidFill>
                   <a:srgbClr val="4B5563"/>
                 </a:solidFill>
                 <a:latin typeface="Bahnschrift"/>
               </a:rPr>
-              <a:t>Frames, aborts, rows, latency, pane and gaps at 1 Hz.</a:t>
+              <a:t>Frame-commit gates (bytes/rows/bad), aborts, latency, pane, gaps at 1 Hz.</a:t>
             </a:r>
           </a:p>
         </p:txBody>
@@ -4074,7 +4074,7 @@
               </a:lnSpc>
             </a:pPr>
             <a:r>
-              <a:rPr sz="1200" b="0" i="0">
+              <a:rPr sz="1100" b="0" i="0">
                 <a:solidFill>
                   <a:srgbClr val="4B5563"/>
                 </a:solidFill>

</xml_diff>

<commit_message>
poster: rebuild on AMD template for Hunan University of Technology
</commit_message>
<xml_diff>
--- a/prj_fin/deliverables/poster.pptx
+++ b/prj_fin/deliverables/poster.pptx
@@ -7,7 +7,7 @@
   <p:sldIdLst>
     <p:sldId id="256" r:id="rId7"/>
   </p:sldIdLst>
-  <p:sldSz cx="7560259" cy="10692079" type="screen4x3"/>
+  <p:sldSz cx="12191695" cy="6858000" type="screen4x3"/>
   <p:notesSz cx="6858000" cy="9144000"/>
   <p:defaultTextStyle>
     <a:defPPr>
@@ -3081,14 +3081,6 @@
 <file path=ppt/slides/slide1.xml><?xml version="1.0" encoding="utf-8"?>
 <p:sld xmlns:a="http://schemas.openxmlformats.org/drawingml/2006/main" xmlns:p="http://schemas.openxmlformats.org/presentationml/2006/main" xmlns:r="http://schemas.openxmlformats.org/officeDocument/2006/relationships">
   <p:cSld>
-    <p:bg>
-      <p:bgPr>
-        <a:solidFill>
-          <a:srgbClr val="FFFFFF"/>
-        </a:solidFill>
-        <a:effectLst/>
-      </p:bgPr>
-    </p:bg>
     <p:spTree>
       <p:nvGrpSpPr>
         <p:cNvPr id="1" name=""/>
@@ -3098,25 +3090,493 @@
       <p:grpSpPr/>
       <p:sp>
         <p:nvSpPr>
-          <p:cNvPr id="2" name="Rectangle 1"/>
+          <p:cNvPr id="2" name="TextBox 1"/>
+          <p:cNvSpPr txBox="1"/>
+          <p:nvPr/>
+        </p:nvSpPr>
+        <p:spPr>
+          <a:xfrm>
+            <a:off x="256032" y="73152"/>
+            <a:ext cx="2926080" cy="164592"/>
+          </a:xfrm>
+          <a:prstGeom prst="rect">
+            <a:avLst/>
+          </a:prstGeom>
+          <a:noFill/>
+        </p:spPr>
+        <p:txBody>
+          <a:bodyPr wrap="square" lIns="0" rIns="0" tIns="0" bIns="0" anchor="t">
+            <a:spAutoFit/>
+          </a:bodyPr>
+          <a:lstStyle/>
+          <a:p>
+            <a:pPr algn="l">
+              <a:lnSpc>
+                <a:spcPct val="100000"/>
+              </a:lnSpc>
+            </a:pPr>
+            <a:r>
+              <a:rPr sz="750" b="0">
+                <a:solidFill>
+                  <a:srgbClr val="5C5C5C"/>
+                </a:solidFill>
+                <a:latin typeface="Arial"/>
+              </a:rPr>
+              <a:t>(c) 2026 Uie  |  AMD FPGA Innovation Design Competition</a:t>
+            </a:r>
+          </a:p>
+        </p:txBody>
+      </p:sp>
+      <p:sp>
+        <p:nvSpPr>
+          <p:cNvPr id="3" name="TextBox 2"/>
+          <p:cNvSpPr txBox="1"/>
+          <p:nvPr/>
+        </p:nvSpPr>
+        <p:spPr>
+          <a:xfrm>
+            <a:off x="384048" y="301752"/>
+            <a:ext cx="7863840" cy="502920"/>
+          </a:xfrm>
+          <a:prstGeom prst="rect">
+            <a:avLst/>
+          </a:prstGeom>
+          <a:noFill/>
+        </p:spPr>
+        <p:txBody>
+          <a:bodyPr wrap="square" lIns="0" rIns="0" tIns="0" bIns="0" anchor="t">
+            <a:spAutoFit/>
+          </a:bodyPr>
+          <a:lstStyle/>
+          <a:p>
+            <a:pPr algn="l">
+              <a:lnSpc>
+                <a:spcPct val="100000"/>
+              </a:lnSpc>
+            </a:pPr>
+            <a:r>
+              <a:rPr sz="3100" b="1">
+                <a:solidFill>
+                  <a:srgbClr val="202020"/>
+                </a:solidFill>
+                <a:latin typeface="Times New Roman"/>
+              </a:rPr>
+              <a:t>ONE FRAME. TWO TRUTHS.</a:t>
+            </a:r>
+          </a:p>
+        </p:txBody>
+      </p:sp>
+      <p:sp>
+        <p:nvSpPr>
+          <p:cNvPr id="4" name="TextBox 3"/>
+          <p:cNvSpPr txBox="1"/>
+          <p:nvPr/>
+        </p:nvSpPr>
+        <p:spPr>
+          <a:xfrm>
+            <a:off x="402336" y="804672"/>
+            <a:ext cx="7772400" cy="274320"/>
+          </a:xfrm>
+          <a:prstGeom prst="rect">
+            <a:avLst/>
+          </a:prstGeom>
+          <a:noFill/>
+        </p:spPr>
+        <p:txBody>
+          <a:bodyPr wrap="square" lIns="0" rIns="0" tIns="0" bIns="0" anchor="t">
+            <a:spAutoFit/>
+          </a:bodyPr>
+          <a:lstStyle/>
+          <a:p>
+            <a:pPr algn="l">
+              <a:lnSpc>
+                <a:spcPct val="100000"/>
+              </a:lnSpc>
+            </a:pPr>
+            <a:r>
+              <a:rPr sz="1350" b="0">
+                <a:solidFill>
+                  <a:srgbClr val="5C5C5C"/>
+                </a:solidFill>
+                <a:latin typeface="Times New Roman"/>
+              </a:rPr>
+              <a:t>A full-hardware video node on Zynq-7020</a:t>
+            </a:r>
+          </a:p>
+        </p:txBody>
+      </p:sp>
+      <p:sp>
+        <p:nvSpPr>
+          <p:cNvPr id="5" name="TextBox 4"/>
+          <p:cNvSpPr txBox="1"/>
+          <p:nvPr/>
+        </p:nvSpPr>
+        <p:spPr>
+          <a:xfrm>
+            <a:off x="402336" y="1060704"/>
+            <a:ext cx="7589520" cy="228600"/>
+          </a:xfrm>
+          <a:prstGeom prst="rect">
+            <a:avLst/>
+          </a:prstGeom>
+          <a:noFill/>
+        </p:spPr>
+        <p:txBody>
+          <a:bodyPr wrap="square" lIns="0" rIns="0" tIns="0" bIns="0" anchor="t">
+            <a:spAutoFit/>
+          </a:bodyPr>
+          <a:lstStyle/>
+          <a:p>
+            <a:pPr algn="l">
+              <a:lnSpc>
+                <a:spcPct val="100000"/>
+              </a:lnSpc>
+            </a:pPr>
+            <a:r>
+              <a:rPr sz="1100" b="0">
+                <a:solidFill>
+                  <a:srgbClr val="7A2D5E"/>
+                </a:solidFill>
+                <a:latin typeface="Microsoft YaHei"/>
+              </a:rPr>
+              <a:t>多源视频流多效果变换处理系统</a:t>
+            </a:r>
+          </a:p>
+        </p:txBody>
+      </p:sp>
+      <p:sp>
+        <p:nvSpPr>
+          <p:cNvPr id="6" name="TextBox 5"/>
+          <p:cNvSpPr txBox="1"/>
+          <p:nvPr/>
+        </p:nvSpPr>
+        <p:spPr>
+          <a:xfrm>
+            <a:off x="402336" y="1307592"/>
+            <a:ext cx="7589520" cy="347472"/>
+          </a:xfrm>
+          <a:prstGeom prst="rect">
+            <a:avLst/>
+          </a:prstGeom>
+          <a:noFill/>
+        </p:spPr>
+        <p:txBody>
+          <a:bodyPr wrap="square" lIns="0" rIns="0" tIns="0" bIns="0" anchor="t">
+            <a:spAutoFit/>
+          </a:bodyPr>
+          <a:lstStyle/>
+          <a:p>
+            <a:pPr algn="l">
+              <a:lnSpc>
+                <a:spcPct val="100000"/>
+              </a:lnSpc>
+            </a:pPr>
+            <a:r>
+              <a:rPr sz="1050" b="1">
+                <a:solidFill>
+                  <a:srgbClr val="202020"/>
+                </a:solidFill>
+                <a:latin typeface="Times New Roman"/>
+              </a:rPr>
+              <a:t>Team Member: </a:t>
+            </a:r>
+            <a:r>
+              <a:rPr sz="1050" b="0">
+                <a:solidFill>
+                  <a:srgbClr val="202020"/>
+                </a:solidFill>
+                <a:latin typeface="Times New Roman"/>
+              </a:rPr>
+              <a:t>Uie  ·  Hunan University of Technology (湖南工业大学), Hunan Province</a:t>
+            </a:r>
+          </a:p>
+        </p:txBody>
+      </p:sp>
+      <p:pic>
+        <p:nvPicPr>
+          <p:cNvPr id="7" name="Picture 6" descr="hut_emblem.png"/>
+          <p:cNvPicPr>
+            <a:picLocks noChangeAspect="1"/>
+          </p:cNvPicPr>
+          <p:nvPr/>
+        </p:nvPicPr>
+        <p:blipFill>
+          <a:blip r:embed="rId2"/>
+          <a:stretch>
+            <a:fillRect/>
+          </a:stretch>
+        </p:blipFill>
+        <p:spPr>
+          <a:xfrm>
+            <a:off x="8213326" y="91440"/>
+            <a:ext cx="636050" cy="658368"/>
+          </a:xfrm>
+          <a:prstGeom prst="rect">
+            <a:avLst/>
+          </a:prstGeom>
+        </p:spPr>
+      </p:pic>
+      <p:sp>
+        <p:nvSpPr>
+          <p:cNvPr id="8" name="TextBox 7"/>
+          <p:cNvSpPr txBox="1"/>
+          <p:nvPr/>
+        </p:nvSpPr>
+        <p:spPr>
+          <a:xfrm>
+            <a:off x="8869680" y="109728"/>
+            <a:ext cx="1243584" cy="237744"/>
+          </a:xfrm>
+          <a:prstGeom prst="rect">
+            <a:avLst/>
+          </a:prstGeom>
+          <a:noFill/>
+        </p:spPr>
+        <p:txBody>
+          <a:bodyPr wrap="square" lIns="0" rIns="0" tIns="0" bIns="0" anchor="t">
+            <a:spAutoFit/>
+          </a:bodyPr>
+          <a:lstStyle/>
+          <a:p>
+            <a:pPr algn="l">
+              <a:lnSpc>
+                <a:spcPct val="100000"/>
+              </a:lnSpc>
+            </a:pPr>
+            <a:r>
+              <a:rPr sz="950" b="1">
+                <a:solidFill>
+                  <a:srgbClr val="7A2D5E"/>
+                </a:solidFill>
+                <a:latin typeface="Microsoft YaHei"/>
+              </a:rPr>
+              <a:t>湖南工业大学</a:t>
+            </a:r>
+          </a:p>
+        </p:txBody>
+      </p:sp>
+      <p:sp>
+        <p:nvSpPr>
+          <p:cNvPr id="9" name="TextBox 8"/>
+          <p:cNvSpPr txBox="1"/>
+          <p:nvPr/>
+        </p:nvSpPr>
+        <p:spPr>
+          <a:xfrm>
+            <a:off x="8869680" y="365760"/>
+            <a:ext cx="1243584" cy="310896"/>
+          </a:xfrm>
+          <a:prstGeom prst="rect">
+            <a:avLst/>
+          </a:prstGeom>
+          <a:noFill/>
+        </p:spPr>
+        <p:txBody>
+          <a:bodyPr wrap="square" lIns="0" rIns="0" tIns="0" bIns="0" anchor="t">
+            <a:spAutoFit/>
+          </a:bodyPr>
+          <a:lstStyle/>
+          <a:p>
+            <a:pPr algn="l">
+              <a:lnSpc>
+                <a:spcPct val="100000"/>
+              </a:lnSpc>
+            </a:pPr>
+            <a:r>
+              <a:rPr sz="560" b="1">
+                <a:solidFill>
+                  <a:srgbClr val="7A2D5E"/>
+                </a:solidFill>
+                <a:latin typeface="Arial"/>
+              </a:rPr>
+              <a:t>HUNAN UNIVERSITY
+OF TECHNOLOGY</a:t>
+            </a:r>
+          </a:p>
+        </p:txBody>
+      </p:sp>
+      <p:pic>
+        <p:nvPicPr>
+          <p:cNvPr id="10" name="Picture 9" descr="amd_logo_black.png"/>
+          <p:cNvPicPr>
+            <a:picLocks noChangeAspect="1"/>
+          </p:cNvPicPr>
+          <p:nvPr/>
+        </p:nvPicPr>
+        <p:blipFill>
+          <a:blip r:embed="rId3"/>
+          <a:stretch>
+            <a:fillRect/>
+          </a:stretch>
+        </p:blipFill>
+        <p:spPr>
+          <a:xfrm>
+            <a:off x="8211312" y="842051"/>
+            <a:ext cx="1143000" cy="272712"/>
+          </a:xfrm>
+          <a:prstGeom prst="rect">
+            <a:avLst/>
+          </a:prstGeom>
+        </p:spPr>
+      </p:pic>
+      <p:sp>
+        <p:nvSpPr>
+          <p:cNvPr id="11" name="TextBox 10"/>
+          <p:cNvSpPr txBox="1"/>
+          <p:nvPr/>
+        </p:nvSpPr>
+        <p:spPr>
+          <a:xfrm>
+            <a:off x="8211312" y="1143000"/>
+            <a:ext cx="1143000" cy="182880"/>
+          </a:xfrm>
+          <a:prstGeom prst="rect">
+            <a:avLst/>
+          </a:prstGeom>
+          <a:noFill/>
+        </p:spPr>
+        <p:txBody>
+          <a:bodyPr wrap="square" lIns="0" rIns="0" tIns="0" bIns="0" anchor="t">
+            <a:spAutoFit/>
+          </a:bodyPr>
+          <a:lstStyle/>
+          <a:p>
+            <a:pPr algn="l">
+              <a:lnSpc>
+                <a:spcPct val="100000"/>
+              </a:lnSpc>
+            </a:pPr>
+            <a:r>
+              <a:rPr sz="750" b="1">
+                <a:solidFill>
+                  <a:srgbClr val="5C5C5C"/>
+                </a:solidFill>
+                <a:latin typeface="Arial"/>
+              </a:rPr>
+              <a:t>ZYNQ-7020</a:t>
+            </a:r>
+          </a:p>
+        </p:txBody>
+      </p:sp>
+      <p:pic>
+        <p:nvPicPr>
+          <p:cNvPr id="12" name="Picture 11" descr="poster_board.jpg"/>
+          <p:cNvPicPr>
+            <a:picLocks noChangeAspect="1"/>
+          </p:cNvPicPr>
+          <p:nvPr/>
+        </p:nvPicPr>
+        <p:blipFill>
+          <a:blip r:embed="rId4"/>
+          <a:stretch>
+            <a:fillRect/>
+          </a:stretch>
+        </p:blipFill>
+        <p:spPr>
+          <a:xfrm>
+            <a:off x="10195560" y="112268"/>
+            <a:ext cx="1737360" cy="1302510"/>
+          </a:xfrm>
+          <a:prstGeom prst="rect">
+            <a:avLst/>
+          </a:prstGeom>
+        </p:spPr>
+      </p:pic>
+      <p:sp>
+        <p:nvSpPr>
+          <p:cNvPr id="13" name="TextBox 12"/>
+          <p:cNvSpPr txBox="1"/>
+          <p:nvPr/>
+        </p:nvSpPr>
+        <p:spPr>
+          <a:xfrm>
+            <a:off x="10149840" y="1481328"/>
+            <a:ext cx="1783080" cy="283464"/>
+          </a:xfrm>
+          <a:prstGeom prst="rect">
+            <a:avLst/>
+          </a:prstGeom>
+          <a:noFill/>
+        </p:spPr>
+        <p:txBody>
+          <a:bodyPr wrap="square" lIns="0" rIns="0" tIns="0" bIns="0" anchor="t">
+            <a:spAutoFit/>
+          </a:bodyPr>
+          <a:lstStyle/>
+          <a:p>
+            <a:pPr algn="l">
+              <a:lnSpc>
+                <a:spcPct val="100000"/>
+              </a:lnSpc>
+            </a:pPr>
+            <a:r>
+              <a:rPr sz="720" b="0">
+                <a:solidFill>
+                  <a:srgbClr val="5C5C5C"/>
+                </a:solidFill>
+                <a:latin typeface="Arial"/>
+              </a:rPr>
+              <a:t>RK-ZYNQ7020-F V1.0
+xc7z020clg484-2 · 1 GbE</a:t>
+            </a:r>
+          </a:p>
+        </p:txBody>
+      </p:sp>
+      <p:cxnSp>
+        <p:nvCxnSpPr>
+          <p:cNvPr id="14" name="Connector 13"/>
+          <p:cNvCxnSpPr/>
+          <p:nvPr/>
+        </p:nvCxnSpPr>
+        <p:spPr>
+          <a:xfrm>
+            <a:off x="274320" y="1719072"/>
+            <a:ext cx="11658600" cy="0"/>
+          </a:xfrm>
+          <a:prstGeom prst="line">
+            <a:avLst/>
+          </a:prstGeom>
+          <a:ln w="15240">
+            <a:solidFill>
+              <a:srgbClr val="3C3C3C"/>
+            </a:solidFill>
+          </a:ln>
+        </p:spPr>
+        <p:style>
+          <a:lnRef idx="2">
+            <a:schemeClr val="accent1"/>
+          </a:lnRef>
+          <a:fillRef idx="0">
+            <a:schemeClr val="accent1"/>
+          </a:fillRef>
+          <a:effectRef idx="1">
+            <a:schemeClr val="accent1"/>
+          </a:effectRef>
+          <a:fontRef idx="minor">
+            <a:schemeClr val="tx1"/>
+          </a:fontRef>
+        </p:style>
+      </p:cxnSp>
+      <p:sp>
+        <p:nvSpPr>
+          <p:cNvPr id="15" name="Rectangle 14"/>
           <p:cNvSpPr/>
           <p:nvPr/>
         </p:nvSpPr>
         <p:spPr>
           <a:xfrm>
-            <a:off x="0" y="0"/>
-            <a:ext cx="7560259" cy="2240280"/>
+            <a:off x="274320" y="1847088"/>
+            <a:ext cx="3456432" cy="347472"/>
           </a:xfrm>
           <a:prstGeom prst="rect">
             <a:avLst/>
           </a:prstGeom>
           <a:solidFill>
-            <a:srgbClr val="F3EBDD"/>
+            <a:srgbClr val="1C1C1C"/>
           </a:solidFill>
           <a:ln>
             <a:noFill/>
           </a:ln>
-          <a:effectLst/>
         </p:spPr>
         <p:style>
           <a:lnRef idx="1">
@@ -3133,23 +3593,32 @@
           </a:fontRef>
         </p:style>
         <p:txBody>
-          <a:bodyPr rtlCol="0" anchor="ctr"/>
-          <a:lstStyle/>
-          <a:p>
-            <a:pPr algn="ctr"/>
-          </a:p>
-        </p:txBody>
-      </p:sp>
-      <p:sp>
-        <p:nvSpPr>
-          <p:cNvPr id="3" name="TextBox 2"/>
+          <a:bodyPr rtlCol="0" anchor="ctr" lIns="109728" rIns="73152" tIns="0" bIns="0"/>
+          <a:lstStyle/>
+          <a:p>
+            <a:pPr algn="l"/>
+            <a:r>
+              <a:rPr sz="1500" b="1">
+                <a:solidFill>
+                  <a:srgbClr val="FFFFFF"/>
+                </a:solidFill>
+                <a:latin typeface="Arial Black"/>
+              </a:rPr>
+              <a:t>INTRODUCTION</a:t>
+            </a:r>
+          </a:p>
+        </p:txBody>
+      </p:sp>
+      <p:sp>
+        <p:nvSpPr>
+          <p:cNvPr id="16" name="TextBox 15"/>
           <p:cNvSpPr txBox="1"/>
           <p:nvPr/>
         </p:nvSpPr>
         <p:spPr>
           <a:xfrm>
-            <a:off x="475488" y="274320"/>
-            <a:ext cx="4389120" cy="182880"/>
+            <a:off x="310896" y="2267712"/>
+            <a:ext cx="3383280" cy="1417320"/>
           </a:xfrm>
           <a:prstGeom prst="rect">
             <a:avLst/>
@@ -3168,66 +3637,51 @@
               </a:lnSpc>
             </a:pPr>
             <a:r>
-              <a:rPr sz="740" b="1" i="0">
-                <a:solidFill>
-                  <a:srgbClr val="111827"/>
-                </a:solidFill>
-                <a:latin typeface="Bahnschrift"/>
+              <a:rPr sz="919" b="0">
+                <a:solidFill>
+                  <a:srgbClr val="202020"/>
+                </a:solidFill>
+                <a:latin typeface="Times New Roman"/>
               </a:rPr>
-              <a:t>AMD FPGA INNOVATION DESIGN COMPETITION</a:t>
-            </a:r>
-          </a:p>
-        </p:txBody>
-      </p:sp>
-      <p:sp>
-        <p:nvSpPr>
-          <p:cNvPr id="4" name="TextBox 3"/>
+              <a:t>Remote video nodes usually have one Ethernet cable and no PC. The operator must know whether the frame arrived, whether processing took effect, and how old the picture is. This node answers all three from one frame: 512x300 RGB565 enters RGMII, is reassembled and committed to DDR only after three gates, then read back once for both panes. The left pane is the original; the right pane is the same frame after geometry and a fixed 15-cycle effect chain. The seam is a per-pixel decision, not two screenshots.</a:t>
+            </a:r>
+          </a:p>
+        </p:txBody>
+      </p:sp>
+      <p:pic>
+        <p:nvPicPr>
+          <p:cNvPr id="17" name="Picture 16" descr="poster_frame_split.png"/>
+          <p:cNvPicPr>
+            <a:picLocks noChangeAspect="1"/>
+          </p:cNvPicPr>
+          <p:nvPr/>
+        </p:nvPicPr>
+        <p:blipFill>
+          <a:blip r:embed="rId5"/>
+          <a:stretch>
+            <a:fillRect/>
+          </a:stretch>
+        </p:blipFill>
+        <p:spPr>
+          <a:xfrm>
+            <a:off x="413735" y="3657600"/>
+            <a:ext cx="3058728" cy="1792224"/>
+          </a:xfrm>
+          <a:prstGeom prst="rect">
+            <a:avLst/>
+          </a:prstGeom>
+        </p:spPr>
+      </p:pic>
+      <p:sp>
+        <p:nvSpPr>
+          <p:cNvPr id="18" name="TextBox 17"/>
           <p:cNvSpPr txBox="1"/>
           <p:nvPr/>
         </p:nvSpPr>
         <p:spPr>
           <a:xfrm>
-            <a:off x="4526280" y="283464"/>
-            <a:ext cx="2148840" cy="182880"/>
-          </a:xfrm>
-          <a:prstGeom prst="rect">
-            <a:avLst/>
-          </a:prstGeom>
-          <a:noFill/>
-        </p:spPr>
-        <p:txBody>
-          <a:bodyPr wrap="square" lIns="0" rIns="0" tIns="0" bIns="0" anchor="t">
-            <a:spAutoFit/>
-          </a:bodyPr>
-          <a:lstStyle/>
-          <a:p>
-            <a:pPr algn="r">
-              <a:lnSpc>
-                <a:spcPct val="100000"/>
-              </a:lnSpc>
-            </a:pPr>
-            <a:r>
-              <a:rPr sz="660" b="0" i="0">
-                <a:solidFill>
-                  <a:srgbClr val="4B5563"/>
-                </a:solidFill>
-                <a:latin typeface="Bahnschrift"/>
-              </a:rPr>
-              <a:t>PRIMARY GROUP   ·   SELF-DEFINED TRACK</a:t>
-            </a:r>
-          </a:p>
-        </p:txBody>
-      </p:sp>
-      <p:sp>
-        <p:nvSpPr>
-          <p:cNvPr id="5" name="TextBox 4"/>
-          <p:cNvSpPr txBox="1"/>
-          <p:nvPr/>
-        </p:nvSpPr>
-        <p:spPr>
-          <a:xfrm>
-            <a:off x="6711696" y="228600"/>
-            <a:ext cx="585216" cy="256032"/>
+            <a:off x="310896" y="5477256"/>
+            <a:ext cx="3383280" cy="237744"/>
           </a:xfrm>
           <a:prstGeom prst="rect">
             <a:avLst/>
@@ -3246,33 +3700,113 @@
               </a:lnSpc>
             </a:pPr>
             <a:r>
-              <a:rPr sz="1700" b="1" i="0">
-                <a:solidFill>
-                  <a:srgbClr val="111827"/>
-                </a:solidFill>
-                <a:latin typeface="Bahnschrift"/>
+              <a:rPr sz="720" b="0">
+                <a:solidFill>
+                  <a:srgbClr val="5C5C5C"/>
+                </a:solidFill>
+                <a:latin typeface="Arial"/>
               </a:rPr>
-              <a:t>AMD</a:t>
-            </a:r>
-          </a:p>
-        </p:txBody>
-      </p:sp>
-      <p:sp>
-        <p:nvSpPr>
-          <p:cNvPr id="6" name="Isosceles Triangle 5"/>
+              <a:t>Same 512x300 frame  ·  seam 50/50  ·  right pane 0 deg + Sobel</a:t>
+            </a:r>
+          </a:p>
+        </p:txBody>
+      </p:sp>
+      <p:sp>
+        <p:nvSpPr>
+          <p:cNvPr id="19" name="TextBox 18"/>
+          <p:cNvSpPr txBox="1"/>
+          <p:nvPr/>
+        </p:nvSpPr>
+        <p:spPr>
+          <a:xfrm>
+            <a:off x="310896" y="5733288"/>
+            <a:ext cx="3383280" cy="182880"/>
+          </a:xfrm>
+          <a:prstGeom prst="rect">
+            <a:avLst/>
+          </a:prstGeom>
+          <a:noFill/>
+        </p:spPr>
+        <p:txBody>
+          <a:bodyPr wrap="square" lIns="0" rIns="0" tIns="0" bIns="0" anchor="t">
+            <a:spAutoFit/>
+          </a:bodyPr>
+          <a:lstStyle/>
+          <a:p>
+            <a:pPr algn="l">
+              <a:lnSpc>
+                <a:spcPct val="100000"/>
+              </a:lnSpc>
+            </a:pPr>
+            <a:r>
+              <a:rPr sz="900" b="1">
+                <a:solidFill>
+                  <a:srgbClr val="7A2D5E"/>
+                </a:solidFill>
+                <a:latin typeface="Times New Roman"/>
+              </a:rPr>
+              <a:t>Key technical issues addressed:</a:t>
+            </a:r>
+          </a:p>
+        </p:txBody>
+      </p:sp>
+      <p:sp>
+        <p:nvSpPr>
+          <p:cNvPr id="20" name="TextBox 19"/>
+          <p:cNvSpPr txBox="1"/>
+          <p:nvPr/>
+        </p:nvSpPr>
+        <p:spPr>
+          <a:xfrm>
+            <a:off x="310896" y="5925312"/>
+            <a:ext cx="3383280" cy="585216"/>
+          </a:xfrm>
+          <a:prstGeom prst="rect">
+            <a:avLst/>
+          </a:prstGeom>
+          <a:noFill/>
+        </p:spPr>
+        <p:txBody>
+          <a:bodyPr wrap="square" lIns="0" rIns="0" tIns="0" bIns="0" anchor="t">
+            <a:spAutoFit/>
+          </a:bodyPr>
+          <a:lstStyle/>
+          <a:p>
+            <a:pPr algn="l">
+              <a:lnSpc>
+                <a:spcPct val="90000"/>
+              </a:lnSpc>
+            </a:pPr>
+            <a:r>
+              <a:rPr sz="670" b="0">
+                <a:solidFill>
+                  <a:srgbClr val="202020"/>
+                </a:solidFill>
+                <a:latin typeface="Times New Roman"/>
+              </a:rPr>
+              <a:t>1. 1 GbE UDP: offset reassembly; commit = bytes + 300 rows + no bad packet.
+2. Same-frame A/B: one coordinate stream, one row map, 15-cycle chain.
+3. Telemetry: aborts, rows_max, gaps, pane_bad; drop 1/100 reddens it.</a:t>
+            </a:r>
+          </a:p>
+        </p:txBody>
+      </p:sp>
+      <p:sp>
+        <p:nvSpPr>
+          <p:cNvPr id="21" name="Rectangle 20"/>
           <p:cNvSpPr/>
           <p:nvPr/>
         </p:nvSpPr>
         <p:spPr>
-          <a:xfrm rot="5400000">
-            <a:off x="7260336" y="274320"/>
-            <a:ext cx="137160" cy="106984"/>
-          </a:xfrm>
-          <a:prstGeom prst="triangle">
+          <a:xfrm>
+            <a:off x="3931920" y="1847088"/>
+            <a:ext cx="3794760" cy="347472"/>
+          </a:xfrm>
+          <a:prstGeom prst="rect">
             <a:avLst/>
           </a:prstGeom>
           <a:solidFill>
-            <a:srgbClr val="111827"/>
+            <a:srgbClr val="1C1C1C"/>
           </a:solidFill>
           <a:ln>
             <a:noFill/>
@@ -3293,34 +3827,109 @@
           </a:fontRef>
         </p:style>
         <p:txBody>
-          <a:bodyPr rtlCol="0" anchor="ctr"/>
-          <a:lstStyle/>
-          <a:p>
-            <a:pPr algn="ctr"/>
-          </a:p>
-        </p:txBody>
-      </p:sp>
-      <p:sp>
-        <p:nvSpPr>
-          <p:cNvPr id="7" name="Rectangle 6"/>
+          <a:bodyPr rtlCol="0" anchor="ctr" lIns="109728" rIns="73152" tIns="0" bIns="0"/>
+          <a:lstStyle/>
+          <a:p>
+            <a:pPr algn="l"/>
+            <a:r>
+              <a:rPr sz="1500" b="1">
+                <a:solidFill>
+                  <a:srgbClr val="FFFFFF"/>
+                </a:solidFill>
+                <a:latin typeface="Arial Black"/>
+              </a:rPr>
+              <a:t>SYSTEM ARCHITECTURE</a:t>
+            </a:r>
+          </a:p>
+        </p:txBody>
+      </p:sp>
+      <p:pic>
+        <p:nvPicPr>
+          <p:cNvPr id="22" name="Picture 21" descr="poster_arch.png"/>
+          <p:cNvPicPr>
+            <a:picLocks noChangeAspect="1"/>
+          </p:cNvPicPr>
+          <p:nvPr/>
+        </p:nvPicPr>
+        <p:blipFill>
+          <a:blip r:embed="rId6"/>
+          <a:stretch>
+            <a:fillRect/>
+          </a:stretch>
+        </p:blipFill>
+        <p:spPr>
+          <a:xfrm>
+            <a:off x="3943694" y="2267712"/>
+            <a:ext cx="3771211" cy="1709928"/>
+          </a:xfrm>
+          <a:prstGeom prst="rect">
+            <a:avLst/>
+          </a:prstGeom>
+        </p:spPr>
+      </p:pic>
+      <p:sp>
+        <p:nvSpPr>
+          <p:cNvPr id="23" name="TextBox 22"/>
+          <p:cNvSpPr txBox="1"/>
+          <p:nvPr/>
+        </p:nvSpPr>
+        <p:spPr>
+          <a:xfrm>
+            <a:off x="3931920" y="4005072"/>
+            <a:ext cx="3794760" cy="219456"/>
+          </a:xfrm>
+          <a:prstGeom prst="rect">
+            <a:avLst/>
+          </a:prstGeom>
+          <a:noFill/>
+        </p:spPr>
+        <p:txBody>
+          <a:bodyPr wrap="square" lIns="0" rIns="0" tIns="0" bIns="0" anchor="t">
+            <a:spAutoFit/>
+          </a:bodyPr>
+          <a:lstStyle/>
+          <a:p>
+            <a:pPr algn="l">
+              <a:lnSpc>
+                <a:spcPct val="100000"/>
+              </a:lnSpc>
+            </a:pPr>
+            <a:r>
+              <a:rPr sz="700" b="0">
+                <a:solidFill>
+                  <a:srgbClr val="5C5C5C"/>
+                </a:solidFill>
+                <a:latin typeface="Arial"/>
+              </a:rPr>
+              <a:t>RGMII -&gt; UDP -&gt; DDR ping-pong -&gt; geometry -&gt; effects -&gt; A/B seam -&gt; HDMI</a:t>
+            </a:r>
+          </a:p>
+        </p:txBody>
+      </p:sp>
+      <p:sp>
+        <p:nvSpPr>
+          <p:cNvPr id="24" name="Rounded Rectangle 23"/>
           <p:cNvSpPr/>
           <p:nvPr/>
         </p:nvSpPr>
         <p:spPr>
           <a:xfrm>
-            <a:off x="475488" y="493776"/>
-            <a:ext cx="6601968" cy="7315"/>
-          </a:xfrm>
-          <a:prstGeom prst="rect">
-            <a:avLst/>
+            <a:off x="3931920" y="4389120"/>
+            <a:ext cx="3794760" cy="1005840"/>
+          </a:xfrm>
+          <a:prstGeom prst="roundRect">
+            <a:avLst>
+              <a:gd name="adj" fmla="val 8000"/>
+            </a:avLst>
           </a:prstGeom>
           <a:solidFill>
-            <a:srgbClr val="C55221"/>
+            <a:srgbClr val="FFFFFF"/>
           </a:solidFill>
-          <a:ln>
-            <a:noFill/>
+          <a:ln w="11430">
+            <a:solidFill>
+              <a:srgbClr val="AAAAAA"/>
+            </a:solidFill>
           </a:ln>
-          <a:effectLst/>
         </p:spPr>
         <p:style>
           <a:lnRef idx="1">
@@ -3337,190 +3946,66 @@
           </a:fontRef>
         </p:style>
         <p:txBody>
-          <a:bodyPr rtlCol="0" anchor="ctr"/>
-          <a:lstStyle/>
-          <a:p>
-            <a:pPr algn="ctr"/>
-          </a:p>
-        </p:txBody>
-      </p:sp>
-      <p:sp>
-        <p:nvSpPr>
-          <p:cNvPr id="8" name="TextBox 7"/>
-          <p:cNvSpPr txBox="1"/>
-          <p:nvPr/>
-        </p:nvSpPr>
-        <p:spPr>
-          <a:xfrm>
-            <a:off x="475488" y="621792"/>
-            <a:ext cx="5852160" cy="182880"/>
-          </a:xfrm>
-          <a:prstGeom prst="rect">
-            <a:avLst/>
-          </a:prstGeom>
-          <a:noFill/>
-        </p:spPr>
-        <p:txBody>
-          <a:bodyPr wrap="square" lIns="0" rIns="0" tIns="0" bIns="0" anchor="t">
-            <a:spAutoFit/>
-          </a:bodyPr>
-          <a:lstStyle/>
-          <a:p>
-            <a:pPr algn="l">
+          <a:bodyPr rtlCol="0" anchor="ctr" wrap="square" lIns="146304" rIns="128016" tIns="73152" bIns="54864"/>
+          <a:lstStyle/>
+          <a:p>
+            <a:pPr algn="ctr">
+              <a:spcAft>
+                <a:spcPts val="300"/>
+              </a:spcAft>
+            </a:pPr>
+            <a:r>
+              <a:rPr sz="1050" b="1">
+                <a:solidFill>
+                  <a:srgbClr val="7A2D5E"/>
+                </a:solidFill>
+                <a:latin typeface="Arial"/>
+              </a:rPr>
+              <a:t>THREE-GATE COMMIT</a:t>
+            </a:r>
+          </a:p>
+          <a:p>
+            <a:pPr>
               <a:lnSpc>
                 <a:spcPct val="100000"/>
               </a:lnSpc>
             </a:pPr>
             <a:r>
-              <a:rPr sz="1000" b="1" i="0">
-                <a:solidFill>
-                  <a:srgbClr val="C55221"/>
-                </a:solidFill>
-                <a:latin typeface="Bahnschrift"/>
+              <a:rPr sz="850">
+                <a:solidFill>
+                  <a:srgbClr val="202020"/>
+                </a:solidFill>
+                <a:latin typeface="Times New Roman"/>
               </a:rPr>
-              <a:t>ZYNQ-7020   ·   A FULLY HARDWARE VIDEO NODE</a:t>
-            </a:r>
-          </a:p>
-        </p:txBody>
-      </p:sp>
-      <p:sp>
-        <p:nvSpPr>
-          <p:cNvPr id="9" name="TextBox 8"/>
-          <p:cNvSpPr txBox="1"/>
-          <p:nvPr/>
-        </p:nvSpPr>
-        <p:spPr>
-          <a:xfrm>
-            <a:off x="475488" y="859536"/>
-            <a:ext cx="6583680" cy="502920"/>
-          </a:xfrm>
-          <a:prstGeom prst="rect">
-            <a:avLst/>
-          </a:prstGeom>
-          <a:noFill/>
-        </p:spPr>
-        <p:txBody>
-          <a:bodyPr wrap="square" lIns="0" rIns="0" tIns="0" bIns="0" anchor="t">
-            <a:spAutoFit/>
-          </a:bodyPr>
-          <a:lstStyle/>
-          <a:p>
-            <a:pPr algn="l">
-              <a:lnSpc>
-                <a:spcPct val="100000"/>
-              </a:lnSpc>
-            </a:pPr>
-            <a:r>
-              <a:rPr sz="3200" b="0" i="0">
-                <a:solidFill>
-                  <a:srgbClr val="111827"/>
-                </a:solidFill>
-                <a:latin typeface="Bahnschrift"/>
-              </a:rPr>
-              <a:t>ONE FRAME.</a:t>
-            </a:r>
-          </a:p>
-        </p:txBody>
-      </p:sp>
-      <p:sp>
-        <p:nvSpPr>
-          <p:cNvPr id="10" name="TextBox 9"/>
-          <p:cNvSpPr txBox="1"/>
-          <p:nvPr/>
-        </p:nvSpPr>
-        <p:spPr>
-          <a:xfrm>
-            <a:off x="475488" y="1243584"/>
-            <a:ext cx="6583680" cy="502920"/>
-          </a:xfrm>
-          <a:prstGeom prst="rect">
-            <a:avLst/>
-          </a:prstGeom>
-          <a:noFill/>
-        </p:spPr>
-        <p:txBody>
-          <a:bodyPr wrap="square" lIns="0" rIns="0" tIns="0" bIns="0" anchor="t">
-            <a:spAutoFit/>
-          </a:bodyPr>
-          <a:lstStyle/>
-          <a:p>
-            <a:pPr algn="l">
-              <a:lnSpc>
-                <a:spcPct val="100000"/>
-              </a:lnSpc>
-            </a:pPr>
-            <a:r>
-              <a:rPr sz="3200" b="0" i="0">
-                <a:solidFill>
-                  <a:srgbClr val="C55221"/>
-                </a:solidFill>
-                <a:latin typeface="Bahnschrift"/>
-              </a:rPr>
-              <a:t>TWO TRUTHS.</a:t>
-            </a:r>
-          </a:p>
-        </p:txBody>
-      </p:sp>
-      <p:sp>
-        <p:nvSpPr>
-          <p:cNvPr id="11" name="TextBox 10"/>
-          <p:cNvSpPr txBox="1"/>
-          <p:nvPr/>
-        </p:nvSpPr>
-        <p:spPr>
-          <a:xfrm>
-            <a:off x="475488" y="1700784"/>
-            <a:ext cx="6400800" cy="420624"/>
-          </a:xfrm>
-          <a:prstGeom prst="rect">
-            <a:avLst/>
-          </a:prstGeom>
-          <a:noFill/>
-        </p:spPr>
-        <p:txBody>
-          <a:bodyPr wrap="square" lIns="0" rIns="0" tIns="0" bIns="0" anchor="t">
-            <a:spAutoFit/>
-          </a:bodyPr>
-          <a:lstStyle/>
-          <a:p>
-            <a:pPr algn="l">
-              <a:lnSpc>
-                <a:spcPct val="106000"/>
-              </a:lnSpc>
-            </a:pPr>
-            <a:r>
-              <a:rPr sz="1100" b="0" i="0">
-                <a:solidFill>
-                  <a:srgbClr val="4B5563"/>
-                </a:solidFill>
-                <a:latin typeface="Bahnschrift"/>
-              </a:rPr>
-              <a:t>Original and processed pixels leave one frame buffer in the same clock; the seam compares content, not screenshots. The node reports what it did on the wire at 1 Hz.</a:t>
-            </a:r>
-          </a:p>
-        </p:txBody>
-      </p:sp>
-      <p:sp>
-        <p:nvSpPr>
-          <p:cNvPr id="12" name="Rectangle 11"/>
+              <a:t>A frame is committed only when 307200 bytes arrived, all 300 source rows were written, and no packet failed. Otherwise the last good frame stays on screen and aborts + rows_max expose the reason.</a:t>
+            </a:r>
+          </a:p>
+        </p:txBody>
+      </p:sp>
+      <p:sp>
+        <p:nvSpPr>
+          <p:cNvPr id="25" name="Rounded Rectangle 24"/>
           <p:cNvSpPr/>
           <p:nvPr/>
         </p:nvSpPr>
         <p:spPr>
           <a:xfrm>
-            <a:off x="0" y="2240280"/>
-            <a:ext cx="7560259" cy="365760"/>
-          </a:xfrm>
-          <a:prstGeom prst="rect">
-            <a:avLst/>
+            <a:off x="3931920" y="5504688"/>
+            <a:ext cx="3794760" cy="1005840"/>
+          </a:xfrm>
+          <a:prstGeom prst="roundRect">
+            <a:avLst>
+              <a:gd name="adj" fmla="val 8000"/>
+            </a:avLst>
           </a:prstGeom>
           <a:solidFill>
-            <a:srgbClr val="C55221"/>
+            <a:srgbClr val="FFFFFF"/>
           </a:solidFill>
-          <a:ln>
-            <a:noFill/>
+          <a:ln w="11430">
+            <a:solidFill>
+              <a:srgbClr val="AAAAAA"/>
+            </a:solidFill>
           </a:ln>
-          <a:effectLst/>
         </p:spPr>
         <p:style>
           <a:lnRef idx="1">
@@ -3537,97 +4022,62 @@
           </a:fontRef>
         </p:style>
         <p:txBody>
-          <a:bodyPr rtlCol="0" anchor="ctr"/>
-          <a:lstStyle/>
-          <a:p>
-            <a:pPr algn="ctr"/>
-          </a:p>
-        </p:txBody>
-      </p:sp>
-      <p:sp>
-        <p:nvSpPr>
-          <p:cNvPr id="13" name="TextBox 12"/>
-          <p:cNvSpPr txBox="1"/>
-          <p:nvPr/>
-        </p:nvSpPr>
-        <p:spPr>
-          <a:xfrm>
-            <a:off x="475488" y="2313432"/>
-            <a:ext cx="6583680" cy="182880"/>
-          </a:xfrm>
-          <a:prstGeom prst="rect">
-            <a:avLst/>
-          </a:prstGeom>
-          <a:noFill/>
-        </p:spPr>
-        <p:txBody>
-          <a:bodyPr wrap="square" lIns="0" rIns="0" tIns="0" bIns="0" anchor="t">
-            <a:spAutoFit/>
-          </a:bodyPr>
-          <a:lstStyle/>
-          <a:p>
-            <a:pPr algn="l">
+          <a:bodyPr rtlCol="0" anchor="ctr" wrap="square" lIns="146304" rIns="128016" tIns="73152" bIns="54864"/>
+          <a:lstStyle/>
+          <a:p>
+            <a:pPr algn="ctr">
+              <a:spcAft>
+                <a:spcPts val="300"/>
+              </a:spcAft>
+            </a:pPr>
+            <a:r>
+              <a:rPr sz="1050" b="1">
+                <a:solidFill>
+                  <a:srgbClr val="7A2D5E"/>
+                </a:solidFill>
+                <a:latin typeface="Arial"/>
+              </a:rPr>
+              <a:t>SAME-FRAME A/B</a:t>
+            </a:r>
+          </a:p>
+          <a:p>
+            <a:pPr>
               <a:lnSpc>
                 <a:spcPct val="100000"/>
               </a:lnSpc>
             </a:pPr>
             <a:r>
-              <a:rPr sz="1200" b="1" i="0">
-                <a:solidFill>
-                  <a:srgbClr val="FFFFFF"/>
-                </a:solidFill>
-                <a:latin typeface="Consolas"/>
+              <a:rPr sz="850">
+                <a:solidFill>
+                  <a:srgbClr val="202020"/>
+                </a:solidFill>
+                <a:latin typeface="Times New Roman"/>
               </a:rPr>
-              <a:t>SAME 512×300 FRAME   /   SOBEL   /   0°   /   NO ROTATION</a:t>
-            </a:r>
-          </a:p>
-        </p:txBody>
-      </p:sp>
-      <p:pic>
-        <p:nvPicPr>
-          <p:cNvPr id="14" name="Picture 13" descr="poster_frame_split.png"/>
-          <p:cNvPicPr>
-            <a:picLocks noChangeAspect="1"/>
-          </p:cNvPicPr>
+              <a:t>Original and processed panes share one source-coordinate stream, one row map and one 15-cycle effect chain. The seam is a per-pixel select; rotation or stacked effects cannot make the panes disagree.</a:t>
+            </a:r>
+          </a:p>
+        </p:txBody>
+      </p:sp>
+      <p:sp>
+        <p:nvSpPr>
+          <p:cNvPr id="26" name="Rectangle 25"/>
+          <p:cNvSpPr/>
           <p:nvPr/>
-        </p:nvPicPr>
-        <p:blipFill>
-          <a:blip r:embed="rId2"/>
-          <a:stretch>
-            <a:fillRect/>
-          </a:stretch>
-        </p:blipFill>
-        <p:spPr>
-          <a:xfrm>
-            <a:off x="475488" y="2724912"/>
-            <a:ext cx="6601968" cy="3867912"/>
+        </p:nvSpPr>
+        <p:spPr>
+          <a:xfrm>
+            <a:off x="7909560" y="1847088"/>
+            <a:ext cx="4023360" cy="347472"/>
           </a:xfrm>
           <a:prstGeom prst="rect">
             <a:avLst/>
           </a:prstGeom>
-        </p:spPr>
-      </p:pic>
-      <p:sp>
-        <p:nvSpPr>
-          <p:cNvPr id="15" name="Rectangle 14"/>
-          <p:cNvSpPr/>
-          <p:nvPr/>
-        </p:nvSpPr>
-        <p:spPr>
-          <a:xfrm>
-            <a:off x="475488" y="2724912"/>
-            <a:ext cx="6601968" cy="3867912"/>
-          </a:xfrm>
-          <a:prstGeom prst="rect">
-            <a:avLst/>
-          </a:prstGeom>
-          <a:noFill/>
-          <a:ln w="10160">
-            <a:solidFill>
-              <a:srgbClr val="C55221"/>
-            </a:solidFill>
+          <a:solidFill>
+            <a:srgbClr val="1C1C1C"/>
+          </a:solidFill>
+          <a:ln>
+            <a:noFill/>
           </a:ln>
-          <a:effectLst/>
         </p:spPr>
         <p:style>
           <a:lnRef idx="1">
@@ -3644,23 +4094,32 @@
           </a:fontRef>
         </p:style>
         <p:txBody>
-          <a:bodyPr rtlCol="0" anchor="ctr"/>
-          <a:lstStyle/>
-          <a:p>
-            <a:pPr algn="ctr"/>
-          </a:p>
-        </p:txBody>
-      </p:sp>
-      <p:sp>
-        <p:nvSpPr>
-          <p:cNvPr id="16" name="TextBox 15"/>
+          <a:bodyPr rtlCol="0" anchor="ctr" lIns="109728" rIns="73152" tIns="0" bIns="0"/>
+          <a:lstStyle/>
+          <a:p>
+            <a:pPr algn="l"/>
+            <a:r>
+              <a:rPr sz="1500" b="1">
+                <a:solidFill>
+                  <a:srgbClr val="FFFFFF"/>
+                </a:solidFill>
+                <a:latin typeface="Arial Black"/>
+              </a:rPr>
+              <a:t>RESULT</a:t>
+            </a:r>
+          </a:p>
+        </p:txBody>
+      </p:sp>
+      <p:sp>
+        <p:nvSpPr>
+          <p:cNvPr id="27" name="TextBox 26"/>
           <p:cNvSpPr txBox="1"/>
           <p:nvPr/>
         </p:nvSpPr>
         <p:spPr>
           <a:xfrm>
-            <a:off x="475488" y="6656832"/>
-            <a:ext cx="6583680" cy="146304"/>
+            <a:off x="7955279" y="2267712"/>
+            <a:ext cx="3931920" cy="502920"/>
           </a:xfrm>
           <a:prstGeom prst="rect">
             <a:avLst/>
@@ -3679,38 +4138,37 @@
               </a:lnSpc>
             </a:pPr>
             <a:r>
-              <a:rPr sz="1000" b="0" i="1">
-                <a:solidFill>
-                  <a:srgbClr val="4B5563"/>
-                </a:solidFill>
-                <a:latin typeface="Bahnschrift"/>
+              <a:rPr sz="919" b="0">
+                <a:solidFill>
+                  <a:srgbClr val="202020"/>
+                </a:solidFill>
+                <a:latin typeface="Times New Roman"/>
               </a:rPr>
-              <a:t>Rendered from the same test frame; two panes, one frame identity.</a:t>
-            </a:r>
-          </a:p>
-        </p:txBody>
-      </p:sp>
-      <p:sp>
-        <p:nvSpPr>
-          <p:cNvPr id="17" name="Rectangle 16"/>
+              <a:t>RGMII -&gt; HDMI entirely in PL; PS only control, SD playback and telemetry. 1024x600 at 59.5 Hz, 1 GbE UDP ingest.</a:t>
+            </a:r>
+          </a:p>
+        </p:txBody>
+      </p:sp>
+      <p:sp>
+        <p:nvSpPr>
+          <p:cNvPr id="28" name="Rectangle 27"/>
           <p:cNvSpPr/>
           <p:nvPr/>
         </p:nvSpPr>
         <p:spPr>
           <a:xfrm>
-            <a:off x="0" y="6784848"/>
-            <a:ext cx="7560259" cy="1536192"/>
+            <a:off x="7955279" y="2880360"/>
+            <a:ext cx="3931920" cy="256032"/>
           </a:xfrm>
           <a:prstGeom prst="rect">
             <a:avLst/>
           </a:prstGeom>
           <a:solidFill>
-            <a:srgbClr val="F3EBDD"/>
+            <a:srgbClr val="F8F8F8"/>
           </a:solidFill>
           <a:ln>
             <a:noFill/>
           </a:ln>
-          <a:effectLst/>
         </p:spPr>
         <p:style>
           <a:lnRef idx="1">
@@ -3736,14 +4194,14 @@
       </p:sp>
       <p:sp>
         <p:nvSpPr>
-          <p:cNvPr id="18" name="TextBox 17"/>
+          <p:cNvPr id="29" name="TextBox 28"/>
           <p:cNvSpPr txBox="1"/>
           <p:nvPr/>
         </p:nvSpPr>
         <p:spPr>
           <a:xfrm>
-            <a:off x="475488" y="6912864"/>
-            <a:ext cx="365760" cy="182880"/>
+            <a:off x="8010144" y="2916936"/>
+            <a:ext cx="1234440" cy="182880"/>
           </a:xfrm>
           <a:prstGeom prst="rect">
             <a:avLst/>
@@ -3762,27 +4220,27 @@
               </a:lnSpc>
             </a:pPr>
             <a:r>
-              <a:rPr sz="1200" b="1" i="0">
-                <a:solidFill>
-                  <a:srgbClr val="C55221"/>
-                </a:solidFill>
-                <a:latin typeface="Bahnschrift"/>
+              <a:rPr sz="819" b="1">
+                <a:solidFill>
+                  <a:srgbClr val="5C5C5C"/>
+                </a:solidFill>
+                <a:latin typeface="Arial"/>
               </a:rPr>
-              <a:t>01</a:t>
-            </a:r>
-          </a:p>
-        </p:txBody>
-      </p:sp>
-      <p:sp>
-        <p:nvSpPr>
-          <p:cNvPr id="19" name="TextBox 18"/>
+              <a:t>Setup WNS</a:t>
+            </a:r>
+          </a:p>
+        </p:txBody>
+      </p:sp>
+      <p:sp>
+        <p:nvSpPr>
+          <p:cNvPr id="30" name="TextBox 29"/>
           <p:cNvSpPr txBox="1"/>
           <p:nvPr/>
         </p:nvSpPr>
         <p:spPr>
           <a:xfrm>
-            <a:off x="859536" y="6912864"/>
-            <a:ext cx="1783080" cy="182880"/>
+            <a:off x="9235440" y="2916936"/>
+            <a:ext cx="2578608" cy="182880"/>
           </a:xfrm>
           <a:prstGeom prst="rect">
             <a:avLst/>
@@ -3801,311 +4259,37 @@
               </a:lnSpc>
             </a:pPr>
             <a:r>
-              <a:rPr sz="1400" b="1" i="0">
-                <a:solidFill>
-                  <a:srgbClr val="111827"/>
-                </a:solidFill>
-                <a:latin typeface="Bahnschrift"/>
+              <a:rPr sz="860" b="0">
+                <a:solidFill>
+                  <a:srgbClr val="202020"/>
+                </a:solidFill>
+                <a:latin typeface="Arial"/>
               </a:rPr>
-              <a:t>SAME-FRAME A/B</a:t>
-            </a:r>
-          </a:p>
-        </p:txBody>
-      </p:sp>
-      <p:sp>
-        <p:nvSpPr>
-          <p:cNvPr id="20" name="TextBox 19"/>
-          <p:cNvSpPr txBox="1"/>
+              <a:t>1.341 ns  ·  0 failing endpoints</a:t>
+            </a:r>
+          </a:p>
+        </p:txBody>
+      </p:sp>
+      <p:sp>
+        <p:nvSpPr>
+          <p:cNvPr id="31" name="Rectangle 30"/>
+          <p:cNvSpPr/>
           <p:nvPr/>
         </p:nvSpPr>
         <p:spPr>
           <a:xfrm>
-            <a:off x="475488" y="7205472"/>
-            <a:ext cx="1993392" cy="777240"/>
+            <a:off x="7955279" y="3154679"/>
+            <a:ext cx="3931920" cy="256032"/>
           </a:xfrm>
           <a:prstGeom prst="rect">
             <a:avLst/>
           </a:prstGeom>
-          <a:noFill/>
-        </p:spPr>
-        <p:txBody>
-          <a:bodyPr wrap="square" lIns="0" rIns="0" tIns="0" bIns="0" anchor="t">
-            <a:spAutoFit/>
-          </a:bodyPr>
-          <a:lstStyle/>
-          <a:p>
-            <a:pPr algn="l">
-              <a:lnSpc>
-                <a:spcPct val="110000"/>
-              </a:lnSpc>
-            </a:pPr>
-            <a:r>
-              <a:rPr sz="1100" b="0" i="0">
-                <a:solidFill>
-                  <a:srgbClr val="4B5563"/>
-                </a:solidFill>
-                <a:latin typeface="Bahnschrift"/>
-              </a:rPr>
-              <a:t>Fixed 15-cycle chain; the seam is a pixel decision.</a:t>
-            </a:r>
-          </a:p>
-        </p:txBody>
-      </p:sp>
-      <p:sp>
-        <p:nvSpPr>
-          <p:cNvPr id="21" name="TextBox 20"/>
-          <p:cNvSpPr txBox="1"/>
-          <p:nvPr/>
-        </p:nvSpPr>
-        <p:spPr>
-          <a:xfrm>
-            <a:off x="2706624" y="6912864"/>
-            <a:ext cx="365760" cy="182880"/>
-          </a:xfrm>
-          <a:prstGeom prst="rect">
-            <a:avLst/>
-          </a:prstGeom>
-          <a:noFill/>
-        </p:spPr>
-        <p:txBody>
-          <a:bodyPr wrap="square" lIns="0" rIns="0" tIns="0" bIns="0" anchor="t">
-            <a:spAutoFit/>
-          </a:bodyPr>
-          <a:lstStyle/>
-          <a:p>
-            <a:pPr algn="l">
-              <a:lnSpc>
-                <a:spcPct val="100000"/>
-              </a:lnSpc>
-            </a:pPr>
-            <a:r>
-              <a:rPr sz="1200" b="1" i="0">
-                <a:solidFill>
-                  <a:srgbClr val="C55221"/>
-                </a:solidFill>
-                <a:latin typeface="Bahnschrift"/>
-              </a:rPr>
-              <a:t>02</a:t>
-            </a:r>
-          </a:p>
-        </p:txBody>
-      </p:sp>
-      <p:sp>
-        <p:nvSpPr>
-          <p:cNvPr id="22" name="TextBox 21"/>
-          <p:cNvSpPr txBox="1"/>
-          <p:nvPr/>
-        </p:nvSpPr>
-        <p:spPr>
-          <a:xfrm>
-            <a:off x="3090672" y="6912864"/>
-            <a:ext cx="1783080" cy="182880"/>
-          </a:xfrm>
-          <a:prstGeom prst="rect">
-            <a:avLst/>
-          </a:prstGeom>
-          <a:noFill/>
-        </p:spPr>
-        <p:txBody>
-          <a:bodyPr wrap="square" lIns="0" rIns="0" tIns="0" bIns="0" anchor="t">
-            <a:spAutoFit/>
-          </a:bodyPr>
-          <a:lstStyle/>
-          <a:p>
-            <a:pPr algn="l">
-              <a:lnSpc>
-                <a:spcPct val="100000"/>
-              </a:lnSpc>
-            </a:pPr>
-            <a:r>
-              <a:rPr sz="1400" b="1" i="0">
-                <a:solidFill>
-                  <a:srgbClr val="111827"/>
-                </a:solidFill>
-                <a:latin typeface="Bahnschrift"/>
-              </a:rPr>
-              <a:t>TELEMETRY</a:t>
-            </a:r>
-          </a:p>
-        </p:txBody>
-      </p:sp>
-      <p:sp>
-        <p:nvSpPr>
-          <p:cNvPr id="23" name="TextBox 22"/>
-          <p:cNvSpPr txBox="1"/>
-          <p:nvPr/>
-        </p:nvSpPr>
-        <p:spPr>
-          <a:xfrm>
-            <a:off x="2706624" y="7205472"/>
-            <a:ext cx="1993392" cy="777240"/>
-          </a:xfrm>
-          <a:prstGeom prst="rect">
-            <a:avLst/>
-          </a:prstGeom>
-          <a:noFill/>
-        </p:spPr>
-        <p:txBody>
-          <a:bodyPr wrap="square" lIns="0" rIns="0" tIns="0" bIns="0" anchor="t">
-            <a:spAutoFit/>
-          </a:bodyPr>
-          <a:lstStyle/>
-          <a:p>
-            <a:pPr algn="l">
-              <a:lnSpc>
-                <a:spcPct val="110000"/>
-              </a:lnSpc>
-            </a:pPr>
-            <a:r>
-              <a:rPr sz="1100" b="0" i="0">
-                <a:solidFill>
-                  <a:srgbClr val="4B5563"/>
-                </a:solidFill>
-                <a:latin typeface="Bahnschrift"/>
-              </a:rPr>
-              <a:t>Frame-commit gates (bytes/rows/bad), aborts, latency, pane, gaps at 1 Hz.</a:t>
-            </a:r>
-          </a:p>
-        </p:txBody>
-      </p:sp>
-      <p:sp>
-        <p:nvSpPr>
-          <p:cNvPr id="24" name="TextBox 23"/>
-          <p:cNvSpPr txBox="1"/>
-          <p:nvPr/>
-        </p:nvSpPr>
-        <p:spPr>
-          <a:xfrm>
-            <a:off x="4937760" y="6912864"/>
-            <a:ext cx="365760" cy="182880"/>
-          </a:xfrm>
-          <a:prstGeom prst="rect">
-            <a:avLst/>
-          </a:prstGeom>
-          <a:noFill/>
-        </p:spPr>
-        <p:txBody>
-          <a:bodyPr wrap="square" lIns="0" rIns="0" tIns="0" bIns="0" anchor="t">
-            <a:spAutoFit/>
-          </a:bodyPr>
-          <a:lstStyle/>
-          <a:p>
-            <a:pPr algn="l">
-              <a:lnSpc>
-                <a:spcPct val="100000"/>
-              </a:lnSpc>
-            </a:pPr>
-            <a:r>
-              <a:rPr sz="1200" b="1" i="0">
-                <a:solidFill>
-                  <a:srgbClr val="C55221"/>
-                </a:solidFill>
-                <a:latin typeface="Bahnschrift"/>
-              </a:rPr>
-              <a:t>03</a:t>
-            </a:r>
-          </a:p>
-        </p:txBody>
-      </p:sp>
-      <p:sp>
-        <p:nvSpPr>
-          <p:cNvPr id="25" name="TextBox 24"/>
-          <p:cNvSpPr txBox="1"/>
-          <p:nvPr/>
-        </p:nvSpPr>
-        <p:spPr>
-          <a:xfrm>
-            <a:off x="5321808" y="6912864"/>
-            <a:ext cx="1783080" cy="182880"/>
-          </a:xfrm>
-          <a:prstGeom prst="rect">
-            <a:avLst/>
-          </a:prstGeom>
-          <a:noFill/>
-        </p:spPr>
-        <p:txBody>
-          <a:bodyPr wrap="square" lIns="0" rIns="0" tIns="0" bIns="0" anchor="t">
-            <a:spAutoFit/>
-          </a:bodyPr>
-          <a:lstStyle/>
-          <a:p>
-            <a:pPr algn="l">
-              <a:lnSpc>
-                <a:spcPct val="100000"/>
-              </a:lnSpc>
-            </a:pPr>
-            <a:r>
-              <a:rPr sz="1400" b="1" i="0">
-                <a:solidFill>
-                  <a:srgbClr val="111827"/>
-                </a:solidFill>
-                <a:latin typeface="Bahnschrift"/>
-              </a:rPr>
-              <a:t>FAULT INJECTION</a:t>
-            </a:r>
-          </a:p>
-        </p:txBody>
-      </p:sp>
-      <p:sp>
-        <p:nvSpPr>
-          <p:cNvPr id="26" name="TextBox 25"/>
-          <p:cNvSpPr txBox="1"/>
-          <p:nvPr/>
-        </p:nvSpPr>
-        <p:spPr>
-          <a:xfrm>
-            <a:off x="4937760" y="7205472"/>
-            <a:ext cx="1993392" cy="777240"/>
-          </a:xfrm>
-          <a:prstGeom prst="rect">
-            <a:avLst/>
-          </a:prstGeom>
-          <a:noFill/>
-        </p:spPr>
-        <p:txBody>
-          <a:bodyPr wrap="square" lIns="0" rIns="0" tIns="0" bIns="0" anchor="t">
-            <a:spAutoFit/>
-          </a:bodyPr>
-          <a:lstStyle/>
-          <a:p>
-            <a:pPr algn="l">
-              <a:lnSpc>
-                <a:spcPct val="110000"/>
-              </a:lnSpc>
-            </a:pPr>
-            <a:r>
-              <a:rPr sz="1100" b="0" i="0">
-                <a:solidFill>
-                  <a:srgbClr val="4B5563"/>
-                </a:solidFill>
-                <a:latin typeface="Bahnschrift"/>
-              </a:rPr>
-              <a:t>Drop 1 in 100; aborts move; recovery returns.</a:t>
-            </a:r>
-          </a:p>
-        </p:txBody>
-      </p:sp>
-      <p:sp>
-        <p:nvSpPr>
-          <p:cNvPr id="27" name="Rectangle 26"/>
-          <p:cNvSpPr/>
-          <p:nvPr/>
-        </p:nvSpPr>
-        <p:spPr>
-          <a:xfrm>
-            <a:off x="0" y="8321040"/>
-            <a:ext cx="7560259" cy="987552"/>
-          </a:xfrm>
-          <a:prstGeom prst="rect">
-            <a:avLst/>
-          </a:prstGeom>
           <a:solidFill>
-            <a:srgbClr val="C55221"/>
+            <a:srgbClr val="FFFFFF"/>
           </a:solidFill>
           <a:ln>
             <a:noFill/>
           </a:ln>
-          <a:effectLst/>
         </p:spPr>
         <p:style>
           <a:lnRef idx="1">
@@ -4131,14 +4315,14 @@
       </p:sp>
       <p:sp>
         <p:nvSpPr>
-          <p:cNvPr id="28" name="TextBox 27"/>
+          <p:cNvPr id="32" name="TextBox 31"/>
           <p:cNvSpPr txBox="1"/>
           <p:nvPr/>
         </p:nvSpPr>
         <p:spPr>
           <a:xfrm>
-            <a:off x="475488" y="8439912"/>
-            <a:ext cx="1481328" cy="365760"/>
+            <a:off x="8010144" y="3191256"/>
+            <a:ext cx="1234440" cy="182880"/>
           </a:xfrm>
           <a:prstGeom prst="rect">
             <a:avLst/>
@@ -4157,27 +4341,27 @@
               </a:lnSpc>
             </a:pPr>
             <a:r>
-              <a:rPr sz="2400" b="0" i="0">
-                <a:solidFill>
-                  <a:srgbClr val="FFFFFF"/>
-                </a:solidFill>
-                <a:latin typeface="Bahnschrift Light"/>
+              <a:rPr sz="819" b="1">
+                <a:solidFill>
+                  <a:srgbClr val="5C5C5C"/>
+                </a:solidFill>
+                <a:latin typeface="Arial"/>
               </a:rPr>
-              <a:t>1.341 ns</a:t>
-            </a:r>
-          </a:p>
-        </p:txBody>
-      </p:sp>
-      <p:sp>
-        <p:nvSpPr>
-          <p:cNvPr id="29" name="TextBox 28"/>
+              <a:t>Hold WHS</a:t>
+            </a:r>
+          </a:p>
+        </p:txBody>
+      </p:sp>
+      <p:sp>
+        <p:nvSpPr>
+          <p:cNvPr id="33" name="TextBox 32"/>
           <p:cNvSpPr txBox="1"/>
           <p:nvPr/>
         </p:nvSpPr>
         <p:spPr>
           <a:xfrm>
-            <a:off x="475488" y="8860536"/>
-            <a:ext cx="1463040" cy="228600"/>
+            <a:off x="9235440" y="3191256"/>
+            <a:ext cx="2578608" cy="182880"/>
           </a:xfrm>
           <a:prstGeom prst="rect">
             <a:avLst/>
@@ -4196,389 +4380,37 @@
               </a:lnSpc>
             </a:pPr>
             <a:r>
-              <a:rPr sz="1200" b="0" i="0">
-                <a:solidFill>
-                  <a:srgbClr val="FFF7ED"/>
-                </a:solidFill>
-                <a:latin typeface="Bahnschrift"/>
+              <a:rPr sz="860" b="0">
+                <a:solidFill>
+                  <a:srgbClr val="202020"/>
+                </a:solidFill>
+                <a:latin typeface="Arial"/>
               </a:rPr>
-              <a:t>setup WNS · 0 failing endpoints</a:t>
-            </a:r>
-          </a:p>
-        </p:txBody>
-      </p:sp>
-      <p:sp>
-        <p:nvSpPr>
-          <p:cNvPr id="30" name="TextBox 29"/>
-          <p:cNvSpPr txBox="1"/>
+              <a:t>0.025 ns  ·  positive margin</a:t>
+            </a:r>
+          </a:p>
+        </p:txBody>
+      </p:sp>
+      <p:sp>
+        <p:nvSpPr>
+          <p:cNvPr id="34" name="Rectangle 33"/>
+          <p:cNvSpPr/>
           <p:nvPr/>
         </p:nvSpPr>
         <p:spPr>
           <a:xfrm>
-            <a:off x="2103120" y="8439912"/>
-            <a:ext cx="1481328" cy="365760"/>
+            <a:off x="7955279" y="3429000"/>
+            <a:ext cx="3931920" cy="256032"/>
           </a:xfrm>
           <a:prstGeom prst="rect">
             <a:avLst/>
           </a:prstGeom>
-          <a:noFill/>
-        </p:spPr>
-        <p:txBody>
-          <a:bodyPr wrap="square" lIns="0" rIns="0" tIns="0" bIns="0" anchor="t">
-            <a:spAutoFit/>
-          </a:bodyPr>
-          <a:lstStyle/>
-          <a:p>
-            <a:pPr algn="l">
-              <a:lnSpc>
-                <a:spcPct val="100000"/>
-              </a:lnSpc>
-            </a:pPr>
-            <a:r>
-              <a:rPr sz="2400" b="0" i="0">
-                <a:solidFill>
-                  <a:srgbClr val="FFFFFF"/>
-                </a:solidFill>
-                <a:latin typeface="Bahnschrift Light"/>
-              </a:rPr>
-              <a:t>0.025 ns</a:t>
-            </a:r>
-          </a:p>
-        </p:txBody>
-      </p:sp>
-      <p:sp>
-        <p:nvSpPr>
-          <p:cNvPr id="31" name="TextBox 30"/>
-          <p:cNvSpPr txBox="1"/>
-          <p:nvPr/>
-        </p:nvSpPr>
-        <p:spPr>
-          <a:xfrm>
-            <a:off x="2103120" y="8860536"/>
-            <a:ext cx="1463040" cy="228600"/>
-          </a:xfrm>
-          <a:prstGeom prst="rect">
-            <a:avLst/>
-          </a:prstGeom>
-          <a:noFill/>
-        </p:spPr>
-        <p:txBody>
-          <a:bodyPr wrap="square" lIns="0" rIns="0" tIns="0" bIns="0" anchor="t">
-            <a:spAutoFit/>
-          </a:bodyPr>
-          <a:lstStyle/>
-          <a:p>
-            <a:pPr algn="l">
-              <a:lnSpc>
-                <a:spcPct val="100000"/>
-              </a:lnSpc>
-            </a:pPr>
-            <a:r>
-              <a:rPr sz="1200" b="0" i="0">
-                <a:solidFill>
-                  <a:srgbClr val="FFF7ED"/>
-                </a:solidFill>
-                <a:latin typeface="Bahnschrift"/>
-              </a:rPr>
-              <a:t>hold WHS · tightest path</a:t>
-            </a:r>
-          </a:p>
-        </p:txBody>
-      </p:sp>
-      <p:sp>
-        <p:nvSpPr>
-          <p:cNvPr id="32" name="TextBox 31"/>
-          <p:cNvSpPr txBox="1"/>
-          <p:nvPr/>
-        </p:nvSpPr>
-        <p:spPr>
-          <a:xfrm>
-            <a:off x="3730752" y="8439912"/>
-            <a:ext cx="1481328" cy="365760"/>
-          </a:xfrm>
-          <a:prstGeom prst="rect">
-            <a:avLst/>
-          </a:prstGeom>
-          <a:noFill/>
-        </p:spPr>
-        <p:txBody>
-          <a:bodyPr wrap="square" lIns="0" rIns="0" tIns="0" bIns="0" anchor="t">
-            <a:spAutoFit/>
-          </a:bodyPr>
-          <a:lstStyle/>
-          <a:p>
-            <a:pPr algn="l">
-              <a:lnSpc>
-                <a:spcPct val="100000"/>
-              </a:lnSpc>
-            </a:pPr>
-            <a:r>
-              <a:rPr sz="2400" b="0" i="0">
-                <a:solidFill>
-                  <a:srgbClr val="FFFFFF"/>
-                </a:solidFill>
-                <a:latin typeface="Bahnschrift Light"/>
-              </a:rPr>
-              <a:t>70.00%</a:t>
-            </a:r>
-          </a:p>
-        </p:txBody>
-      </p:sp>
-      <p:sp>
-        <p:nvSpPr>
-          <p:cNvPr id="33" name="TextBox 32"/>
-          <p:cNvSpPr txBox="1"/>
-          <p:nvPr/>
-        </p:nvSpPr>
-        <p:spPr>
-          <a:xfrm>
-            <a:off x="3730752" y="8860536"/>
-            <a:ext cx="1463040" cy="228600"/>
-          </a:xfrm>
-          <a:prstGeom prst="rect">
-            <a:avLst/>
-          </a:prstGeom>
-          <a:noFill/>
-        </p:spPr>
-        <p:txBody>
-          <a:bodyPr wrap="square" lIns="0" rIns="0" tIns="0" bIns="0" anchor="t">
-            <a:spAutoFit/>
-          </a:bodyPr>
-          <a:lstStyle/>
-          <a:p>
-            <a:pPr algn="l">
-              <a:lnSpc>
-                <a:spcPct val="100000"/>
-              </a:lnSpc>
-            </a:pPr>
-            <a:r>
-              <a:rPr sz="1200" b="0" i="0">
-                <a:solidFill>
-                  <a:srgbClr val="FFF7ED"/>
-                </a:solidFill>
-                <a:latin typeface="Bahnschrift"/>
-              </a:rPr>
-              <a:t>BRAM · 98 of 140 tiles</a:t>
-            </a:r>
-          </a:p>
-        </p:txBody>
-      </p:sp>
-      <p:sp>
-        <p:nvSpPr>
-          <p:cNvPr id="34" name="TextBox 33"/>
-          <p:cNvSpPr txBox="1"/>
-          <p:nvPr/>
-        </p:nvSpPr>
-        <p:spPr>
-          <a:xfrm>
-            <a:off x="5358383" y="8439912"/>
-            <a:ext cx="1481328" cy="365760"/>
-          </a:xfrm>
-          <a:prstGeom prst="rect">
-            <a:avLst/>
-          </a:prstGeom>
-          <a:noFill/>
-        </p:spPr>
-        <p:txBody>
-          <a:bodyPr wrap="square" lIns="0" rIns="0" tIns="0" bIns="0" anchor="t">
-            <a:spAutoFit/>
-          </a:bodyPr>
-          <a:lstStyle/>
-          <a:p>
-            <a:pPr algn="l">
-              <a:lnSpc>
-                <a:spcPct val="100000"/>
-              </a:lnSpc>
-            </a:pPr>
-            <a:r>
-              <a:rPr sz="2200" b="0" i="0">
-                <a:solidFill>
-                  <a:srgbClr val="FFFFFF"/>
-                </a:solidFill>
-                <a:latin typeface="Bahnschrift Light"/>
-              </a:rPr>
-              <a:t>15 cycles</a:t>
-            </a:r>
-          </a:p>
-        </p:txBody>
-      </p:sp>
-      <p:sp>
-        <p:nvSpPr>
-          <p:cNvPr id="35" name="TextBox 34"/>
-          <p:cNvSpPr txBox="1"/>
-          <p:nvPr/>
-        </p:nvSpPr>
-        <p:spPr>
-          <a:xfrm>
-            <a:off x="5358383" y="8860536"/>
-            <a:ext cx="1463040" cy="228600"/>
-          </a:xfrm>
-          <a:prstGeom prst="rect">
-            <a:avLst/>
-          </a:prstGeom>
-          <a:noFill/>
-        </p:spPr>
-        <p:txBody>
-          <a:bodyPr wrap="square" lIns="0" rIns="0" tIns="0" bIns="0" anchor="t">
-            <a:spAutoFit/>
-          </a:bodyPr>
-          <a:lstStyle/>
-          <a:p>
-            <a:pPr algn="l">
-              <a:lnSpc>
-                <a:spcPct val="100000"/>
-              </a:lnSpc>
-            </a:pPr>
-            <a:r>
-              <a:rPr sz="1200" b="0" i="0">
-                <a:solidFill>
-                  <a:srgbClr val="FFF7ED"/>
-                </a:solidFill>
-                <a:latin typeface="Bahnschrift"/>
-              </a:rPr>
-              <a:t>fixed effect latency</a:t>
-            </a:r>
-          </a:p>
-        </p:txBody>
-      </p:sp>
-      <p:sp>
-        <p:nvSpPr>
-          <p:cNvPr id="36" name="TextBox 35"/>
-          <p:cNvSpPr txBox="1"/>
-          <p:nvPr/>
-        </p:nvSpPr>
-        <p:spPr>
-          <a:xfrm>
-            <a:off x="475488" y="9491472"/>
-            <a:ext cx="6601968" cy="182880"/>
-          </a:xfrm>
-          <a:prstGeom prst="rect">
-            <a:avLst/>
-          </a:prstGeom>
-          <a:noFill/>
-        </p:spPr>
-        <p:txBody>
-          <a:bodyPr wrap="square" lIns="0" rIns="0" tIns="0" bIns="0" anchor="t">
-            <a:spAutoFit/>
-          </a:bodyPr>
-          <a:lstStyle/>
-          <a:p>
-            <a:pPr algn="l">
-              <a:lnSpc>
-                <a:spcPct val="100000"/>
-              </a:lnSpc>
-            </a:pPr>
-            <a:r>
-              <a:rPr sz="1000" b="1" i="0">
-                <a:solidFill>
-                  <a:srgbClr val="CC8800"/>
-                </a:solidFill>
-                <a:latin typeface="Consolas"/>
-              </a:rPr>
-              <a:t>RGMII  →  MAC  →  UDP  →  DDR  →  GEOMETRY  →  6-STAGE EFFECTS  →  A/B SEAM  →  HDMI</a:t>
-            </a:r>
-          </a:p>
-        </p:txBody>
-      </p:sp>
-      <p:sp>
-        <p:nvSpPr>
-          <p:cNvPr id="37" name="TextBox 36"/>
-          <p:cNvSpPr txBox="1"/>
-          <p:nvPr/>
-        </p:nvSpPr>
-        <p:spPr>
-          <a:xfrm>
-            <a:off x="475488" y="9692640"/>
-            <a:ext cx="6601968" cy="182880"/>
-          </a:xfrm>
-          <a:prstGeom prst="rect">
-            <a:avLst/>
-          </a:prstGeom>
-          <a:noFill/>
-        </p:spPr>
-        <p:txBody>
-          <a:bodyPr wrap="square" lIns="0" rIns="0" tIns="0" bIns="0" anchor="t">
-            <a:spAutoFit/>
-          </a:bodyPr>
-          <a:lstStyle/>
-          <a:p>
-            <a:pPr algn="l">
-              <a:lnSpc>
-                <a:spcPct val="100000"/>
-              </a:lnSpc>
-            </a:pPr>
-            <a:r>
-              <a:rPr sz="900" b="0" i="0">
-                <a:solidFill>
-                  <a:srgbClr val="4B5563"/>
-                </a:solidFill>
-                <a:latin typeface="Bahnschrift"/>
-              </a:rPr>
-              <a:t>512×300 RGB565 at 30 fps  →  1024×600 at 59.5 Hz   ·   xc7z020clg484-2   ·   1 GbE UDP ingest   ·   SD and test-pattern fallback</a:t>
-            </a:r>
-          </a:p>
-        </p:txBody>
-      </p:sp>
-      <p:sp>
-        <p:nvSpPr>
-          <p:cNvPr id="38" name="TextBox 37"/>
-          <p:cNvSpPr txBox="1"/>
-          <p:nvPr/>
-        </p:nvSpPr>
-        <p:spPr>
-          <a:xfrm>
-            <a:off x="475488" y="9948672"/>
-            <a:ext cx="6601968" cy="164592"/>
-          </a:xfrm>
-          <a:prstGeom prst="rect">
-            <a:avLst/>
-          </a:prstGeom>
-          <a:noFill/>
-        </p:spPr>
-        <p:txBody>
-          <a:bodyPr wrap="square" lIns="0" rIns="0" tIns="0" bIns="0" anchor="t">
-            <a:spAutoFit/>
-          </a:bodyPr>
-          <a:lstStyle/>
-          <a:p>
-            <a:pPr algn="l">
-              <a:lnSpc>
-                <a:spcPct val="100000"/>
-              </a:lnSpc>
-            </a:pPr>
-            <a:r>
-              <a:rPr sz="1000" b="1" i="0">
-                <a:solidFill>
-                  <a:srgbClr val="111827"/>
-                </a:solidFill>
-                <a:latin typeface="Consolas"/>
-              </a:rPr>
-              <a:t>29.95 FPS   ·   PANE_BAD=0   ·   QSPI COLD BOOT</a:t>
-            </a:r>
-          </a:p>
-        </p:txBody>
-      </p:sp>
-      <p:sp>
-        <p:nvSpPr>
-          <p:cNvPr id="39" name="Rectangle 38"/>
-          <p:cNvSpPr/>
-          <p:nvPr/>
-        </p:nvSpPr>
-        <p:spPr>
-          <a:xfrm>
-            <a:off x="475488" y="10323576"/>
-            <a:ext cx="6601968" cy="5486"/>
-          </a:xfrm>
-          <a:prstGeom prst="rect">
-            <a:avLst/>
-          </a:prstGeom>
           <a:solidFill>
-            <a:srgbClr val="C55221"/>
+            <a:srgbClr val="F8F8F8"/>
           </a:solidFill>
           <a:ln>
             <a:noFill/>
           </a:ln>
-          <a:effectLst/>
         </p:spPr>
         <p:style>
           <a:lnRef idx="1">
@@ -4604,14 +4436,14 @@
       </p:sp>
       <p:sp>
         <p:nvSpPr>
-          <p:cNvPr id="40" name="TextBox 39"/>
+          <p:cNvPr id="35" name="TextBox 34"/>
           <p:cNvSpPr txBox="1"/>
           <p:nvPr/>
         </p:nvSpPr>
         <p:spPr>
           <a:xfrm>
-            <a:off x="475488" y="10387584"/>
-            <a:ext cx="5349240" cy="274320"/>
+            <a:off x="8010144" y="3465576"/>
+            <a:ext cx="1234440" cy="182880"/>
           </a:xfrm>
           <a:prstGeom prst="rect">
             <a:avLst/>
@@ -4625,61 +4457,777 @@
           <a:lstStyle/>
           <a:p>
             <a:pPr algn="l">
-              <a:lnSpc>
-                <a:spcPct val="103000"/>
-              </a:lnSpc>
-            </a:pPr>
-            <a:r>
-              <a:rPr sz="550" b="0" i="0">
-                <a:solidFill>
-                  <a:srgbClr val="4B5563"/>
-                </a:solidFill>
-                <a:latin typeface="Bahnschrift"/>
-              </a:rPr>
-              <a:t>AMD, the AMD Arrow logo and combinations thereof are trademarks of Advanced Micro Devices, Inc. Zynq is a trademark of AMD. All other trademarks are the property of their respective owners.</a:t>
-            </a:r>
-          </a:p>
-        </p:txBody>
-      </p:sp>
-      <p:sp>
-        <p:nvSpPr>
-          <p:cNvPr id="41" name="TextBox 40"/>
-          <p:cNvSpPr txBox="1"/>
-          <p:nvPr/>
-        </p:nvSpPr>
-        <p:spPr>
-          <a:xfrm>
-            <a:off x="5349240" y="10387584"/>
-            <a:ext cx="1737360" cy="182880"/>
-          </a:xfrm>
-          <a:prstGeom prst="rect">
-            <a:avLst/>
-          </a:prstGeom>
-          <a:noFill/>
-        </p:spPr>
-        <p:txBody>
-          <a:bodyPr wrap="square" lIns="0" rIns="0" tIns="0" bIns="0" anchor="t">
-            <a:spAutoFit/>
-          </a:bodyPr>
-          <a:lstStyle/>
-          <a:p>
-            <a:pPr algn="r">
               <a:lnSpc>
                 <a:spcPct val="100000"/>
               </a:lnSpc>
             </a:pPr>
             <a:r>
-              <a:rPr sz="560" b="0" i="0">
-                <a:solidFill>
-                  <a:srgbClr val="4B5563"/>
-                </a:solidFill>
-                <a:latin typeface="Bahnschrift"/>
+              <a:rPr sz="819" b="1">
+                <a:solidFill>
+                  <a:srgbClr val="5C5C5C"/>
+                </a:solidFill>
+                <a:latin typeface="Arial"/>
               </a:rPr>
-              <a:t>Zynq-7020  ·  1024×600 HDMI</a:t>
-            </a:r>
-          </a:p>
-        </p:txBody>
-      </p:sp>
+              <a:t>BRAM</a:t>
+            </a:r>
+          </a:p>
+        </p:txBody>
+      </p:sp>
+      <p:sp>
+        <p:nvSpPr>
+          <p:cNvPr id="36" name="TextBox 35"/>
+          <p:cNvSpPr txBox="1"/>
+          <p:nvPr/>
+        </p:nvSpPr>
+        <p:spPr>
+          <a:xfrm>
+            <a:off x="9235440" y="3465576"/>
+            <a:ext cx="2578608" cy="182880"/>
+          </a:xfrm>
+          <a:prstGeom prst="rect">
+            <a:avLst/>
+          </a:prstGeom>
+          <a:noFill/>
+        </p:spPr>
+        <p:txBody>
+          <a:bodyPr wrap="square" lIns="0" rIns="0" tIns="0" bIns="0" anchor="t">
+            <a:spAutoFit/>
+          </a:bodyPr>
+          <a:lstStyle/>
+          <a:p>
+            <a:pPr algn="l">
+              <a:lnSpc>
+                <a:spcPct val="100000"/>
+              </a:lnSpc>
+            </a:pPr>
+            <a:r>
+              <a:rPr sz="860" b="0">
+                <a:solidFill>
+                  <a:srgbClr val="202020"/>
+                </a:solidFill>
+                <a:latin typeface="Arial"/>
+              </a:rPr>
+              <a:t>70.0%  ·  98 / 140 tiles</a:t>
+            </a:r>
+          </a:p>
+        </p:txBody>
+      </p:sp>
+      <p:sp>
+        <p:nvSpPr>
+          <p:cNvPr id="37" name="Rectangle 36"/>
+          <p:cNvSpPr/>
+          <p:nvPr/>
+        </p:nvSpPr>
+        <p:spPr>
+          <a:xfrm>
+            <a:off x="7955279" y="3703320"/>
+            <a:ext cx="3931920" cy="256032"/>
+          </a:xfrm>
+          <a:prstGeom prst="rect">
+            <a:avLst/>
+          </a:prstGeom>
+          <a:solidFill>
+            <a:srgbClr val="FFFFFF"/>
+          </a:solidFill>
+          <a:ln>
+            <a:noFill/>
+          </a:ln>
+        </p:spPr>
+        <p:style>
+          <a:lnRef idx="1">
+            <a:schemeClr val="accent1"/>
+          </a:lnRef>
+          <a:fillRef idx="3">
+            <a:schemeClr val="accent1"/>
+          </a:fillRef>
+          <a:effectRef idx="2">
+            <a:schemeClr val="accent1"/>
+          </a:effectRef>
+          <a:fontRef idx="minor">
+            <a:schemeClr val="lt1"/>
+          </a:fontRef>
+        </p:style>
+        <p:txBody>
+          <a:bodyPr rtlCol="0" anchor="ctr"/>
+          <a:lstStyle/>
+          <a:p>
+            <a:pPr algn="ctr"/>
+          </a:p>
+        </p:txBody>
+      </p:sp>
+      <p:sp>
+        <p:nvSpPr>
+          <p:cNvPr id="38" name="TextBox 37"/>
+          <p:cNvSpPr txBox="1"/>
+          <p:nvPr/>
+        </p:nvSpPr>
+        <p:spPr>
+          <a:xfrm>
+            <a:off x="8010144" y="3739896"/>
+            <a:ext cx="1234440" cy="182880"/>
+          </a:xfrm>
+          <a:prstGeom prst="rect">
+            <a:avLst/>
+          </a:prstGeom>
+          <a:noFill/>
+        </p:spPr>
+        <p:txBody>
+          <a:bodyPr wrap="square" lIns="0" rIns="0" tIns="0" bIns="0" anchor="t">
+            <a:spAutoFit/>
+          </a:bodyPr>
+          <a:lstStyle/>
+          <a:p>
+            <a:pPr algn="l">
+              <a:lnSpc>
+                <a:spcPct val="100000"/>
+              </a:lnSpc>
+            </a:pPr>
+            <a:r>
+              <a:rPr sz="819" b="1">
+                <a:solidFill>
+                  <a:srgbClr val="5C5C5C"/>
+                </a:solidFill>
+                <a:latin typeface="Arial"/>
+              </a:rPr>
+              <a:t>8 s stream</a:t>
+            </a:r>
+          </a:p>
+        </p:txBody>
+      </p:sp>
+      <p:sp>
+        <p:nvSpPr>
+          <p:cNvPr id="39" name="TextBox 38"/>
+          <p:cNvSpPr txBox="1"/>
+          <p:nvPr/>
+        </p:nvSpPr>
+        <p:spPr>
+          <a:xfrm>
+            <a:off x="9235440" y="3739896"/>
+            <a:ext cx="2578608" cy="182880"/>
+          </a:xfrm>
+          <a:prstGeom prst="rect">
+            <a:avLst/>
+          </a:prstGeom>
+          <a:noFill/>
+        </p:spPr>
+        <p:txBody>
+          <a:bodyPr wrap="square" lIns="0" rIns="0" tIns="0" bIns="0" anchor="t">
+            <a:spAutoFit/>
+          </a:bodyPr>
+          <a:lstStyle/>
+          <a:p>
+            <a:pPr algn="l">
+              <a:lnSpc>
+                <a:spcPct val="100000"/>
+              </a:lnSpc>
+            </a:pPr>
+            <a:r>
+              <a:rPr sz="860" b="0">
+                <a:solidFill>
+                  <a:srgbClr val="202020"/>
+                </a:solidFill>
+                <a:latin typeface="Arial"/>
+              </a:rPr>
+              <a:t>241 frames  ·  29.95 fps</a:t>
+            </a:r>
+          </a:p>
+        </p:txBody>
+      </p:sp>
+      <p:sp>
+        <p:nvSpPr>
+          <p:cNvPr id="40" name="Rectangle 39"/>
+          <p:cNvSpPr/>
+          <p:nvPr/>
+        </p:nvSpPr>
+        <p:spPr>
+          <a:xfrm>
+            <a:off x="7955279" y="3977639"/>
+            <a:ext cx="3931920" cy="256032"/>
+          </a:xfrm>
+          <a:prstGeom prst="rect">
+            <a:avLst/>
+          </a:prstGeom>
+          <a:solidFill>
+            <a:srgbClr val="F8F8F8"/>
+          </a:solidFill>
+          <a:ln>
+            <a:noFill/>
+          </a:ln>
+        </p:spPr>
+        <p:style>
+          <a:lnRef idx="1">
+            <a:schemeClr val="accent1"/>
+          </a:lnRef>
+          <a:fillRef idx="3">
+            <a:schemeClr val="accent1"/>
+          </a:fillRef>
+          <a:effectRef idx="2">
+            <a:schemeClr val="accent1"/>
+          </a:effectRef>
+          <a:fontRef idx="minor">
+            <a:schemeClr val="lt1"/>
+          </a:fontRef>
+        </p:style>
+        <p:txBody>
+          <a:bodyPr rtlCol="0" anchor="ctr"/>
+          <a:lstStyle/>
+          <a:p>
+            <a:pPr algn="ctr"/>
+          </a:p>
+        </p:txBody>
+      </p:sp>
+      <p:sp>
+        <p:nvSpPr>
+          <p:cNvPr id="41" name="TextBox 40"/>
+          <p:cNvSpPr txBox="1"/>
+          <p:nvPr/>
+        </p:nvSpPr>
+        <p:spPr>
+          <a:xfrm>
+            <a:off x="8010144" y="4014215"/>
+            <a:ext cx="1234440" cy="182880"/>
+          </a:xfrm>
+          <a:prstGeom prst="rect">
+            <a:avLst/>
+          </a:prstGeom>
+          <a:noFill/>
+        </p:spPr>
+        <p:txBody>
+          <a:bodyPr wrap="square" lIns="0" rIns="0" tIns="0" bIns="0" anchor="t">
+            <a:spAutoFit/>
+          </a:bodyPr>
+          <a:lstStyle/>
+          <a:p>
+            <a:pPr algn="l">
+              <a:lnSpc>
+                <a:spcPct val="100000"/>
+              </a:lnSpc>
+            </a:pPr>
+            <a:r>
+              <a:rPr sz="819" b="1">
+                <a:solidFill>
+                  <a:srgbClr val="5C5C5C"/>
+                </a:solidFill>
+                <a:latin typeface="Arial"/>
+              </a:rPr>
+              <a:t>UART battery</a:t>
+            </a:r>
+          </a:p>
+        </p:txBody>
+      </p:sp>
+      <p:sp>
+        <p:nvSpPr>
+          <p:cNvPr id="42" name="TextBox 41"/>
+          <p:cNvSpPr txBox="1"/>
+          <p:nvPr/>
+        </p:nvSpPr>
+        <p:spPr>
+          <a:xfrm>
+            <a:off x="9235440" y="4014215"/>
+            <a:ext cx="2578608" cy="182880"/>
+          </a:xfrm>
+          <a:prstGeom prst="rect">
+            <a:avLst/>
+          </a:prstGeom>
+          <a:noFill/>
+        </p:spPr>
+        <p:txBody>
+          <a:bodyPr wrap="square" lIns="0" rIns="0" tIns="0" bIns="0" anchor="t">
+            <a:spAutoFit/>
+          </a:bodyPr>
+          <a:lstStyle/>
+          <a:p>
+            <a:pPr algn="l">
+              <a:lnSpc>
+                <a:spcPct val="100000"/>
+              </a:lnSpc>
+            </a:pPr>
+            <a:r>
+              <a:rPr sz="860" b="0">
+                <a:solidFill>
+                  <a:srgbClr val="202020"/>
+                </a:solidFill>
+                <a:latin typeface="Arial"/>
+              </a:rPr>
+              <a:t>105 commands  ·  PASS</a:t>
+            </a:r>
+          </a:p>
+        </p:txBody>
+      </p:sp>
+      <p:sp>
+        <p:nvSpPr>
+          <p:cNvPr id="43" name="Rectangle 42"/>
+          <p:cNvSpPr/>
+          <p:nvPr/>
+        </p:nvSpPr>
+        <p:spPr>
+          <a:xfrm>
+            <a:off x="7955279" y="4251960"/>
+            <a:ext cx="3931920" cy="256032"/>
+          </a:xfrm>
+          <a:prstGeom prst="rect">
+            <a:avLst/>
+          </a:prstGeom>
+          <a:solidFill>
+            <a:srgbClr val="FFFFFF"/>
+          </a:solidFill>
+          <a:ln>
+            <a:noFill/>
+          </a:ln>
+        </p:spPr>
+        <p:style>
+          <a:lnRef idx="1">
+            <a:schemeClr val="accent1"/>
+          </a:lnRef>
+          <a:fillRef idx="3">
+            <a:schemeClr val="accent1"/>
+          </a:fillRef>
+          <a:effectRef idx="2">
+            <a:schemeClr val="accent1"/>
+          </a:effectRef>
+          <a:fontRef idx="minor">
+            <a:schemeClr val="lt1"/>
+          </a:fontRef>
+        </p:style>
+        <p:txBody>
+          <a:bodyPr rtlCol="0" anchor="ctr"/>
+          <a:lstStyle/>
+          <a:p>
+            <a:pPr algn="ctr"/>
+          </a:p>
+        </p:txBody>
+      </p:sp>
+      <p:sp>
+        <p:nvSpPr>
+          <p:cNvPr id="44" name="TextBox 43"/>
+          <p:cNvSpPr txBox="1"/>
+          <p:nvPr/>
+        </p:nvSpPr>
+        <p:spPr>
+          <a:xfrm>
+            <a:off x="8010144" y="4288536"/>
+            <a:ext cx="1234440" cy="182880"/>
+          </a:xfrm>
+          <a:prstGeom prst="rect">
+            <a:avLst/>
+          </a:prstGeom>
+          <a:noFill/>
+        </p:spPr>
+        <p:txBody>
+          <a:bodyPr wrap="square" lIns="0" rIns="0" tIns="0" bIns="0" anchor="t">
+            <a:spAutoFit/>
+          </a:bodyPr>
+          <a:lstStyle/>
+          <a:p>
+            <a:pPr algn="l">
+              <a:lnSpc>
+                <a:spcPct val="100000"/>
+              </a:lnSpc>
+            </a:pPr>
+            <a:r>
+              <a:rPr sz="819" b="1">
+                <a:solidFill>
+                  <a:srgbClr val="5C5C5C"/>
+                </a:solidFill>
+                <a:latin typeface="Arial"/>
+              </a:rPr>
+              <a:t>QSPI cold boot</a:t>
+            </a:r>
+          </a:p>
+        </p:txBody>
+      </p:sp>
+      <p:sp>
+        <p:nvSpPr>
+          <p:cNvPr id="45" name="TextBox 44"/>
+          <p:cNvSpPr txBox="1"/>
+          <p:nvPr/>
+        </p:nvSpPr>
+        <p:spPr>
+          <a:xfrm>
+            <a:off x="9235440" y="4288536"/>
+            <a:ext cx="2578608" cy="182880"/>
+          </a:xfrm>
+          <a:prstGeom prst="rect">
+            <a:avLst/>
+          </a:prstGeom>
+          <a:noFill/>
+        </p:spPr>
+        <p:txBody>
+          <a:bodyPr wrap="square" lIns="0" rIns="0" tIns="0" bIns="0" anchor="t">
+            <a:spAutoFit/>
+          </a:bodyPr>
+          <a:lstStyle/>
+          <a:p>
+            <a:pPr algn="l">
+              <a:lnSpc>
+                <a:spcPct val="100000"/>
+              </a:lnSpc>
+            </a:pPr>
+            <a:r>
+              <a:rPr sz="860" b="0">
+                <a:solidFill>
+                  <a:srgbClr val="202020"/>
+                </a:solidFill>
+                <a:latin typeface="Arial"/>
+              </a:rPr>
+              <a:t>DONE / EOS  ·  no CRC error</a:t>
+            </a:r>
+          </a:p>
+        </p:txBody>
+      </p:sp>
+      <p:sp>
+        <p:nvSpPr>
+          <p:cNvPr id="46" name="Rectangle 45"/>
+          <p:cNvSpPr/>
+          <p:nvPr/>
+        </p:nvSpPr>
+        <p:spPr>
+          <a:xfrm>
+            <a:off x="7955279" y="4526279"/>
+            <a:ext cx="3931920" cy="256032"/>
+          </a:xfrm>
+          <a:prstGeom prst="rect">
+            <a:avLst/>
+          </a:prstGeom>
+          <a:solidFill>
+            <a:srgbClr val="F8F8F8"/>
+          </a:solidFill>
+          <a:ln>
+            <a:noFill/>
+          </a:ln>
+        </p:spPr>
+        <p:style>
+          <a:lnRef idx="1">
+            <a:schemeClr val="accent1"/>
+          </a:lnRef>
+          <a:fillRef idx="3">
+            <a:schemeClr val="accent1"/>
+          </a:fillRef>
+          <a:effectRef idx="2">
+            <a:schemeClr val="accent1"/>
+          </a:effectRef>
+          <a:fontRef idx="minor">
+            <a:schemeClr val="lt1"/>
+          </a:fontRef>
+        </p:style>
+        <p:txBody>
+          <a:bodyPr rtlCol="0" anchor="ctr"/>
+          <a:lstStyle/>
+          <a:p>
+            <a:pPr algn="ctr"/>
+          </a:p>
+        </p:txBody>
+      </p:sp>
+      <p:sp>
+        <p:nvSpPr>
+          <p:cNvPr id="47" name="TextBox 46"/>
+          <p:cNvSpPr txBox="1"/>
+          <p:nvPr/>
+        </p:nvSpPr>
+        <p:spPr>
+          <a:xfrm>
+            <a:off x="8010144" y="4562855"/>
+            <a:ext cx="1234440" cy="182880"/>
+          </a:xfrm>
+          <a:prstGeom prst="rect">
+            <a:avLst/>
+          </a:prstGeom>
+          <a:noFill/>
+        </p:spPr>
+        <p:txBody>
+          <a:bodyPr wrap="square" lIns="0" rIns="0" tIns="0" bIns="0" anchor="t">
+            <a:spAutoFit/>
+          </a:bodyPr>
+          <a:lstStyle/>
+          <a:p>
+            <a:pPr algn="l">
+              <a:lnSpc>
+                <a:spcPct val="100000"/>
+              </a:lnSpc>
+            </a:pPr>
+            <a:r>
+              <a:rPr sz="819" b="1">
+                <a:solidFill>
+                  <a:srgbClr val="5C5C5C"/>
+                </a:solidFill>
+                <a:latin typeface="Arial"/>
+              </a:rPr>
+              <a:t>Fault injection</a:t>
+            </a:r>
+          </a:p>
+        </p:txBody>
+      </p:sp>
+      <p:sp>
+        <p:nvSpPr>
+          <p:cNvPr id="48" name="TextBox 47"/>
+          <p:cNvSpPr txBox="1"/>
+          <p:nvPr/>
+        </p:nvSpPr>
+        <p:spPr>
+          <a:xfrm>
+            <a:off x="9235440" y="4562855"/>
+            <a:ext cx="2578608" cy="182880"/>
+          </a:xfrm>
+          <a:prstGeom prst="rect">
+            <a:avLst/>
+          </a:prstGeom>
+          <a:noFill/>
+        </p:spPr>
+        <p:txBody>
+          <a:bodyPr wrap="square" lIns="0" rIns="0" tIns="0" bIns="0" anchor="t">
+            <a:spAutoFit/>
+          </a:bodyPr>
+          <a:lstStyle/>
+          <a:p>
+            <a:pPr algn="l">
+              <a:lnSpc>
+                <a:spcPct val="100000"/>
+              </a:lnSpc>
+            </a:pPr>
+            <a:r>
+              <a:rPr sz="860" b="0">
+                <a:solidFill>
+                  <a:srgbClr val="202020"/>
+                </a:solidFill>
+                <a:latin typeface="Arial"/>
+              </a:rPr>
+              <a:t>22.0 / 0 / 18.9 fps  ·  PASS</a:t>
+            </a:r>
+          </a:p>
+        </p:txBody>
+      </p:sp>
+      <p:sp>
+        <p:nvSpPr>
+          <p:cNvPr id="49" name="TextBox 48"/>
+          <p:cNvSpPr txBox="1"/>
+          <p:nvPr/>
+        </p:nvSpPr>
+        <p:spPr>
+          <a:xfrm>
+            <a:off x="7955279" y="5010912"/>
+            <a:ext cx="3931920" cy="201168"/>
+          </a:xfrm>
+          <a:prstGeom prst="rect">
+            <a:avLst/>
+          </a:prstGeom>
+          <a:noFill/>
+        </p:spPr>
+        <p:txBody>
+          <a:bodyPr wrap="square" lIns="0" rIns="0" tIns="0" bIns="0" anchor="t">
+            <a:spAutoFit/>
+          </a:bodyPr>
+          <a:lstStyle/>
+          <a:p>
+            <a:pPr algn="l">
+              <a:lnSpc>
+                <a:spcPct val="100000"/>
+              </a:lnSpc>
+            </a:pPr>
+            <a:r>
+              <a:rPr sz="1050" b="1">
+                <a:solidFill>
+                  <a:srgbClr val="7A2D5E"/>
+                </a:solidFill>
+                <a:latin typeface="Arial Black"/>
+              </a:rPr>
+              <a:t>OBSERVABILITY</a:t>
+            </a:r>
+          </a:p>
+        </p:txBody>
+      </p:sp>
+      <p:sp>
+        <p:nvSpPr>
+          <p:cNvPr id="50" name="TextBox 49"/>
+          <p:cNvSpPr txBox="1"/>
+          <p:nvPr/>
+        </p:nvSpPr>
+        <p:spPr>
+          <a:xfrm>
+            <a:off x="7955279" y="5248656"/>
+            <a:ext cx="3931920" cy="621792"/>
+          </a:xfrm>
+          <a:prstGeom prst="rect">
+            <a:avLst/>
+          </a:prstGeom>
+          <a:noFill/>
+        </p:spPr>
+        <p:txBody>
+          <a:bodyPr wrap="square" lIns="0" rIns="0" tIns="0" bIns="0" anchor="t">
+            <a:spAutoFit/>
+          </a:bodyPr>
+          <a:lstStyle/>
+          <a:p>
+            <a:pPr algn="l">
+              <a:lnSpc>
+                <a:spcPct val="100000"/>
+              </a:lnSpc>
+            </a:pPr>
+            <a:r>
+              <a:rPr sz="860" b="0">
+                <a:solidFill>
+                  <a:srgbClr val="202020"/>
+                </a:solidFill>
+                <a:latin typeface="Times New Roman"/>
+              </a:rPr>
+              <a:t>link / 1 Hz UDP telemetry: aborts, rows_max, stall, gap_min/max and pane_bad. The same counters are readable over UART, JTAG and the wire.</a:t>
+            </a:r>
+          </a:p>
+        </p:txBody>
+      </p:sp>
+      <p:sp>
+        <p:nvSpPr>
+          <p:cNvPr id="51" name="Rounded Rectangle 50"/>
+          <p:cNvSpPr/>
+          <p:nvPr/>
+        </p:nvSpPr>
+        <p:spPr>
+          <a:xfrm>
+            <a:off x="7955279" y="5989320"/>
+            <a:ext cx="3931920" cy="384048"/>
+          </a:xfrm>
+          <a:prstGeom prst="roundRect">
+            <a:avLst>
+              <a:gd name="adj" fmla="val 15000"/>
+            </a:avLst>
+          </a:prstGeom>
+          <a:solidFill>
+            <a:srgbClr val="F5ECF1"/>
+          </a:solidFill>
+          <a:ln w="11430">
+            <a:solidFill>
+              <a:srgbClr val="7A2D5E"/>
+            </a:solidFill>
+          </a:ln>
+        </p:spPr>
+        <p:style>
+          <a:lnRef idx="1">
+            <a:schemeClr val="accent1"/>
+          </a:lnRef>
+          <a:fillRef idx="3">
+            <a:schemeClr val="accent1"/>
+          </a:fillRef>
+          <a:effectRef idx="2">
+            <a:schemeClr val="accent1"/>
+          </a:effectRef>
+          <a:fontRef idx="minor">
+            <a:schemeClr val="lt1"/>
+          </a:fontRef>
+        </p:style>
+        <p:txBody>
+          <a:bodyPr rtlCol="0" anchor="ctr" lIns="109728" tIns="0" bIns="0"/>
+          <a:lstStyle/>
+          <a:p>
+            <a:pPr algn="ctr"/>
+            <a:r>
+              <a:rPr sz="900" b="1">
+                <a:solidFill>
+                  <a:srgbClr val="7A2D5E"/>
+                </a:solidFill>
+                <a:latin typeface="Arial"/>
+              </a:rPr>
+              <a:t>DROP 1 IN 100  -&gt;  ABORTS RISE  -&gt;  RECOVERY</a:t>
+            </a:r>
+          </a:p>
+        </p:txBody>
+      </p:sp>
+      <p:cxnSp>
+        <p:nvCxnSpPr>
+          <p:cNvPr id="52" name="Connector 51"/>
+          <p:cNvCxnSpPr/>
+          <p:nvPr/>
+        </p:nvCxnSpPr>
+        <p:spPr>
+          <a:xfrm>
+            <a:off x="274320" y="6565392"/>
+            <a:ext cx="11658600" cy="0"/>
+          </a:xfrm>
+          <a:prstGeom prst="line">
+            <a:avLst/>
+          </a:prstGeom>
+          <a:ln w="8890">
+            <a:solidFill>
+              <a:srgbClr val="BEBEBE"/>
+            </a:solidFill>
+          </a:ln>
+        </p:spPr>
+        <p:style>
+          <a:lnRef idx="2">
+            <a:schemeClr val="accent1"/>
+          </a:lnRef>
+          <a:fillRef idx="0">
+            <a:schemeClr val="accent1"/>
+          </a:fillRef>
+          <a:effectRef idx="1">
+            <a:schemeClr val="accent1"/>
+          </a:effectRef>
+          <a:fontRef idx="minor">
+            <a:schemeClr val="tx1"/>
+          </a:fontRef>
+        </p:style>
+      </p:cxnSp>
+      <p:sp>
+        <p:nvSpPr>
+          <p:cNvPr id="53" name="TextBox 52"/>
+          <p:cNvSpPr txBox="1"/>
+          <p:nvPr/>
+        </p:nvSpPr>
+        <p:spPr>
+          <a:xfrm>
+            <a:off x="274320" y="6611112"/>
+            <a:ext cx="8961120" cy="164592"/>
+          </a:xfrm>
+          <a:prstGeom prst="rect">
+            <a:avLst/>
+          </a:prstGeom>
+          <a:noFill/>
+        </p:spPr>
+        <p:txBody>
+          <a:bodyPr wrap="square" lIns="0" rIns="0" tIns="0" bIns="0" anchor="t">
+            <a:spAutoFit/>
+          </a:bodyPr>
+          <a:lstStyle/>
+          <a:p>
+            <a:pPr algn="l">
+              <a:lnSpc>
+                <a:spcPct val="100000"/>
+              </a:lnSpc>
+            </a:pPr>
+            <a:r>
+              <a:rPr sz="620" b="0">
+                <a:solidFill>
+                  <a:srgbClr val="5C5C5C"/>
+                </a:solidFill>
+                <a:latin typeface="Arial"/>
+              </a:rPr>
+              <a:t>AMD, the AMD Arrow logo and combinations thereof are trademarks of Advanced Micro Devices, Inc. Zynq is a trademark of AMD. All other trademarks are the property of their respective owners.</a:t>
+            </a:r>
+          </a:p>
+        </p:txBody>
+      </p:sp>
+      <p:pic>
+        <p:nvPicPr>
+          <p:cNvPr id="54" name="Picture 53" descr="amd_logo_black.png"/>
+          <p:cNvPicPr>
+            <a:picLocks noChangeAspect="1"/>
+          </p:cNvPicPr>
+          <p:nvPr/>
+        </p:nvPicPr>
+        <p:blipFill>
+          <a:blip r:embed="rId3"/>
+          <a:stretch>
+            <a:fillRect/>
+          </a:stretch>
+        </p:blipFill>
+        <p:spPr>
+          <a:xfrm>
+            <a:off x="11292840" y="6500358"/>
+            <a:ext cx="621792" cy="148355"/>
+          </a:xfrm>
+          <a:prstGeom prst="rect">
+            <a:avLst/>
+          </a:prstGeom>
+        </p:spPr>
+      </p:pic>
     </p:spTree>
   </p:cSld>
   <p:clrMapOvr>

</xml_diff>

<commit_message>
docs: rename project and update poster/team name
</commit_message>
<xml_diff>
--- a/prj_fin/deliverables/poster.pptx
+++ b/prj_fin/deliverables/poster.pptx
@@ -3122,7 +3122,7 @@
                 </a:solidFill>
                 <a:latin typeface="Arial"/>
               </a:rPr>
-              <a:t>(c) 2026 Uie  |  AMD FPGA Innovation Design Competition</a:t>
+              <a:t>(c) 2026 Uie_Team  |  AMD FPGA Innovation Design Competition</a:t>
             </a:r>
           </a:p>
         </p:txBody>
@@ -3239,7 +3239,7 @@
                 </a:solidFill>
                 <a:latin typeface="Microsoft YaHei"/>
               </a:rPr>
-              <a:t>多源视频流多效果变换处理系统</a:t>
+              <a:t>多源视频同帧对照处理系统</a:t>
             </a:r>
           </a:p>
         </p:txBody>
@@ -3278,7 +3278,7 @@
                 </a:solidFill>
                 <a:latin typeface="Times New Roman"/>
               </a:rPr>
-              <a:t>Team Member: </a:t>
+              <a:t>Team: </a:t>
             </a:r>
             <a:r>
               <a:rPr sz="1050" b="0">
@@ -3287,7 +3287,7 @@
                 </a:solidFill>
                 <a:latin typeface="Times New Roman"/>
               </a:rPr>
-              <a:t>Uie  ·  Hunan University of Technology (湖南工业大学), Hunan Province</a:t>
+              <a:t>Uie_Team  ·  Hunan University of Technology (湖南工业大学), Hunan Province</a:t>
             </a:r>
           </a:p>
         </p:txBody>

</xml_diff>

<commit_message>
poster: add member/advisor names, resources and conclusion
</commit_message>
<xml_diff>
--- a/prj_fin/deliverables/poster.pptx
+++ b/prj_fin/deliverables/poster.pptx
@@ -3252,8 +3252,8 @@
         </p:nvSpPr>
         <p:spPr>
           <a:xfrm>
-            <a:off x="402336" y="1307592"/>
-            <a:ext cx="7589520" cy="347472"/>
+            <a:off x="402336" y="1271016"/>
+            <a:ext cx="7589520" cy="210312"/>
           </a:xfrm>
           <a:prstGeom prst="rect">
             <a:avLst/>
@@ -3272,7 +3272,7 @@
               </a:lnSpc>
             </a:pPr>
             <a:r>
-              <a:rPr sz="1050" b="1">
+              <a:rPr sz="1000" b="1">
                 <a:solidFill>
                   <a:srgbClr val="202020"/>
                 </a:solidFill>
@@ -3281,20 +3281,68 @@
               <a:t>Team: </a:t>
             </a:r>
             <a:r>
-              <a:rPr sz="1050" b="0">
+              <a:rPr sz="1000" b="0">
                 <a:solidFill>
                   <a:srgbClr val="202020"/>
                 </a:solidFill>
                 <a:latin typeface="Times New Roman"/>
               </a:rPr>
-              <a:t>Uie_Team  ·  Hunan University of Technology (湖南工业大学), Hunan Province</a:t>
+              <a:t>Uie_Team  ·  Member: Wang Xu (王旭)</a:t>
+            </a:r>
+          </a:p>
+        </p:txBody>
+      </p:sp>
+      <p:sp>
+        <p:nvSpPr>
+          <p:cNvPr id="7" name="TextBox 6"/>
+          <p:cNvSpPr txBox="1"/>
+          <p:nvPr/>
+        </p:nvSpPr>
+        <p:spPr>
+          <a:xfrm>
+            <a:off x="402336" y="1490472"/>
+            <a:ext cx="7589520" cy="201168"/>
+          </a:xfrm>
+          <a:prstGeom prst="rect">
+            <a:avLst/>
+          </a:prstGeom>
+          <a:noFill/>
+        </p:spPr>
+        <p:txBody>
+          <a:bodyPr wrap="square" lIns="0" rIns="0" tIns="0" bIns="0" anchor="t">
+            <a:spAutoFit/>
+          </a:bodyPr>
+          <a:lstStyle/>
+          <a:p>
+            <a:pPr algn="l">
+              <a:lnSpc>
+                <a:spcPct val="100000"/>
+              </a:lnSpc>
+            </a:pPr>
+            <a:r>
+              <a:rPr sz="950" b="1">
+                <a:solidFill>
+                  <a:srgbClr val="202020"/>
+                </a:solidFill>
+                <a:latin typeface="Times New Roman"/>
+              </a:rPr>
+              <a:t>Advisors: </a:t>
+            </a:r>
+            <a:r>
+              <a:rPr sz="950" b="0">
+                <a:solidFill>
+                  <a:srgbClr val="202020"/>
+                </a:solidFill>
+                <a:latin typeface="Times New Roman"/>
+              </a:rPr>
+              <a:t>Tan Huisheng (谭会生), Liang Jiaojiao (梁娇娇)</a:t>
             </a:r>
           </a:p>
         </p:txBody>
       </p:sp>
       <p:pic>
         <p:nvPicPr>
-          <p:cNvPr id="7" name="Picture 6" descr="hut_emblem.png"/>
+          <p:cNvPr id="8" name="Picture 7" descr="hut_emblem.png"/>
           <p:cNvPicPr>
             <a:picLocks noChangeAspect="1"/>
           </p:cNvPicPr>
@@ -3318,7 +3366,7 @@
       </p:pic>
       <p:sp>
         <p:nvSpPr>
-          <p:cNvPr id="8" name="TextBox 7"/>
+          <p:cNvPr id="9" name="TextBox 8"/>
           <p:cNvSpPr txBox="1"/>
           <p:nvPr/>
         </p:nvSpPr>
@@ -3357,7 +3405,7 @@
       </p:sp>
       <p:sp>
         <p:nvSpPr>
-          <p:cNvPr id="9" name="TextBox 8"/>
+          <p:cNvPr id="10" name="TextBox 9"/>
           <p:cNvSpPr txBox="1"/>
           <p:nvPr/>
         </p:nvSpPr>
@@ -3397,7 +3445,7 @@
       </p:sp>
       <p:pic>
         <p:nvPicPr>
-          <p:cNvPr id="10" name="Picture 9" descr="amd_logo_black.png"/>
+          <p:cNvPr id="11" name="Picture 10" descr="amd_logo_black.png"/>
           <p:cNvPicPr>
             <a:picLocks noChangeAspect="1"/>
           </p:cNvPicPr>
@@ -3421,7 +3469,7 @@
       </p:pic>
       <p:sp>
         <p:nvSpPr>
-          <p:cNvPr id="11" name="TextBox 10"/>
+          <p:cNvPr id="12" name="TextBox 11"/>
           <p:cNvSpPr txBox="1"/>
           <p:nvPr/>
         </p:nvSpPr>
@@ -3460,7 +3508,7 @@
       </p:sp>
       <p:pic>
         <p:nvPicPr>
-          <p:cNvPr id="12" name="Picture 11" descr="poster_board.jpg"/>
+          <p:cNvPr id="13" name="Picture 12" descr="poster_board.jpg"/>
           <p:cNvPicPr>
             <a:picLocks noChangeAspect="1"/>
           </p:cNvPicPr>
@@ -3484,7 +3532,7 @@
       </p:pic>
       <p:sp>
         <p:nvSpPr>
-          <p:cNvPr id="13" name="TextBox 12"/>
+          <p:cNvPr id="14" name="TextBox 13"/>
           <p:cNvSpPr txBox="1"/>
           <p:nvPr/>
         </p:nvSpPr>
@@ -3524,7 +3572,7 @@
       </p:sp>
       <p:cxnSp>
         <p:nvCxnSpPr>
-          <p:cNvPr id="14" name="Connector 13"/>
+          <p:cNvPr id="15" name="Connector 14"/>
           <p:cNvCxnSpPr/>
           <p:nvPr/>
         </p:nvCxnSpPr>
@@ -3559,7 +3607,7 @@
       </p:cxnSp>
       <p:sp>
         <p:nvSpPr>
-          <p:cNvPr id="15" name="Rectangle 14"/>
+          <p:cNvPr id="16" name="Rectangle 15"/>
           <p:cNvSpPr/>
           <p:nvPr/>
         </p:nvSpPr>
@@ -3611,7 +3659,7 @@
       </p:sp>
       <p:sp>
         <p:nvSpPr>
-          <p:cNvPr id="16" name="TextBox 15"/>
+          <p:cNvPr id="17" name="TextBox 16"/>
           <p:cNvSpPr txBox="1"/>
           <p:nvPr/>
         </p:nvSpPr>
@@ -3650,7 +3698,7 @@
       </p:sp>
       <p:pic>
         <p:nvPicPr>
-          <p:cNvPr id="17" name="Picture 16" descr="poster_frame_split.png"/>
+          <p:cNvPr id="18" name="Picture 17" descr="poster_frame_split.png"/>
           <p:cNvPicPr>
             <a:picLocks noChangeAspect="1"/>
           </p:cNvPicPr>
@@ -3674,7 +3722,7 @@
       </p:pic>
       <p:sp>
         <p:nvSpPr>
-          <p:cNvPr id="18" name="TextBox 17"/>
+          <p:cNvPr id="19" name="TextBox 18"/>
           <p:cNvSpPr txBox="1"/>
           <p:nvPr/>
         </p:nvSpPr>
@@ -3713,7 +3761,7 @@
       </p:sp>
       <p:sp>
         <p:nvSpPr>
-          <p:cNvPr id="19" name="TextBox 18"/>
+          <p:cNvPr id="20" name="TextBox 19"/>
           <p:cNvSpPr txBox="1"/>
           <p:nvPr/>
         </p:nvSpPr>
@@ -3752,7 +3800,7 @@
       </p:sp>
       <p:sp>
         <p:nvSpPr>
-          <p:cNvPr id="20" name="TextBox 19"/>
+          <p:cNvPr id="21" name="TextBox 20"/>
           <p:cNvSpPr txBox="1"/>
           <p:nvPr/>
         </p:nvSpPr>
@@ -3793,7 +3841,7 @@
       </p:sp>
       <p:sp>
         <p:nvSpPr>
-          <p:cNvPr id="21" name="Rectangle 20"/>
+          <p:cNvPr id="22" name="Rectangle 21"/>
           <p:cNvSpPr/>
           <p:nvPr/>
         </p:nvSpPr>
@@ -3845,7 +3893,7 @@
       </p:sp>
       <p:pic>
         <p:nvPicPr>
-          <p:cNvPr id="22" name="Picture 21" descr="poster_arch.png"/>
+          <p:cNvPr id="23" name="Picture 22" descr="poster_arch.png"/>
           <p:cNvPicPr>
             <a:picLocks noChangeAspect="1"/>
           </p:cNvPicPr>
@@ -3869,7 +3917,7 @@
       </p:pic>
       <p:sp>
         <p:nvSpPr>
-          <p:cNvPr id="23" name="TextBox 22"/>
+          <p:cNvPr id="24" name="TextBox 23"/>
           <p:cNvSpPr txBox="1"/>
           <p:nvPr/>
         </p:nvSpPr>
@@ -3908,7 +3956,7 @@
       </p:sp>
       <p:sp>
         <p:nvSpPr>
-          <p:cNvPr id="24" name="Rounded Rectangle 23"/>
+          <p:cNvPr id="25" name="Rounded Rectangle 24"/>
           <p:cNvSpPr/>
           <p:nvPr/>
         </p:nvSpPr>
@@ -3984,7 +4032,7 @@
       </p:sp>
       <p:sp>
         <p:nvSpPr>
-          <p:cNvPr id="25" name="Rounded Rectangle 24"/>
+          <p:cNvPr id="26" name="Rounded Rectangle 25"/>
           <p:cNvSpPr/>
           <p:nvPr/>
         </p:nvSpPr>
@@ -4060,7 +4108,7 @@
       </p:sp>
       <p:sp>
         <p:nvSpPr>
-          <p:cNvPr id="26" name="Rectangle 25"/>
+          <p:cNvPr id="27" name="Rectangle 26"/>
           <p:cNvSpPr/>
           <p:nvPr/>
         </p:nvSpPr>
@@ -4112,7 +4160,7 @@
       </p:sp>
       <p:sp>
         <p:nvSpPr>
-          <p:cNvPr id="27" name="TextBox 26"/>
+          <p:cNvPr id="28" name="TextBox 27"/>
           <p:cNvSpPr txBox="1"/>
           <p:nvPr/>
         </p:nvSpPr>
@@ -4151,14 +4199,14 @@
       </p:sp>
       <p:sp>
         <p:nvSpPr>
-          <p:cNvPr id="28" name="Rectangle 27"/>
+          <p:cNvPr id="29" name="Rectangle 28"/>
           <p:cNvSpPr/>
           <p:nvPr/>
         </p:nvSpPr>
         <p:spPr>
           <a:xfrm>
             <a:off x="7955279" y="2880360"/>
-            <a:ext cx="3931920" cy="256032"/>
+            <a:ext cx="3931920" cy="228600"/>
           </a:xfrm>
           <a:prstGeom prst="rect">
             <a:avLst/>
@@ -4194,14 +4242,14 @@
       </p:sp>
       <p:sp>
         <p:nvSpPr>
-          <p:cNvPr id="29" name="TextBox 28"/>
+          <p:cNvPr id="30" name="TextBox 29"/>
           <p:cNvSpPr txBox="1"/>
           <p:nvPr/>
         </p:nvSpPr>
         <p:spPr>
           <a:xfrm>
-            <a:off x="8010144" y="2916936"/>
-            <a:ext cx="1234440" cy="182880"/>
+            <a:off x="8010144" y="2907791"/>
+            <a:ext cx="1234440" cy="173736"/>
           </a:xfrm>
           <a:prstGeom prst="rect">
             <a:avLst/>
@@ -4220,7 +4268,7 @@
               </a:lnSpc>
             </a:pPr>
             <a:r>
-              <a:rPr sz="819" b="1">
+              <a:rPr sz="800" b="1">
                 <a:solidFill>
                   <a:srgbClr val="5C5C5C"/>
                 </a:solidFill>
@@ -4233,14 +4281,14 @@
       </p:sp>
       <p:sp>
         <p:nvSpPr>
-          <p:cNvPr id="30" name="TextBox 29"/>
+          <p:cNvPr id="31" name="TextBox 30"/>
           <p:cNvSpPr txBox="1"/>
           <p:nvPr/>
         </p:nvSpPr>
         <p:spPr>
           <a:xfrm>
-            <a:off x="9235440" y="2916936"/>
-            <a:ext cx="2578608" cy="182880"/>
+            <a:off x="9235440" y="2907791"/>
+            <a:ext cx="2578608" cy="173736"/>
           </a:xfrm>
           <a:prstGeom prst="rect">
             <a:avLst/>
@@ -4259,7 +4307,7 @@
               </a:lnSpc>
             </a:pPr>
             <a:r>
-              <a:rPr sz="860" b="0">
+              <a:rPr sz="840" b="0">
                 <a:solidFill>
                   <a:srgbClr val="202020"/>
                 </a:solidFill>
@@ -4272,14 +4320,14 @@
       </p:sp>
       <p:sp>
         <p:nvSpPr>
-          <p:cNvPr id="31" name="Rectangle 30"/>
+          <p:cNvPr id="32" name="Rectangle 31"/>
           <p:cNvSpPr/>
           <p:nvPr/>
         </p:nvSpPr>
         <p:spPr>
           <a:xfrm>
-            <a:off x="7955279" y="3154679"/>
-            <a:ext cx="3931920" cy="256032"/>
+            <a:off x="7955279" y="3127248"/>
+            <a:ext cx="3931920" cy="228600"/>
           </a:xfrm>
           <a:prstGeom prst="rect">
             <a:avLst/>
@@ -4315,14 +4363,14 @@
       </p:sp>
       <p:sp>
         <p:nvSpPr>
-          <p:cNvPr id="32" name="TextBox 31"/>
+          <p:cNvPr id="33" name="TextBox 32"/>
           <p:cNvSpPr txBox="1"/>
           <p:nvPr/>
         </p:nvSpPr>
         <p:spPr>
           <a:xfrm>
-            <a:off x="8010144" y="3191256"/>
-            <a:ext cx="1234440" cy="182880"/>
+            <a:off x="8010144" y="3154679"/>
+            <a:ext cx="1234440" cy="173736"/>
           </a:xfrm>
           <a:prstGeom prst="rect">
             <a:avLst/>
@@ -4341,7 +4389,7 @@
               </a:lnSpc>
             </a:pPr>
             <a:r>
-              <a:rPr sz="819" b="1">
+              <a:rPr sz="800" b="1">
                 <a:solidFill>
                   <a:srgbClr val="5C5C5C"/>
                 </a:solidFill>
@@ -4354,14 +4402,14 @@
       </p:sp>
       <p:sp>
         <p:nvSpPr>
-          <p:cNvPr id="33" name="TextBox 32"/>
+          <p:cNvPr id="34" name="TextBox 33"/>
           <p:cNvSpPr txBox="1"/>
           <p:nvPr/>
         </p:nvSpPr>
         <p:spPr>
           <a:xfrm>
-            <a:off x="9235440" y="3191256"/>
-            <a:ext cx="2578608" cy="182880"/>
+            <a:off x="9235440" y="3154679"/>
+            <a:ext cx="2578608" cy="173736"/>
           </a:xfrm>
           <a:prstGeom prst="rect">
             <a:avLst/>
@@ -4380,7 +4428,7 @@
               </a:lnSpc>
             </a:pPr>
             <a:r>
-              <a:rPr sz="860" b="0">
+              <a:rPr sz="840" b="0">
                 <a:solidFill>
                   <a:srgbClr val="202020"/>
                 </a:solidFill>
@@ -4393,14 +4441,14 @@
       </p:sp>
       <p:sp>
         <p:nvSpPr>
-          <p:cNvPr id="34" name="Rectangle 33"/>
+          <p:cNvPr id="35" name="Rectangle 34"/>
           <p:cNvSpPr/>
           <p:nvPr/>
         </p:nvSpPr>
         <p:spPr>
           <a:xfrm>
-            <a:off x="7955279" y="3429000"/>
-            <a:ext cx="3931920" cy="256032"/>
+            <a:off x="7955279" y="3374136"/>
+            <a:ext cx="3931920" cy="228600"/>
           </a:xfrm>
           <a:prstGeom prst="rect">
             <a:avLst/>
@@ -4436,14 +4484,14 @@
       </p:sp>
       <p:sp>
         <p:nvSpPr>
-          <p:cNvPr id="35" name="TextBox 34"/>
+          <p:cNvPr id="36" name="TextBox 35"/>
           <p:cNvSpPr txBox="1"/>
           <p:nvPr/>
         </p:nvSpPr>
         <p:spPr>
           <a:xfrm>
-            <a:off x="8010144" y="3465576"/>
-            <a:ext cx="1234440" cy="182880"/>
+            <a:off x="8010144" y="3401568"/>
+            <a:ext cx="1234440" cy="173736"/>
           </a:xfrm>
           <a:prstGeom prst="rect">
             <a:avLst/>
@@ -4462,7 +4510,7 @@
               </a:lnSpc>
             </a:pPr>
             <a:r>
-              <a:rPr sz="819" b="1">
+              <a:rPr sz="800" b="1">
                 <a:solidFill>
                   <a:srgbClr val="5C5C5C"/>
                 </a:solidFill>
@@ -4475,14 +4523,14 @@
       </p:sp>
       <p:sp>
         <p:nvSpPr>
-          <p:cNvPr id="36" name="TextBox 35"/>
+          <p:cNvPr id="37" name="TextBox 36"/>
           <p:cNvSpPr txBox="1"/>
           <p:nvPr/>
         </p:nvSpPr>
         <p:spPr>
           <a:xfrm>
-            <a:off x="9235440" y="3465576"/>
-            <a:ext cx="2578608" cy="182880"/>
+            <a:off x="9235440" y="3401568"/>
+            <a:ext cx="2578608" cy="173736"/>
           </a:xfrm>
           <a:prstGeom prst="rect">
             <a:avLst/>
@@ -4501,7 +4549,7 @@
               </a:lnSpc>
             </a:pPr>
             <a:r>
-              <a:rPr sz="860" b="0">
+              <a:rPr sz="840" b="0">
                 <a:solidFill>
                   <a:srgbClr val="202020"/>
                 </a:solidFill>
@@ -4514,14 +4562,14 @@
       </p:sp>
       <p:sp>
         <p:nvSpPr>
-          <p:cNvPr id="37" name="Rectangle 36"/>
+          <p:cNvPr id="38" name="Rectangle 37"/>
           <p:cNvSpPr/>
           <p:nvPr/>
         </p:nvSpPr>
         <p:spPr>
           <a:xfrm>
-            <a:off x="7955279" y="3703320"/>
-            <a:ext cx="3931920" cy="256032"/>
+            <a:off x="7955279" y="3621024"/>
+            <a:ext cx="3931920" cy="228600"/>
           </a:xfrm>
           <a:prstGeom prst="rect">
             <a:avLst/>
@@ -4557,14 +4605,14 @@
       </p:sp>
       <p:sp>
         <p:nvSpPr>
-          <p:cNvPr id="38" name="TextBox 37"/>
+          <p:cNvPr id="39" name="TextBox 38"/>
           <p:cNvSpPr txBox="1"/>
           <p:nvPr/>
         </p:nvSpPr>
         <p:spPr>
           <a:xfrm>
-            <a:off x="8010144" y="3739896"/>
-            <a:ext cx="1234440" cy="182880"/>
+            <a:off x="8010144" y="3648456"/>
+            <a:ext cx="1234440" cy="173736"/>
           </a:xfrm>
           <a:prstGeom prst="rect">
             <a:avLst/>
@@ -4583,7 +4631,7 @@
               </a:lnSpc>
             </a:pPr>
             <a:r>
-              <a:rPr sz="819" b="1">
+              <a:rPr sz="800" b="1">
                 <a:solidFill>
                   <a:srgbClr val="5C5C5C"/>
                 </a:solidFill>
@@ -4596,14 +4644,14 @@
       </p:sp>
       <p:sp>
         <p:nvSpPr>
-          <p:cNvPr id="39" name="TextBox 38"/>
+          <p:cNvPr id="40" name="TextBox 39"/>
           <p:cNvSpPr txBox="1"/>
           <p:nvPr/>
         </p:nvSpPr>
         <p:spPr>
           <a:xfrm>
-            <a:off x="9235440" y="3739896"/>
-            <a:ext cx="2578608" cy="182880"/>
+            <a:off x="9235440" y="3648456"/>
+            <a:ext cx="2578608" cy="173736"/>
           </a:xfrm>
           <a:prstGeom prst="rect">
             <a:avLst/>
@@ -4622,7 +4670,7 @@
               </a:lnSpc>
             </a:pPr>
             <a:r>
-              <a:rPr sz="860" b="0">
+              <a:rPr sz="840" b="0">
                 <a:solidFill>
                   <a:srgbClr val="202020"/>
                 </a:solidFill>
@@ -4635,14 +4683,14 @@
       </p:sp>
       <p:sp>
         <p:nvSpPr>
-          <p:cNvPr id="40" name="Rectangle 39"/>
+          <p:cNvPr id="41" name="Rectangle 40"/>
           <p:cNvSpPr/>
           <p:nvPr/>
         </p:nvSpPr>
         <p:spPr>
           <a:xfrm>
-            <a:off x="7955279" y="3977639"/>
-            <a:ext cx="3931920" cy="256032"/>
+            <a:off x="7955279" y="3867912"/>
+            <a:ext cx="3931920" cy="228600"/>
           </a:xfrm>
           <a:prstGeom prst="rect">
             <a:avLst/>
@@ -4678,14 +4726,14 @@
       </p:sp>
       <p:sp>
         <p:nvSpPr>
-          <p:cNvPr id="41" name="TextBox 40"/>
+          <p:cNvPr id="42" name="TextBox 41"/>
           <p:cNvSpPr txBox="1"/>
           <p:nvPr/>
         </p:nvSpPr>
         <p:spPr>
           <a:xfrm>
-            <a:off x="8010144" y="4014215"/>
-            <a:ext cx="1234440" cy="182880"/>
+            <a:off x="8010144" y="3895344"/>
+            <a:ext cx="1234440" cy="173736"/>
           </a:xfrm>
           <a:prstGeom prst="rect">
             <a:avLst/>
@@ -4704,7 +4752,7 @@
               </a:lnSpc>
             </a:pPr>
             <a:r>
-              <a:rPr sz="819" b="1">
+              <a:rPr sz="800" b="1">
                 <a:solidFill>
                   <a:srgbClr val="5C5C5C"/>
                 </a:solidFill>
@@ -4717,14 +4765,14 @@
       </p:sp>
       <p:sp>
         <p:nvSpPr>
-          <p:cNvPr id="42" name="TextBox 41"/>
+          <p:cNvPr id="43" name="TextBox 42"/>
           <p:cNvSpPr txBox="1"/>
           <p:nvPr/>
         </p:nvSpPr>
         <p:spPr>
           <a:xfrm>
-            <a:off x="9235440" y="4014215"/>
-            <a:ext cx="2578608" cy="182880"/>
+            <a:off x="9235440" y="3895344"/>
+            <a:ext cx="2578608" cy="173736"/>
           </a:xfrm>
           <a:prstGeom prst="rect">
             <a:avLst/>
@@ -4743,7 +4791,7 @@
               </a:lnSpc>
             </a:pPr>
             <a:r>
-              <a:rPr sz="860" b="0">
+              <a:rPr sz="840" b="0">
                 <a:solidFill>
                   <a:srgbClr val="202020"/>
                 </a:solidFill>
@@ -4756,14 +4804,14 @@
       </p:sp>
       <p:sp>
         <p:nvSpPr>
-          <p:cNvPr id="43" name="Rectangle 42"/>
+          <p:cNvPr id="44" name="Rectangle 43"/>
           <p:cNvSpPr/>
           <p:nvPr/>
         </p:nvSpPr>
         <p:spPr>
           <a:xfrm>
-            <a:off x="7955279" y="4251960"/>
-            <a:ext cx="3931920" cy="256032"/>
+            <a:off x="7955279" y="4114800"/>
+            <a:ext cx="3931920" cy="228600"/>
           </a:xfrm>
           <a:prstGeom prst="rect">
             <a:avLst/>
@@ -4799,14 +4847,14 @@
       </p:sp>
       <p:sp>
         <p:nvSpPr>
-          <p:cNvPr id="44" name="TextBox 43"/>
+          <p:cNvPr id="45" name="TextBox 44"/>
           <p:cNvSpPr txBox="1"/>
           <p:nvPr/>
         </p:nvSpPr>
         <p:spPr>
           <a:xfrm>
-            <a:off x="8010144" y="4288536"/>
-            <a:ext cx="1234440" cy="182880"/>
+            <a:off x="8010144" y="4142232"/>
+            <a:ext cx="1234440" cy="173736"/>
           </a:xfrm>
           <a:prstGeom prst="rect">
             <a:avLst/>
@@ -4825,7 +4873,7 @@
               </a:lnSpc>
             </a:pPr>
             <a:r>
-              <a:rPr sz="819" b="1">
+              <a:rPr sz="800" b="1">
                 <a:solidFill>
                   <a:srgbClr val="5C5C5C"/>
                 </a:solidFill>
@@ -4838,14 +4886,14 @@
       </p:sp>
       <p:sp>
         <p:nvSpPr>
-          <p:cNvPr id="45" name="TextBox 44"/>
+          <p:cNvPr id="46" name="TextBox 45"/>
           <p:cNvSpPr txBox="1"/>
           <p:nvPr/>
         </p:nvSpPr>
         <p:spPr>
           <a:xfrm>
-            <a:off x="9235440" y="4288536"/>
-            <a:ext cx="2578608" cy="182880"/>
+            <a:off x="9235440" y="4142232"/>
+            <a:ext cx="2578608" cy="173736"/>
           </a:xfrm>
           <a:prstGeom prst="rect">
             <a:avLst/>
@@ -4864,7 +4912,7 @@
               </a:lnSpc>
             </a:pPr>
             <a:r>
-              <a:rPr sz="860" b="0">
+              <a:rPr sz="840" b="0">
                 <a:solidFill>
                   <a:srgbClr val="202020"/>
                 </a:solidFill>
@@ -4877,14 +4925,14 @@
       </p:sp>
       <p:sp>
         <p:nvSpPr>
-          <p:cNvPr id="46" name="Rectangle 45"/>
+          <p:cNvPr id="47" name="Rectangle 46"/>
           <p:cNvSpPr/>
           <p:nvPr/>
         </p:nvSpPr>
         <p:spPr>
           <a:xfrm>
-            <a:off x="7955279" y="4526279"/>
-            <a:ext cx="3931920" cy="256032"/>
+            <a:off x="7955279" y="4361688"/>
+            <a:ext cx="3931920" cy="228600"/>
           </a:xfrm>
           <a:prstGeom prst="rect">
             <a:avLst/>
@@ -4920,14 +4968,14 @@
       </p:sp>
       <p:sp>
         <p:nvSpPr>
-          <p:cNvPr id="47" name="TextBox 46"/>
+          <p:cNvPr id="48" name="TextBox 47"/>
           <p:cNvSpPr txBox="1"/>
           <p:nvPr/>
         </p:nvSpPr>
         <p:spPr>
           <a:xfrm>
-            <a:off x="8010144" y="4562855"/>
-            <a:ext cx="1234440" cy="182880"/>
+            <a:off x="8010144" y="4389120"/>
+            <a:ext cx="1234440" cy="173736"/>
           </a:xfrm>
           <a:prstGeom prst="rect">
             <a:avLst/>
@@ -4946,7 +4994,7 @@
               </a:lnSpc>
             </a:pPr>
             <a:r>
-              <a:rPr sz="819" b="1">
+              <a:rPr sz="800" b="1">
                 <a:solidFill>
                   <a:srgbClr val="5C5C5C"/>
                 </a:solidFill>
@@ -4959,14 +5007,14 @@
       </p:sp>
       <p:sp>
         <p:nvSpPr>
-          <p:cNvPr id="48" name="TextBox 47"/>
+          <p:cNvPr id="49" name="TextBox 48"/>
           <p:cNvSpPr txBox="1"/>
           <p:nvPr/>
         </p:nvSpPr>
         <p:spPr>
           <a:xfrm>
-            <a:off x="9235440" y="4562855"/>
-            <a:ext cx="2578608" cy="182880"/>
+            <a:off x="9235440" y="4389120"/>
+            <a:ext cx="2578608" cy="173736"/>
           </a:xfrm>
           <a:prstGeom prst="rect">
             <a:avLst/>
@@ -4985,7 +5033,7 @@
               </a:lnSpc>
             </a:pPr>
             <a:r>
-              <a:rPr sz="860" b="0">
+              <a:rPr sz="840" b="0">
                 <a:solidFill>
                   <a:srgbClr val="202020"/>
                 </a:solidFill>
@@ -4998,105 +5046,23 @@
       </p:sp>
       <p:sp>
         <p:nvSpPr>
-          <p:cNvPr id="49" name="TextBox 48"/>
-          <p:cNvSpPr txBox="1"/>
-          <p:nvPr/>
-        </p:nvSpPr>
-        <p:spPr>
-          <a:xfrm>
-            <a:off x="7955279" y="5010912"/>
-            <a:ext cx="3931920" cy="201168"/>
-          </a:xfrm>
-          <a:prstGeom prst="rect">
-            <a:avLst/>
-          </a:prstGeom>
-          <a:noFill/>
-        </p:spPr>
-        <p:txBody>
-          <a:bodyPr wrap="square" lIns="0" rIns="0" tIns="0" bIns="0" anchor="t">
-            <a:spAutoFit/>
-          </a:bodyPr>
-          <a:lstStyle/>
-          <a:p>
-            <a:pPr algn="l">
-              <a:lnSpc>
-                <a:spcPct val="100000"/>
-              </a:lnSpc>
-            </a:pPr>
-            <a:r>
-              <a:rPr sz="1050" b="1">
-                <a:solidFill>
-                  <a:srgbClr val="7A2D5E"/>
-                </a:solidFill>
-                <a:latin typeface="Arial Black"/>
-              </a:rPr>
-              <a:t>OBSERVABILITY</a:t>
-            </a:r>
-          </a:p>
-        </p:txBody>
-      </p:sp>
-      <p:sp>
-        <p:nvSpPr>
-          <p:cNvPr id="50" name="TextBox 49"/>
-          <p:cNvSpPr txBox="1"/>
-          <p:nvPr/>
-        </p:nvSpPr>
-        <p:spPr>
-          <a:xfrm>
-            <a:off x="7955279" y="5248656"/>
-            <a:ext cx="3931920" cy="621792"/>
-          </a:xfrm>
-          <a:prstGeom prst="rect">
-            <a:avLst/>
-          </a:prstGeom>
-          <a:noFill/>
-        </p:spPr>
-        <p:txBody>
-          <a:bodyPr wrap="square" lIns="0" rIns="0" tIns="0" bIns="0" anchor="t">
-            <a:spAutoFit/>
-          </a:bodyPr>
-          <a:lstStyle/>
-          <a:p>
-            <a:pPr algn="l">
-              <a:lnSpc>
-                <a:spcPct val="100000"/>
-              </a:lnSpc>
-            </a:pPr>
-            <a:r>
-              <a:rPr sz="860" b="0">
-                <a:solidFill>
-                  <a:srgbClr val="202020"/>
-                </a:solidFill>
-                <a:latin typeface="Times New Roman"/>
-              </a:rPr>
-              <a:t>link / 1 Hz UDP telemetry: aborts, rows_max, stall, gap_min/max and pane_bad. The same counters are readable over UART, JTAG and the wire.</a:t>
-            </a:r>
-          </a:p>
-        </p:txBody>
-      </p:sp>
-      <p:sp>
-        <p:nvSpPr>
-          <p:cNvPr id="51" name="Rounded Rectangle 50"/>
+          <p:cNvPr id="50" name="Rectangle 49"/>
           <p:cNvSpPr/>
           <p:nvPr/>
         </p:nvSpPr>
         <p:spPr>
           <a:xfrm>
-            <a:off x="7955279" y="5989320"/>
-            <a:ext cx="3931920" cy="384048"/>
-          </a:xfrm>
-          <a:prstGeom prst="roundRect">
-            <a:avLst>
-              <a:gd name="adj" fmla="val 15000"/>
-            </a:avLst>
+            <a:off x="7955279" y="4608576"/>
+            <a:ext cx="3931920" cy="228600"/>
+          </a:xfrm>
+          <a:prstGeom prst="rect">
+            <a:avLst/>
           </a:prstGeom>
           <a:solidFill>
-            <a:srgbClr val="F5ECF1"/>
+            <a:srgbClr val="FFFFFF"/>
           </a:solidFill>
-          <a:ln w="11430">
-            <a:solidFill>
-              <a:srgbClr val="7A2D5E"/>
-            </a:solidFill>
+          <a:ln>
+            <a:noFill/>
           </a:ln>
         </p:spPr>
         <p:style>
@@ -5114,12 +5080,215 @@
           </a:fontRef>
         </p:style>
         <p:txBody>
+          <a:bodyPr rtlCol="0" anchor="ctr"/>
+          <a:lstStyle/>
+          <a:p>
+            <a:pPr algn="ctr"/>
+          </a:p>
+        </p:txBody>
+      </p:sp>
+      <p:sp>
+        <p:nvSpPr>
+          <p:cNvPr id="51" name="TextBox 50"/>
+          <p:cNvSpPr txBox="1"/>
+          <p:nvPr/>
+        </p:nvSpPr>
+        <p:spPr>
+          <a:xfrm>
+            <a:off x="8010144" y="4636008"/>
+            <a:ext cx="1234440" cy="173736"/>
+          </a:xfrm>
+          <a:prstGeom prst="rect">
+            <a:avLst/>
+          </a:prstGeom>
+          <a:noFill/>
+        </p:spPr>
+        <p:txBody>
+          <a:bodyPr wrap="square" lIns="0" rIns="0" tIns="0" bIns="0" anchor="t">
+            <a:spAutoFit/>
+          </a:bodyPr>
+          <a:lstStyle/>
+          <a:p>
+            <a:pPr algn="l">
+              <a:lnSpc>
+                <a:spcPct val="100000"/>
+              </a:lnSpc>
+            </a:pPr>
+            <a:r>
+              <a:rPr sz="800" b="1">
+                <a:solidFill>
+                  <a:srgbClr val="5C5C5C"/>
+                </a:solidFill>
+                <a:latin typeface="Arial"/>
+              </a:rPr>
+              <a:t>LUT / FF / DSP</a:t>
+            </a:r>
+          </a:p>
+        </p:txBody>
+      </p:sp>
+      <p:sp>
+        <p:nvSpPr>
+          <p:cNvPr id="52" name="TextBox 51"/>
+          <p:cNvSpPr txBox="1"/>
+          <p:nvPr/>
+        </p:nvSpPr>
+        <p:spPr>
+          <a:xfrm>
+            <a:off x="9235440" y="4636008"/>
+            <a:ext cx="2578608" cy="173736"/>
+          </a:xfrm>
+          <a:prstGeom prst="rect">
+            <a:avLst/>
+          </a:prstGeom>
+          <a:noFill/>
+        </p:spPr>
+        <p:txBody>
+          <a:bodyPr wrap="square" lIns="0" rIns="0" tIns="0" bIns="0" anchor="t">
+            <a:spAutoFit/>
+          </a:bodyPr>
+          <a:lstStyle/>
+          <a:p>
+            <a:pPr algn="l">
+              <a:lnSpc>
+                <a:spcPct val="100000"/>
+              </a:lnSpc>
+            </a:pPr>
+            <a:r>
+              <a:rPr sz="840" b="0">
+                <a:solidFill>
+                  <a:srgbClr val="202020"/>
+                </a:solidFill>
+                <a:latin typeface="Arial"/>
+              </a:rPr>
+              <a:t>28.13 / 8.55 / 8.64 %</a:t>
+            </a:r>
+          </a:p>
+        </p:txBody>
+      </p:sp>
+      <p:sp>
+        <p:nvSpPr>
+          <p:cNvPr id="53" name="TextBox 52"/>
+          <p:cNvSpPr txBox="1"/>
+          <p:nvPr/>
+        </p:nvSpPr>
+        <p:spPr>
+          <a:xfrm>
+            <a:off x="7955279" y="4965192"/>
+            <a:ext cx="3931920" cy="201168"/>
+          </a:xfrm>
+          <a:prstGeom prst="rect">
+            <a:avLst/>
+          </a:prstGeom>
+          <a:noFill/>
+        </p:spPr>
+        <p:txBody>
+          <a:bodyPr wrap="square" lIns="0" rIns="0" tIns="0" bIns="0" anchor="t">
+            <a:spAutoFit/>
+          </a:bodyPr>
+          <a:lstStyle/>
+          <a:p>
+            <a:pPr algn="l">
+              <a:lnSpc>
+                <a:spcPct val="100000"/>
+              </a:lnSpc>
+            </a:pPr>
+            <a:r>
+              <a:rPr sz="1050" b="1">
+                <a:solidFill>
+                  <a:srgbClr val="7A2D5E"/>
+                </a:solidFill>
+                <a:latin typeface="Arial Black"/>
+              </a:rPr>
+              <a:t>OBSERVABILITY</a:t>
+            </a:r>
+          </a:p>
+        </p:txBody>
+      </p:sp>
+      <p:sp>
+        <p:nvSpPr>
+          <p:cNvPr id="54" name="TextBox 53"/>
+          <p:cNvSpPr txBox="1"/>
+          <p:nvPr/>
+        </p:nvSpPr>
+        <p:spPr>
+          <a:xfrm>
+            <a:off x="7955279" y="5193792"/>
+            <a:ext cx="3931920" cy="530352"/>
+          </a:xfrm>
+          <a:prstGeom prst="rect">
+            <a:avLst/>
+          </a:prstGeom>
+          <a:noFill/>
+        </p:spPr>
+        <p:txBody>
+          <a:bodyPr wrap="square" lIns="0" rIns="0" tIns="0" bIns="0" anchor="t">
+            <a:spAutoFit/>
+          </a:bodyPr>
+          <a:lstStyle/>
+          <a:p>
+            <a:pPr algn="l">
+              <a:lnSpc>
+                <a:spcPct val="100000"/>
+              </a:lnSpc>
+            </a:pPr>
+            <a:r>
+              <a:rPr sz="860" b="0">
+                <a:solidFill>
+                  <a:srgbClr val="202020"/>
+                </a:solidFill>
+                <a:latin typeface="Times New Roman"/>
+              </a:rPr>
+              <a:t>link / 1 Hz UDP telemetry: aborts, rows_max, stall, gap_min/max and pane_bad. The same counters are readable over UART, JTAG and the wire.</a:t>
+            </a:r>
+          </a:p>
+        </p:txBody>
+      </p:sp>
+      <p:sp>
+        <p:nvSpPr>
+          <p:cNvPr id="55" name="Rounded Rectangle 54"/>
+          <p:cNvSpPr/>
+          <p:nvPr/>
+        </p:nvSpPr>
+        <p:spPr>
+          <a:xfrm>
+            <a:off x="7955279" y="5797296"/>
+            <a:ext cx="3931920" cy="365760"/>
+          </a:xfrm>
+          <a:prstGeom prst="roundRect">
+            <a:avLst>
+              <a:gd name="adj" fmla="val 15000"/>
+            </a:avLst>
+          </a:prstGeom>
+          <a:solidFill>
+            <a:srgbClr val="F5ECF1"/>
+          </a:solidFill>
+          <a:ln w="11430">
+            <a:solidFill>
+              <a:srgbClr val="7A2D5E"/>
+            </a:solidFill>
+          </a:ln>
+        </p:spPr>
+        <p:style>
+          <a:lnRef idx="1">
+            <a:schemeClr val="accent1"/>
+          </a:lnRef>
+          <a:fillRef idx="3">
+            <a:schemeClr val="accent1"/>
+          </a:fillRef>
+          <a:effectRef idx="2">
+            <a:schemeClr val="accent1"/>
+          </a:effectRef>
+          <a:fontRef idx="minor">
+            <a:schemeClr val="lt1"/>
+          </a:fontRef>
+        </p:style>
+        <p:txBody>
           <a:bodyPr rtlCol="0" anchor="ctr" lIns="109728" tIns="0" bIns="0"/>
           <a:lstStyle/>
           <a:p>
             <a:pPr algn="ctr"/>
             <a:r>
-              <a:rPr sz="900" b="1">
+              <a:rPr sz="860" b="1">
                 <a:solidFill>
                   <a:srgbClr val="7A2D5E"/>
                 </a:solidFill>
@@ -5130,9 +5299,48 @@
           </a:p>
         </p:txBody>
       </p:sp>
+      <p:sp>
+        <p:nvSpPr>
+          <p:cNvPr id="56" name="TextBox 55"/>
+          <p:cNvSpPr txBox="1"/>
+          <p:nvPr/>
+        </p:nvSpPr>
+        <p:spPr>
+          <a:xfrm>
+            <a:off x="7955279" y="6254496"/>
+            <a:ext cx="3931920" cy="256032"/>
+          </a:xfrm>
+          <a:prstGeom prst="rect">
+            <a:avLst/>
+          </a:prstGeom>
+          <a:noFill/>
+        </p:spPr>
+        <p:txBody>
+          <a:bodyPr wrap="square" lIns="0" rIns="0" tIns="0" bIns="0" anchor="t">
+            <a:spAutoFit/>
+          </a:bodyPr>
+          <a:lstStyle/>
+          <a:p>
+            <a:pPr algn="l">
+              <a:lnSpc>
+                <a:spcPct val="100000"/>
+              </a:lnSpc>
+            </a:pPr>
+            <a:r>
+              <a:rPr sz="670" b="0">
+                <a:solidFill>
+                  <a:srgbClr val="5C5C5C"/>
+                </a:solidFill>
+                <a:latin typeface="Times New Roman"/>
+              </a:rPr>
+              <a:t>Conclusion: one frame, two panes, one wire-readable account.  Next: 1080p, dual-stream, close RGMII TX hold.</a:t>
+            </a:r>
+          </a:p>
+        </p:txBody>
+      </p:sp>
       <p:cxnSp>
         <p:nvCxnSpPr>
-          <p:cNvPr id="52" name="Connector 51"/>
+          <p:cNvPr id="57" name="Connector 56"/>
           <p:cNvCxnSpPr/>
           <p:nvPr/>
         </p:nvCxnSpPr>
@@ -5167,7 +5375,7 @@
       </p:cxnSp>
       <p:sp>
         <p:nvSpPr>
-          <p:cNvPr id="53" name="TextBox 52"/>
+          <p:cNvPr id="58" name="TextBox 57"/>
           <p:cNvSpPr txBox="1"/>
           <p:nvPr/>
         </p:nvSpPr>
@@ -5206,7 +5414,7 @@
       </p:sp>
       <p:pic>
         <p:nvPicPr>
-          <p:cNvPr id="54" name="Picture 53" descr="amd_logo_black.png"/>
+          <p:cNvPr id="59" name="Picture 58" descr="amd_logo_black.png"/>
           <p:cNvPicPr>
             <a:picLocks noChangeAspect="1"/>
           </p:cNvPicPr>

</xml_diff>

<commit_message>
poster: show board and screen, simplify architecture, add conclusion
</commit_message>
<xml_diff>
--- a/prj_fin/deliverables/poster.pptx
+++ b/prj_fin/deliverables/poster.pptx
@@ -3508,7 +3508,7 @@
       </p:sp>
       <p:pic>
         <p:nvPicPr>
-          <p:cNvPr id="13" name="Picture 12" descr="poster_board.jpg"/>
+          <p:cNvPr id="13" name="Picture 12" descr="poster_overview.jpg"/>
           <p:cNvPicPr>
             <a:picLocks noChangeAspect="1"/>
           </p:cNvPicPr>
@@ -3522,8 +3522,8 @@
         </p:blipFill>
         <p:spPr>
           <a:xfrm>
-            <a:off x="10195560" y="112268"/>
-            <a:ext cx="1737360" cy="1302510"/>
+            <a:off x="10058400" y="109728"/>
+            <a:ext cx="1828800" cy="914400"/>
           </a:xfrm>
           <a:prstGeom prst="rect">
             <a:avLst/>
@@ -3826,7 +3826,7 @@
               </a:lnSpc>
             </a:pPr>
             <a:r>
-              <a:rPr sz="670" b="0">
+              <a:rPr sz="700" b="0">
                 <a:solidFill>
                   <a:srgbClr val="202020"/>
                 </a:solidFill>
@@ -3893,7 +3893,7 @@
       </p:sp>
       <p:pic>
         <p:nvPicPr>
-          <p:cNvPr id="23" name="Picture 22" descr="poster_arch.png"/>
+          <p:cNvPr id="23" name="Picture 22" descr="poster_arch_simple.png"/>
           <p:cNvPicPr>
             <a:picLocks noChangeAspect="1"/>
           </p:cNvPicPr>
@@ -3907,8 +3907,8 @@
         </p:blipFill>
         <p:spPr>
           <a:xfrm>
-            <a:off x="3943694" y="2267712"/>
-            <a:ext cx="3771211" cy="1709928"/>
+            <a:off x="3948379" y="2267712"/>
+            <a:ext cx="3761841" cy="1709928"/>
           </a:xfrm>
           <a:prstGeom prst="rect">
             <a:avLst/>
@@ -3943,7 +3943,7 @@
               </a:lnSpc>
             </a:pPr>
             <a:r>
-              <a:rPr sz="700" b="0">
+              <a:rPr sz="680" b="0">
                 <a:solidFill>
                   <a:srgbClr val="5C5C5C"/>
                 </a:solidFill>
@@ -3956,27 +3956,23 @@
       </p:sp>
       <p:sp>
         <p:nvSpPr>
-          <p:cNvPr id="25" name="Rounded Rectangle 24"/>
+          <p:cNvPr id="25" name="Rectangle 24"/>
           <p:cNvSpPr/>
           <p:nvPr/>
         </p:nvSpPr>
         <p:spPr>
           <a:xfrm>
-            <a:off x="3931920" y="4389120"/>
-            <a:ext cx="3794760" cy="1005840"/>
-          </a:xfrm>
-          <a:prstGeom prst="roundRect">
-            <a:avLst>
-              <a:gd name="adj" fmla="val 8000"/>
-            </a:avLst>
+            <a:off x="3931920" y="4224528"/>
+            <a:ext cx="3794760" cy="274320"/>
+          </a:xfrm>
+          <a:prstGeom prst="rect">
+            <a:avLst/>
           </a:prstGeom>
           <a:solidFill>
-            <a:srgbClr val="FFFFFF"/>
+            <a:srgbClr val="1C1C1C"/>
           </a:solidFill>
-          <a:ln w="11430">
-            <a:solidFill>
-              <a:srgbClr val="AAAAAA"/>
-            </a:solidFill>
+          <a:ln>
+            <a:noFill/>
           </a:ln>
         </p:spPr>
         <p:style>
@@ -3994,38 +3990,18 @@
           </a:fontRef>
         </p:style>
         <p:txBody>
-          <a:bodyPr rtlCol="0" anchor="ctr" wrap="square" lIns="146304" rIns="128016" tIns="73152" bIns="54864"/>
-          <a:lstStyle/>
-          <a:p>
-            <a:pPr algn="ctr">
-              <a:spcAft>
-                <a:spcPts val="300"/>
-              </a:spcAft>
-            </a:pPr>
-            <a:r>
-              <a:rPr sz="1050" b="1">
-                <a:solidFill>
-                  <a:srgbClr val="7A2D5E"/>
-                </a:solidFill>
-                <a:latin typeface="Arial"/>
+          <a:bodyPr rtlCol="0" anchor="ctr" lIns="109728" rIns="73152" tIns="0" bIns="0"/>
+          <a:lstStyle/>
+          <a:p>
+            <a:pPr algn="l"/>
+            <a:r>
+              <a:rPr sz="1250" b="1">
+                <a:solidFill>
+                  <a:srgbClr val="FFFFFF"/>
+                </a:solidFill>
+                <a:latin typeface="Arial Black"/>
               </a:rPr>
-              <a:t>THREE-GATE COMMIT</a:t>
-            </a:r>
-          </a:p>
-          <a:p>
-            <a:pPr>
-              <a:lnSpc>
-                <a:spcPct val="100000"/>
-              </a:lnSpc>
-            </a:pPr>
-            <a:r>
-              <a:rPr sz="850">
-                <a:solidFill>
-                  <a:srgbClr val="202020"/>
-                </a:solidFill>
-                <a:latin typeface="Times New Roman"/>
-              </a:rPr>
-              <a:t>A frame is committed only when 307200 bytes arrived, all 300 source rows were written, and no packet failed. Otherwise the last good frame stays on screen and aborts + rows_max expose the reason.</a:t>
+              <a:t>CREATIVE DESIGN</a:t>
             </a:r>
           </a:p>
         </p:txBody>
@@ -4038,8 +4014,8 @@
         </p:nvSpPr>
         <p:spPr>
           <a:xfrm>
-            <a:off x="3931920" y="5504688"/>
-            <a:ext cx="3794760" cy="1005840"/>
+            <a:off x="3931920" y="4572000"/>
+            <a:ext cx="3794760" cy="932688"/>
           </a:xfrm>
           <a:prstGeom prst="roundRect">
             <a:avLst>
@@ -4085,7 +4061,7 @@
                 </a:solidFill>
                 <a:latin typeface="Arial"/>
               </a:rPr>
-              <a:t>SAME-FRAME A/B</a:t>
+              <a:t>THREE-GATE COMMIT</a:t>
             </a:r>
           </a:p>
           <a:p>
@@ -4101,30 +4077,34 @@
                 </a:solidFill>
                 <a:latin typeface="Times New Roman"/>
               </a:rPr>
-              <a:t>Original and processed panes share one source-coordinate stream, one row map and one 15-cycle effect chain. The seam is a per-pixel select; rotation or stacked effects cannot make the panes disagree.</a:t>
-            </a:r>
-          </a:p>
-        </p:txBody>
-      </p:sp>
-      <p:sp>
-        <p:nvSpPr>
-          <p:cNvPr id="27" name="Rectangle 26"/>
+              <a:t>A frame is committed only when 307200 bytes arrived, all 300 source rows were written, and no packet failed. Otherwise the last good frame stays on screen and aborts + rows_max expose the reason.</a:t>
+            </a:r>
+          </a:p>
+        </p:txBody>
+      </p:sp>
+      <p:sp>
+        <p:nvSpPr>
+          <p:cNvPr id="27" name="Rounded Rectangle 26"/>
           <p:cNvSpPr/>
           <p:nvPr/>
         </p:nvSpPr>
         <p:spPr>
           <a:xfrm>
-            <a:off x="7909560" y="1847088"/>
-            <a:ext cx="4023360" cy="347472"/>
-          </a:xfrm>
-          <a:prstGeom prst="rect">
-            <a:avLst/>
+            <a:off x="3931920" y="5577840"/>
+            <a:ext cx="3794760" cy="932688"/>
+          </a:xfrm>
+          <a:prstGeom prst="roundRect">
+            <a:avLst>
+              <a:gd name="adj" fmla="val 8000"/>
+            </a:avLst>
           </a:prstGeom>
           <a:solidFill>
-            <a:srgbClr val="1C1C1C"/>
+            <a:srgbClr val="FFFFFF"/>
           </a:solidFill>
-          <a:ln>
-            <a:noFill/>
+          <a:ln w="11430">
+            <a:solidFill>
+              <a:srgbClr val="AAAAAA"/>
+            </a:solidFill>
           </a:ln>
         </p:spPr>
         <p:style>
@@ -4142,77 +4122,58 @@
           </a:fontRef>
         </p:style>
         <p:txBody>
-          <a:bodyPr rtlCol="0" anchor="ctr" lIns="109728" rIns="73152" tIns="0" bIns="0"/>
-          <a:lstStyle/>
-          <a:p>
-            <a:pPr algn="l"/>
-            <a:r>
-              <a:rPr sz="1500" b="1">
-                <a:solidFill>
-                  <a:srgbClr val="FFFFFF"/>
-                </a:solidFill>
-                <a:latin typeface="Arial Black"/>
+          <a:bodyPr rtlCol="0" anchor="ctr" wrap="square" lIns="146304" rIns="128016" tIns="73152" bIns="54864"/>
+          <a:lstStyle/>
+          <a:p>
+            <a:pPr algn="ctr">
+              <a:spcAft>
+                <a:spcPts val="300"/>
+              </a:spcAft>
+            </a:pPr>
+            <a:r>
+              <a:rPr sz="1050" b="1">
+                <a:solidFill>
+                  <a:srgbClr val="7A2D5E"/>
+                </a:solidFill>
+                <a:latin typeface="Arial"/>
               </a:rPr>
-              <a:t>RESULT</a:t>
-            </a:r>
-          </a:p>
-        </p:txBody>
-      </p:sp>
-      <p:sp>
-        <p:nvSpPr>
-          <p:cNvPr id="28" name="TextBox 27"/>
-          <p:cNvSpPr txBox="1"/>
-          <p:nvPr/>
-        </p:nvSpPr>
-        <p:spPr>
-          <a:xfrm>
-            <a:off x="7955279" y="2267712"/>
-            <a:ext cx="3931920" cy="502920"/>
-          </a:xfrm>
-          <a:prstGeom prst="rect">
-            <a:avLst/>
-          </a:prstGeom>
-          <a:noFill/>
-        </p:spPr>
-        <p:txBody>
-          <a:bodyPr wrap="square" lIns="0" rIns="0" tIns="0" bIns="0" anchor="t">
-            <a:spAutoFit/>
-          </a:bodyPr>
-          <a:lstStyle/>
-          <a:p>
-            <a:pPr algn="l">
+              <a:t>SAME-FRAME A/B</a:t>
+            </a:r>
+          </a:p>
+          <a:p>
+            <a:pPr>
               <a:lnSpc>
                 <a:spcPct val="100000"/>
               </a:lnSpc>
             </a:pPr>
             <a:r>
-              <a:rPr sz="919" b="0">
+              <a:rPr sz="850">
                 <a:solidFill>
                   <a:srgbClr val="202020"/>
                 </a:solidFill>
                 <a:latin typeface="Times New Roman"/>
               </a:rPr>
-              <a:t>RGMII -&gt; HDMI entirely in PL; PS only control, SD playback and telemetry. 1024x600 at 59.5 Hz, 1 GbE UDP ingest.</a:t>
-            </a:r>
-          </a:p>
-        </p:txBody>
-      </p:sp>
-      <p:sp>
-        <p:nvSpPr>
-          <p:cNvPr id="29" name="Rectangle 28"/>
+              <a:t>The original tap is delay-aligned to the 15-cycle processed path; both panes share one coordinate stream and one row map. The seam is a per-pixel select; rotation or stacked effects cannot make the panes disagree.</a:t>
+            </a:r>
+          </a:p>
+        </p:txBody>
+      </p:sp>
+      <p:sp>
+        <p:nvSpPr>
+          <p:cNvPr id="28" name="Rectangle 27"/>
           <p:cNvSpPr/>
           <p:nvPr/>
         </p:nvSpPr>
         <p:spPr>
           <a:xfrm>
-            <a:off x="7955279" y="2880360"/>
-            <a:ext cx="3931920" cy="228600"/>
+            <a:off x="7909560" y="1847088"/>
+            <a:ext cx="4023360" cy="347472"/>
           </a:xfrm>
           <a:prstGeom prst="rect">
             <a:avLst/>
           </a:prstGeom>
           <a:solidFill>
-            <a:srgbClr val="F8F8F8"/>
+            <a:srgbClr val="1C1C1C"/>
           </a:solidFill>
           <a:ln>
             <a:noFill/>
@@ -4233,23 +4194,32 @@
           </a:fontRef>
         </p:style>
         <p:txBody>
-          <a:bodyPr rtlCol="0" anchor="ctr"/>
-          <a:lstStyle/>
-          <a:p>
-            <a:pPr algn="ctr"/>
-          </a:p>
-        </p:txBody>
-      </p:sp>
-      <p:sp>
-        <p:nvSpPr>
-          <p:cNvPr id="30" name="TextBox 29"/>
+          <a:bodyPr rtlCol="0" anchor="ctr" lIns="109728" rIns="73152" tIns="0" bIns="0"/>
+          <a:lstStyle/>
+          <a:p>
+            <a:pPr algn="l"/>
+            <a:r>
+              <a:rPr sz="1500" b="1">
+                <a:solidFill>
+                  <a:srgbClr val="FFFFFF"/>
+                </a:solidFill>
+                <a:latin typeface="Arial Black"/>
+              </a:rPr>
+              <a:t>RESULT</a:t>
+            </a:r>
+          </a:p>
+        </p:txBody>
+      </p:sp>
+      <p:sp>
+        <p:nvSpPr>
+          <p:cNvPr id="29" name="TextBox 28"/>
           <p:cNvSpPr txBox="1"/>
           <p:nvPr/>
         </p:nvSpPr>
         <p:spPr>
           <a:xfrm>
-            <a:off x="8010144" y="2907791"/>
-            <a:ext cx="1234440" cy="173736"/>
+            <a:off x="7955279" y="2267712"/>
+            <a:ext cx="3931920" cy="530352"/>
           </a:xfrm>
           <a:prstGeom prst="rect">
             <a:avLst/>
@@ -4268,72 +4238,33 @@
               </a:lnSpc>
             </a:pPr>
             <a:r>
-              <a:rPr sz="800" b="1">
-                <a:solidFill>
-                  <a:srgbClr val="5C5C5C"/>
-                </a:solidFill>
-                <a:latin typeface="Arial"/>
+              <a:rPr sz="890" b="0">
+                <a:solidFill>
+                  <a:srgbClr val="202020"/>
+                </a:solidFill>
+                <a:latin typeface="Times New Roman"/>
               </a:rPr>
-              <a:t>Setup WNS</a:t>
-            </a:r>
-          </a:p>
-        </p:txBody>
-      </p:sp>
-      <p:sp>
-        <p:nvSpPr>
-          <p:cNvPr id="31" name="TextBox 30"/>
-          <p:cNvSpPr txBox="1"/>
-          <p:nvPr/>
-        </p:nvSpPr>
-        <p:spPr>
-          <a:xfrm>
-            <a:off x="9235440" y="2907791"/>
-            <a:ext cx="2578608" cy="173736"/>
-          </a:xfrm>
-          <a:prstGeom prst="rect">
-            <a:avLst/>
-          </a:prstGeom>
-          <a:noFill/>
-        </p:spPr>
-        <p:txBody>
-          <a:bodyPr wrap="square" lIns="0" rIns="0" tIns="0" bIns="0" anchor="t">
-            <a:spAutoFit/>
-          </a:bodyPr>
-          <a:lstStyle/>
-          <a:p>
-            <a:pPr algn="l">
-              <a:lnSpc>
-                <a:spcPct val="100000"/>
-              </a:lnSpc>
-            </a:pPr>
-            <a:r>
-              <a:rPr sz="840" b="0">
-                <a:solidFill>
-                  <a:srgbClr val="202020"/>
-                </a:solidFill>
-                <a:latin typeface="Arial"/>
-              </a:rPr>
-              <a:t>1.341 ns  ·  0 failing endpoints</a:t>
-            </a:r>
-          </a:p>
-        </p:txBody>
-      </p:sp>
-      <p:sp>
-        <p:nvSpPr>
-          <p:cNvPr id="32" name="Rectangle 31"/>
+              <a:t>RGMII -&gt; HDMI entirely in PL; PS only control, SD playback and serial status. 1024x600 at 59.5 Hz; 74 Mb/s payload on 1 GbE; PL-internal latency 2-16 ms.</a:t>
+            </a:r>
+          </a:p>
+        </p:txBody>
+      </p:sp>
+      <p:sp>
+        <p:nvSpPr>
+          <p:cNvPr id="30" name="Rectangle 29"/>
           <p:cNvSpPr/>
           <p:nvPr/>
         </p:nvSpPr>
         <p:spPr>
           <a:xfrm>
-            <a:off x="7955279" y="3127248"/>
+            <a:off x="7955279" y="2880360"/>
             <a:ext cx="3931920" cy="228600"/>
           </a:xfrm>
           <a:prstGeom prst="rect">
             <a:avLst/>
           </a:prstGeom>
           <a:solidFill>
-            <a:srgbClr val="FFFFFF"/>
+            <a:srgbClr val="F8F8F8"/>
           </a:solidFill>
           <a:ln>
             <a:noFill/>
@@ -4363,13 +4294,13 @@
       </p:sp>
       <p:sp>
         <p:nvSpPr>
-          <p:cNvPr id="33" name="TextBox 32"/>
+          <p:cNvPr id="31" name="TextBox 30"/>
           <p:cNvSpPr txBox="1"/>
           <p:nvPr/>
         </p:nvSpPr>
         <p:spPr>
           <a:xfrm>
-            <a:off x="8010144" y="3154679"/>
+            <a:off x="8010144" y="2907791"/>
             <a:ext cx="1234440" cy="173736"/>
           </a:xfrm>
           <a:prstGeom prst="rect">
@@ -4389,26 +4320,26 @@
               </a:lnSpc>
             </a:pPr>
             <a:r>
-              <a:rPr sz="800" b="1">
+              <a:rPr sz="819" b="1">
                 <a:solidFill>
                   <a:srgbClr val="5C5C5C"/>
                 </a:solidFill>
                 <a:latin typeface="Arial"/>
               </a:rPr>
-              <a:t>Hold WHS</a:t>
-            </a:r>
-          </a:p>
-        </p:txBody>
-      </p:sp>
-      <p:sp>
-        <p:nvSpPr>
-          <p:cNvPr id="34" name="TextBox 33"/>
+              <a:t>Setup WNS</a:t>
+            </a:r>
+          </a:p>
+        </p:txBody>
+      </p:sp>
+      <p:sp>
+        <p:nvSpPr>
+          <p:cNvPr id="32" name="TextBox 31"/>
           <p:cNvSpPr txBox="1"/>
           <p:nvPr/>
         </p:nvSpPr>
         <p:spPr>
           <a:xfrm>
-            <a:off x="9235440" y="3154679"/>
+            <a:off x="9235440" y="2907791"/>
             <a:ext cx="2578608" cy="173736"/>
           </a:xfrm>
           <a:prstGeom prst="rect">
@@ -4428,33 +4359,33 @@
               </a:lnSpc>
             </a:pPr>
             <a:r>
-              <a:rPr sz="840" b="0">
+              <a:rPr sz="860" b="0">
                 <a:solidFill>
                   <a:srgbClr val="202020"/>
                 </a:solidFill>
                 <a:latin typeface="Arial"/>
               </a:rPr>
-              <a:t>0.025 ns  ·  positive margin</a:t>
-            </a:r>
-          </a:p>
-        </p:txBody>
-      </p:sp>
-      <p:sp>
-        <p:nvSpPr>
-          <p:cNvPr id="35" name="Rectangle 34"/>
+              <a:t>1.341 ns  ·  0 failing endpoints</a:t>
+            </a:r>
+          </a:p>
+        </p:txBody>
+      </p:sp>
+      <p:sp>
+        <p:nvSpPr>
+          <p:cNvPr id="33" name="Rectangle 32"/>
           <p:cNvSpPr/>
           <p:nvPr/>
         </p:nvSpPr>
         <p:spPr>
           <a:xfrm>
-            <a:off x="7955279" y="3374136"/>
+            <a:off x="7955279" y="3127248"/>
             <a:ext cx="3931920" cy="228600"/>
           </a:xfrm>
           <a:prstGeom prst="rect">
             <a:avLst/>
           </a:prstGeom>
           <a:solidFill>
-            <a:srgbClr val="F8F8F8"/>
+            <a:srgbClr val="FFFFFF"/>
           </a:solidFill>
           <a:ln>
             <a:noFill/>
@@ -4484,13 +4415,13 @@
       </p:sp>
       <p:sp>
         <p:nvSpPr>
-          <p:cNvPr id="36" name="TextBox 35"/>
+          <p:cNvPr id="34" name="TextBox 33"/>
           <p:cNvSpPr txBox="1"/>
           <p:nvPr/>
         </p:nvSpPr>
         <p:spPr>
           <a:xfrm>
-            <a:off x="8010144" y="3401568"/>
+            <a:off x="8010144" y="3154679"/>
             <a:ext cx="1234440" cy="173736"/>
           </a:xfrm>
           <a:prstGeom prst="rect">
@@ -4510,26 +4441,26 @@
               </a:lnSpc>
             </a:pPr>
             <a:r>
-              <a:rPr sz="800" b="1">
+              <a:rPr sz="819" b="1">
                 <a:solidFill>
                   <a:srgbClr val="5C5C5C"/>
                 </a:solidFill>
                 <a:latin typeface="Arial"/>
               </a:rPr>
-              <a:t>BRAM</a:t>
-            </a:r>
-          </a:p>
-        </p:txBody>
-      </p:sp>
-      <p:sp>
-        <p:nvSpPr>
-          <p:cNvPr id="37" name="TextBox 36"/>
+              <a:t>Hold WHS</a:t>
+            </a:r>
+          </a:p>
+        </p:txBody>
+      </p:sp>
+      <p:sp>
+        <p:nvSpPr>
+          <p:cNvPr id="35" name="TextBox 34"/>
           <p:cNvSpPr txBox="1"/>
           <p:nvPr/>
         </p:nvSpPr>
         <p:spPr>
           <a:xfrm>
-            <a:off x="9235440" y="3401568"/>
+            <a:off x="9235440" y="3154679"/>
             <a:ext cx="2578608" cy="173736"/>
           </a:xfrm>
           <a:prstGeom prst="rect">
@@ -4549,33 +4480,33 @@
               </a:lnSpc>
             </a:pPr>
             <a:r>
-              <a:rPr sz="840" b="0">
+              <a:rPr sz="860" b="0">
                 <a:solidFill>
                   <a:srgbClr val="202020"/>
                 </a:solidFill>
                 <a:latin typeface="Arial"/>
               </a:rPr>
-              <a:t>70.0%  ·  98 / 140 tiles</a:t>
-            </a:r>
-          </a:p>
-        </p:txBody>
-      </p:sp>
-      <p:sp>
-        <p:nvSpPr>
-          <p:cNvPr id="38" name="Rectangle 37"/>
+              <a:t>0.025 ns  ·  positive margin</a:t>
+            </a:r>
+          </a:p>
+        </p:txBody>
+      </p:sp>
+      <p:sp>
+        <p:nvSpPr>
+          <p:cNvPr id="36" name="Rectangle 35"/>
           <p:cNvSpPr/>
           <p:nvPr/>
         </p:nvSpPr>
         <p:spPr>
           <a:xfrm>
-            <a:off x="7955279" y="3621024"/>
+            <a:off x="7955279" y="3374136"/>
             <a:ext cx="3931920" cy="228600"/>
           </a:xfrm>
           <a:prstGeom prst="rect">
             <a:avLst/>
           </a:prstGeom>
           <a:solidFill>
-            <a:srgbClr val="FFFFFF"/>
+            <a:srgbClr val="F8F8F8"/>
           </a:solidFill>
           <a:ln>
             <a:noFill/>
@@ -4605,13 +4536,13 @@
       </p:sp>
       <p:sp>
         <p:nvSpPr>
-          <p:cNvPr id="39" name="TextBox 38"/>
+          <p:cNvPr id="37" name="TextBox 36"/>
           <p:cNvSpPr txBox="1"/>
           <p:nvPr/>
         </p:nvSpPr>
         <p:spPr>
           <a:xfrm>
-            <a:off x="8010144" y="3648456"/>
+            <a:off x="8010144" y="3401568"/>
             <a:ext cx="1234440" cy="173736"/>
           </a:xfrm>
           <a:prstGeom prst="rect">
@@ -4631,26 +4562,26 @@
               </a:lnSpc>
             </a:pPr>
             <a:r>
-              <a:rPr sz="800" b="1">
+              <a:rPr sz="819" b="1">
                 <a:solidFill>
                   <a:srgbClr val="5C5C5C"/>
                 </a:solidFill>
                 <a:latin typeface="Arial"/>
               </a:rPr>
-              <a:t>8 s stream</a:t>
-            </a:r>
-          </a:p>
-        </p:txBody>
-      </p:sp>
-      <p:sp>
-        <p:nvSpPr>
-          <p:cNvPr id="40" name="TextBox 39"/>
+              <a:t>BRAM</a:t>
+            </a:r>
+          </a:p>
+        </p:txBody>
+      </p:sp>
+      <p:sp>
+        <p:nvSpPr>
+          <p:cNvPr id="38" name="TextBox 37"/>
           <p:cNvSpPr txBox="1"/>
           <p:nvPr/>
         </p:nvSpPr>
         <p:spPr>
           <a:xfrm>
-            <a:off x="9235440" y="3648456"/>
+            <a:off x="9235440" y="3401568"/>
             <a:ext cx="2578608" cy="173736"/>
           </a:xfrm>
           <a:prstGeom prst="rect">
@@ -4670,33 +4601,33 @@
               </a:lnSpc>
             </a:pPr>
             <a:r>
-              <a:rPr sz="840" b="0">
+              <a:rPr sz="860" b="0">
                 <a:solidFill>
                   <a:srgbClr val="202020"/>
                 </a:solidFill>
                 <a:latin typeface="Arial"/>
               </a:rPr>
-              <a:t>241 frames  ·  29.95 fps</a:t>
-            </a:r>
-          </a:p>
-        </p:txBody>
-      </p:sp>
-      <p:sp>
-        <p:nvSpPr>
-          <p:cNvPr id="41" name="Rectangle 40"/>
+              <a:t>70.0%  ·  98 / 140 tiles</a:t>
+            </a:r>
+          </a:p>
+        </p:txBody>
+      </p:sp>
+      <p:sp>
+        <p:nvSpPr>
+          <p:cNvPr id="39" name="Rectangle 38"/>
           <p:cNvSpPr/>
           <p:nvPr/>
         </p:nvSpPr>
         <p:spPr>
           <a:xfrm>
-            <a:off x="7955279" y="3867912"/>
+            <a:off x="7955279" y="3621024"/>
             <a:ext cx="3931920" cy="228600"/>
           </a:xfrm>
           <a:prstGeom prst="rect">
             <a:avLst/>
           </a:prstGeom>
           <a:solidFill>
-            <a:srgbClr val="F8F8F8"/>
+            <a:srgbClr val="FFFFFF"/>
           </a:solidFill>
           <a:ln>
             <a:noFill/>
@@ -4726,13 +4657,13 @@
       </p:sp>
       <p:sp>
         <p:nvSpPr>
-          <p:cNvPr id="42" name="TextBox 41"/>
+          <p:cNvPr id="40" name="TextBox 39"/>
           <p:cNvSpPr txBox="1"/>
           <p:nvPr/>
         </p:nvSpPr>
         <p:spPr>
           <a:xfrm>
-            <a:off x="8010144" y="3895344"/>
+            <a:off x="8010144" y="3648456"/>
             <a:ext cx="1234440" cy="173736"/>
           </a:xfrm>
           <a:prstGeom prst="rect">
@@ -4752,26 +4683,26 @@
               </a:lnSpc>
             </a:pPr>
             <a:r>
-              <a:rPr sz="800" b="1">
+              <a:rPr sz="819" b="1">
                 <a:solidFill>
                   <a:srgbClr val="5C5C5C"/>
                 </a:solidFill>
                 <a:latin typeface="Arial"/>
               </a:rPr>
-              <a:t>UART battery</a:t>
-            </a:r>
-          </a:p>
-        </p:txBody>
-      </p:sp>
-      <p:sp>
-        <p:nvSpPr>
-          <p:cNvPr id="43" name="TextBox 42"/>
+              <a:t>8.05 s stream</a:t>
+            </a:r>
+          </a:p>
+        </p:txBody>
+      </p:sp>
+      <p:sp>
+        <p:nvSpPr>
+          <p:cNvPr id="41" name="TextBox 40"/>
           <p:cNvSpPr txBox="1"/>
           <p:nvPr/>
         </p:nvSpPr>
         <p:spPr>
           <a:xfrm>
-            <a:off x="9235440" y="3895344"/>
+            <a:off x="9235440" y="3648456"/>
             <a:ext cx="2578608" cy="173736"/>
           </a:xfrm>
           <a:prstGeom prst="rect">
@@ -4791,33 +4722,33 @@
               </a:lnSpc>
             </a:pPr>
             <a:r>
-              <a:rPr sz="840" b="0">
+              <a:rPr sz="860" b="0">
                 <a:solidFill>
                   <a:srgbClr val="202020"/>
                 </a:solidFill>
                 <a:latin typeface="Arial"/>
               </a:rPr>
-              <a:t>105 commands  ·  PASS</a:t>
-            </a:r>
-          </a:p>
-        </p:txBody>
-      </p:sp>
-      <p:sp>
-        <p:nvSpPr>
-          <p:cNvPr id="44" name="Rectangle 43"/>
+              <a:t>241 frames  ·  29.95 fps</a:t>
+            </a:r>
+          </a:p>
+        </p:txBody>
+      </p:sp>
+      <p:sp>
+        <p:nvSpPr>
+          <p:cNvPr id="42" name="Rectangle 41"/>
           <p:cNvSpPr/>
           <p:nvPr/>
         </p:nvSpPr>
         <p:spPr>
           <a:xfrm>
-            <a:off x="7955279" y="4114800"/>
+            <a:off x="7955279" y="3867912"/>
             <a:ext cx="3931920" cy="228600"/>
           </a:xfrm>
           <a:prstGeom prst="rect">
             <a:avLst/>
           </a:prstGeom>
           <a:solidFill>
-            <a:srgbClr val="FFFFFF"/>
+            <a:srgbClr val="F8F8F8"/>
           </a:solidFill>
           <a:ln>
             <a:noFill/>
@@ -4847,13 +4778,13 @@
       </p:sp>
       <p:sp>
         <p:nvSpPr>
-          <p:cNvPr id="45" name="TextBox 44"/>
+          <p:cNvPr id="43" name="TextBox 42"/>
           <p:cNvSpPr txBox="1"/>
           <p:nvPr/>
         </p:nvSpPr>
         <p:spPr>
           <a:xfrm>
-            <a:off x="8010144" y="4142232"/>
+            <a:off x="8010144" y="3895344"/>
             <a:ext cx="1234440" cy="173736"/>
           </a:xfrm>
           <a:prstGeom prst="rect">
@@ -4873,26 +4804,26 @@
               </a:lnSpc>
             </a:pPr>
             <a:r>
-              <a:rPr sz="800" b="1">
+              <a:rPr sz="819" b="1">
                 <a:solidFill>
                   <a:srgbClr val="5C5C5C"/>
                 </a:solidFill>
                 <a:latin typeface="Arial"/>
               </a:rPr>
-              <a:t>QSPI cold boot</a:t>
-            </a:r>
-          </a:p>
-        </p:txBody>
-      </p:sp>
-      <p:sp>
-        <p:nvSpPr>
-          <p:cNvPr id="46" name="TextBox 45"/>
+              <a:t>UART battery</a:t>
+            </a:r>
+          </a:p>
+        </p:txBody>
+      </p:sp>
+      <p:sp>
+        <p:nvSpPr>
+          <p:cNvPr id="44" name="TextBox 43"/>
           <p:cNvSpPr txBox="1"/>
           <p:nvPr/>
         </p:nvSpPr>
         <p:spPr>
           <a:xfrm>
-            <a:off x="9235440" y="4142232"/>
+            <a:off x="9235440" y="3895344"/>
             <a:ext cx="2578608" cy="173736"/>
           </a:xfrm>
           <a:prstGeom prst="rect">
@@ -4912,33 +4843,33 @@
               </a:lnSpc>
             </a:pPr>
             <a:r>
-              <a:rPr sz="840" b="0">
+              <a:rPr sz="860" b="0">
                 <a:solidFill>
                   <a:srgbClr val="202020"/>
                 </a:solidFill>
                 <a:latin typeface="Arial"/>
               </a:rPr>
-              <a:t>DONE / EOS  ·  no CRC error</a:t>
-            </a:r>
-          </a:p>
-        </p:txBody>
-      </p:sp>
-      <p:sp>
-        <p:nvSpPr>
-          <p:cNvPr id="47" name="Rectangle 46"/>
+              <a:t>105 commands  ·  PASS</a:t>
+            </a:r>
+          </a:p>
+        </p:txBody>
+      </p:sp>
+      <p:sp>
+        <p:nvSpPr>
+          <p:cNvPr id="45" name="Rectangle 44"/>
           <p:cNvSpPr/>
           <p:nvPr/>
         </p:nvSpPr>
         <p:spPr>
           <a:xfrm>
-            <a:off x="7955279" y="4361688"/>
+            <a:off x="7955279" y="4114800"/>
             <a:ext cx="3931920" cy="228600"/>
           </a:xfrm>
           <a:prstGeom prst="rect">
             <a:avLst/>
           </a:prstGeom>
           <a:solidFill>
-            <a:srgbClr val="F8F8F8"/>
+            <a:srgbClr val="FFFFFF"/>
           </a:solidFill>
           <a:ln>
             <a:noFill/>
@@ -4968,13 +4899,13 @@
       </p:sp>
       <p:sp>
         <p:nvSpPr>
-          <p:cNvPr id="48" name="TextBox 47"/>
+          <p:cNvPr id="46" name="TextBox 45"/>
           <p:cNvSpPr txBox="1"/>
           <p:nvPr/>
         </p:nvSpPr>
         <p:spPr>
           <a:xfrm>
-            <a:off x="8010144" y="4389120"/>
+            <a:off x="8010144" y="4142232"/>
             <a:ext cx="1234440" cy="173736"/>
           </a:xfrm>
           <a:prstGeom prst="rect">
@@ -4994,26 +4925,26 @@
               </a:lnSpc>
             </a:pPr>
             <a:r>
-              <a:rPr sz="800" b="1">
+              <a:rPr sz="819" b="1">
                 <a:solidFill>
                   <a:srgbClr val="5C5C5C"/>
                 </a:solidFill>
                 <a:latin typeface="Arial"/>
               </a:rPr>
-              <a:t>Fault injection</a:t>
-            </a:r>
-          </a:p>
-        </p:txBody>
-      </p:sp>
-      <p:sp>
-        <p:nvSpPr>
-          <p:cNvPr id="49" name="TextBox 48"/>
+              <a:t>QSPI cold boot</a:t>
+            </a:r>
+          </a:p>
+        </p:txBody>
+      </p:sp>
+      <p:sp>
+        <p:nvSpPr>
+          <p:cNvPr id="47" name="TextBox 46"/>
           <p:cNvSpPr txBox="1"/>
           <p:nvPr/>
         </p:nvSpPr>
         <p:spPr>
           <a:xfrm>
-            <a:off x="9235440" y="4389120"/>
+            <a:off x="9235440" y="4142232"/>
             <a:ext cx="2578608" cy="173736"/>
           </a:xfrm>
           <a:prstGeom prst="rect">
@@ -5033,33 +4964,33 @@
               </a:lnSpc>
             </a:pPr>
             <a:r>
-              <a:rPr sz="840" b="0">
+              <a:rPr sz="860" b="0">
                 <a:solidFill>
                   <a:srgbClr val="202020"/>
                 </a:solidFill>
                 <a:latin typeface="Arial"/>
               </a:rPr>
-              <a:t>22.0 / 0 / 18.9 fps  ·  PASS</a:t>
-            </a:r>
-          </a:p>
-        </p:txBody>
-      </p:sp>
-      <p:sp>
-        <p:nvSpPr>
-          <p:cNvPr id="50" name="Rectangle 49"/>
+              <a:t>DONE / EOS  ·  no CRC error</a:t>
+            </a:r>
+          </a:p>
+        </p:txBody>
+      </p:sp>
+      <p:sp>
+        <p:nvSpPr>
+          <p:cNvPr id="48" name="Rectangle 47"/>
           <p:cNvSpPr/>
           <p:nvPr/>
         </p:nvSpPr>
         <p:spPr>
           <a:xfrm>
-            <a:off x="7955279" y="4608576"/>
+            <a:off x="7955279" y="4361688"/>
             <a:ext cx="3931920" cy="228600"/>
           </a:xfrm>
           <a:prstGeom prst="rect">
             <a:avLst/>
           </a:prstGeom>
           <a:solidFill>
-            <a:srgbClr val="FFFFFF"/>
+            <a:srgbClr val="F8F8F8"/>
           </a:solidFill>
           <a:ln>
             <a:noFill/>
@@ -5089,13 +5020,13 @@
       </p:sp>
       <p:sp>
         <p:nvSpPr>
-          <p:cNvPr id="51" name="TextBox 50"/>
+          <p:cNvPr id="49" name="TextBox 48"/>
           <p:cNvSpPr txBox="1"/>
           <p:nvPr/>
         </p:nvSpPr>
         <p:spPr>
           <a:xfrm>
-            <a:off x="8010144" y="4636008"/>
+            <a:off x="8010144" y="4389120"/>
             <a:ext cx="1234440" cy="173736"/>
           </a:xfrm>
           <a:prstGeom prst="rect">
@@ -5115,26 +5046,26 @@
               </a:lnSpc>
             </a:pPr>
             <a:r>
-              <a:rPr sz="800" b="1">
+              <a:rPr sz="819" b="1">
                 <a:solidFill>
                   <a:srgbClr val="5C5C5C"/>
                 </a:solidFill>
                 <a:latin typeface="Arial"/>
               </a:rPr>
-              <a:t>LUT / FF / DSP</a:t>
-            </a:r>
-          </a:p>
-        </p:txBody>
-      </p:sp>
-      <p:sp>
-        <p:nvSpPr>
-          <p:cNvPr id="52" name="TextBox 51"/>
+              <a:t>Fault inject (C/L/R)</a:t>
+            </a:r>
+          </a:p>
+        </p:txBody>
+      </p:sp>
+      <p:sp>
+        <p:nvSpPr>
+          <p:cNvPr id="50" name="TextBox 49"/>
           <p:cNvSpPr txBox="1"/>
           <p:nvPr/>
         </p:nvSpPr>
         <p:spPr>
           <a:xfrm>
-            <a:off x="9235440" y="4636008"/>
+            <a:off x="9235440" y="4389120"/>
             <a:ext cx="2578608" cy="173736"/>
           </a:xfrm>
           <a:prstGeom prst="rect">
@@ -5154,118 +5085,36 @@
               </a:lnSpc>
             </a:pPr>
             <a:r>
-              <a:rPr sz="840" b="0">
+              <a:rPr sz="860" b="0">
                 <a:solidFill>
                   <a:srgbClr val="202020"/>
                 </a:solidFill>
                 <a:latin typeface="Arial"/>
               </a:rPr>
-              <a:t>28.13 / 8.55 / 8.64 %</a:t>
-            </a:r>
-          </a:p>
-        </p:txBody>
-      </p:sp>
-      <p:sp>
-        <p:nvSpPr>
-          <p:cNvPr id="53" name="TextBox 52"/>
-          <p:cNvSpPr txBox="1"/>
-          <p:nvPr/>
-        </p:nvSpPr>
-        <p:spPr>
-          <a:xfrm>
-            <a:off x="7955279" y="4965192"/>
-            <a:ext cx="3931920" cy="201168"/>
-          </a:xfrm>
-          <a:prstGeom prst="rect">
-            <a:avLst/>
-          </a:prstGeom>
-          <a:noFill/>
-        </p:spPr>
-        <p:txBody>
-          <a:bodyPr wrap="square" lIns="0" rIns="0" tIns="0" bIns="0" anchor="t">
-            <a:spAutoFit/>
-          </a:bodyPr>
-          <a:lstStyle/>
-          <a:p>
-            <a:pPr algn="l">
-              <a:lnSpc>
-                <a:spcPct val="100000"/>
-              </a:lnSpc>
-            </a:pPr>
-            <a:r>
-              <a:rPr sz="1050" b="1">
-                <a:solidFill>
-                  <a:srgbClr val="7A2D5E"/>
-                </a:solidFill>
-                <a:latin typeface="Arial Black"/>
-              </a:rPr>
-              <a:t>OBSERVABILITY</a:t>
-            </a:r>
-          </a:p>
-        </p:txBody>
-      </p:sp>
-      <p:sp>
-        <p:nvSpPr>
-          <p:cNvPr id="54" name="TextBox 53"/>
-          <p:cNvSpPr txBox="1"/>
-          <p:nvPr/>
-        </p:nvSpPr>
-        <p:spPr>
-          <a:xfrm>
-            <a:off x="7955279" y="5193792"/>
-            <a:ext cx="3931920" cy="530352"/>
-          </a:xfrm>
-          <a:prstGeom prst="rect">
-            <a:avLst/>
-          </a:prstGeom>
-          <a:noFill/>
-        </p:spPr>
-        <p:txBody>
-          <a:bodyPr wrap="square" lIns="0" rIns="0" tIns="0" bIns="0" anchor="t">
-            <a:spAutoFit/>
-          </a:bodyPr>
-          <a:lstStyle/>
-          <a:p>
-            <a:pPr algn="l">
-              <a:lnSpc>
-                <a:spcPct val="100000"/>
-              </a:lnSpc>
-            </a:pPr>
-            <a:r>
-              <a:rPr sz="860" b="0">
-                <a:solidFill>
-                  <a:srgbClr val="202020"/>
-                </a:solidFill>
-                <a:latin typeface="Times New Roman"/>
-              </a:rPr>
-              <a:t>link / 1 Hz UDP telemetry: aborts, rows_max, stall, gap_min/max and pane_bad. The same counters are readable over UART, JTAG and the wire.</a:t>
-            </a:r>
-          </a:p>
-        </p:txBody>
-      </p:sp>
-      <p:sp>
-        <p:nvSpPr>
-          <p:cNvPr id="55" name="Rounded Rectangle 54"/>
+              <a:t>22.0 / 0 / 18.9 fps  ·  PASS</a:t>
+            </a:r>
+          </a:p>
+        </p:txBody>
+      </p:sp>
+      <p:sp>
+        <p:nvSpPr>
+          <p:cNvPr id="51" name="Rectangle 50"/>
           <p:cNvSpPr/>
           <p:nvPr/>
         </p:nvSpPr>
         <p:spPr>
           <a:xfrm>
-            <a:off x="7955279" y="5797296"/>
-            <a:ext cx="3931920" cy="365760"/>
-          </a:xfrm>
-          <a:prstGeom prst="roundRect">
-            <a:avLst>
-              <a:gd name="adj" fmla="val 15000"/>
-            </a:avLst>
+            <a:off x="7955279" y="4608576"/>
+            <a:ext cx="3931920" cy="228600"/>
+          </a:xfrm>
+          <a:prstGeom prst="rect">
+            <a:avLst/>
           </a:prstGeom>
           <a:solidFill>
-            <a:srgbClr val="F5ECF1"/>
+            <a:srgbClr val="FFFFFF"/>
           </a:solidFill>
-          <a:ln w="11430">
-            <a:solidFill>
-              <a:srgbClr val="7A2D5E"/>
-            </a:solidFill>
+          <a:ln>
+            <a:noFill/>
           </a:ln>
         </p:spPr>
         <p:style>
@@ -5283,32 +5132,23 @@
           </a:fontRef>
         </p:style>
         <p:txBody>
-          <a:bodyPr rtlCol="0" anchor="ctr" lIns="109728" tIns="0" bIns="0"/>
+          <a:bodyPr rtlCol="0" anchor="ctr"/>
           <a:lstStyle/>
           <a:p>
             <a:pPr algn="ctr"/>
-            <a:r>
-              <a:rPr sz="860" b="1">
-                <a:solidFill>
-                  <a:srgbClr val="7A2D5E"/>
-                </a:solidFill>
-                <a:latin typeface="Arial"/>
-              </a:rPr>
-              <a:t>DROP 1 IN 100  -&gt;  ABORTS RISE  -&gt;  RECOVERY</a:t>
-            </a:r>
-          </a:p>
-        </p:txBody>
-      </p:sp>
-      <p:sp>
-        <p:nvSpPr>
-          <p:cNvPr id="56" name="TextBox 55"/>
+          </a:p>
+        </p:txBody>
+      </p:sp>
+      <p:sp>
+        <p:nvSpPr>
+          <p:cNvPr id="52" name="TextBox 51"/>
           <p:cNvSpPr txBox="1"/>
           <p:nvPr/>
         </p:nvSpPr>
         <p:spPr>
           <a:xfrm>
-            <a:off x="7955279" y="6254496"/>
-            <a:ext cx="3931920" cy="256032"/>
+            <a:off x="8010144" y="4636008"/>
+            <a:ext cx="1234440" cy="173736"/>
           </a:xfrm>
           <a:prstGeom prst="rect">
             <a:avLst/>
@@ -5327,20 +5167,215 @@
               </a:lnSpc>
             </a:pPr>
             <a:r>
-              <a:rPr sz="670" b="0">
+              <a:rPr sz="819" b="1">
                 <a:solidFill>
                   <a:srgbClr val="5C5C5C"/>
+                </a:solidFill>
+                <a:latin typeface="Arial"/>
+              </a:rPr>
+              <a:t>LUT / FF / DSP</a:t>
+            </a:r>
+          </a:p>
+        </p:txBody>
+      </p:sp>
+      <p:sp>
+        <p:nvSpPr>
+          <p:cNvPr id="53" name="TextBox 52"/>
+          <p:cNvSpPr txBox="1"/>
+          <p:nvPr/>
+        </p:nvSpPr>
+        <p:spPr>
+          <a:xfrm>
+            <a:off x="9235440" y="4636008"/>
+            <a:ext cx="2578608" cy="173736"/>
+          </a:xfrm>
+          <a:prstGeom prst="rect">
+            <a:avLst/>
+          </a:prstGeom>
+          <a:noFill/>
+        </p:spPr>
+        <p:txBody>
+          <a:bodyPr wrap="square" lIns="0" rIns="0" tIns="0" bIns="0" anchor="t">
+            <a:spAutoFit/>
+          </a:bodyPr>
+          <a:lstStyle/>
+          <a:p>
+            <a:pPr algn="l">
+              <a:lnSpc>
+                <a:spcPct val="100000"/>
+              </a:lnSpc>
+            </a:pPr>
+            <a:r>
+              <a:rPr sz="860" b="0">
+                <a:solidFill>
+                  <a:srgbClr val="202020"/>
+                </a:solidFill>
+                <a:latin typeface="Arial"/>
+              </a:rPr>
+              <a:t>28.13 / 8.55 / 8.64 %</a:t>
+            </a:r>
+          </a:p>
+        </p:txBody>
+      </p:sp>
+      <p:sp>
+        <p:nvSpPr>
+          <p:cNvPr id="54" name="TextBox 53"/>
+          <p:cNvSpPr txBox="1"/>
+          <p:nvPr/>
+        </p:nvSpPr>
+        <p:spPr>
+          <a:xfrm>
+            <a:off x="7955279" y="4965192"/>
+            <a:ext cx="3931920" cy="201168"/>
+          </a:xfrm>
+          <a:prstGeom prst="rect">
+            <a:avLst/>
+          </a:prstGeom>
+          <a:noFill/>
+        </p:spPr>
+        <p:txBody>
+          <a:bodyPr wrap="square" lIns="0" rIns="0" tIns="0" bIns="0" anchor="t">
+            <a:spAutoFit/>
+          </a:bodyPr>
+          <a:lstStyle/>
+          <a:p>
+            <a:pPr algn="l">
+              <a:lnSpc>
+                <a:spcPct val="100000"/>
+              </a:lnSpc>
+            </a:pPr>
+            <a:r>
+              <a:rPr sz="1050" b="1">
+                <a:solidFill>
+                  <a:srgbClr val="7A2D5E"/>
+                </a:solidFill>
+                <a:latin typeface="Arial Black"/>
+              </a:rPr>
+              <a:t>OBSERVABILITY</a:t>
+            </a:r>
+          </a:p>
+        </p:txBody>
+      </p:sp>
+      <p:sp>
+        <p:nvSpPr>
+          <p:cNvPr id="55" name="TextBox 54"/>
+          <p:cNvSpPr txBox="1"/>
+          <p:nvPr/>
+        </p:nvSpPr>
+        <p:spPr>
+          <a:xfrm>
+            <a:off x="7955279" y="5175504"/>
+            <a:ext cx="3931920" cy="530352"/>
+          </a:xfrm>
+          <a:prstGeom prst="rect">
+            <a:avLst/>
+          </a:prstGeom>
+          <a:noFill/>
+        </p:spPr>
+        <p:txBody>
+          <a:bodyPr wrap="square" lIns="0" rIns="0" tIns="0" bIns="0" anchor="t">
+            <a:spAutoFit/>
+          </a:bodyPr>
+          <a:lstStyle/>
+          <a:p>
+            <a:pPr algn="l">
+              <a:lnSpc>
+                <a:spcPct val="100000"/>
+              </a:lnSpc>
+            </a:pPr>
+            <a:r>
+              <a:rPr sz="819" b="0">
+                <a:solidFill>
+                  <a:srgbClr val="202020"/>
                 </a:solidFill>
                 <a:latin typeface="Times New Roman"/>
               </a:rPr>
-              <a:t>Conclusion: one frame, two panes, one wire-readable account.  Next: 1080p, dual-stream, close RGMII TX hold.</a:t>
+              <a:t>UART link gives stall and gap_min/max; the 1 Hz PL UDP beacon gives frames, packets, aborts, rows_max, pane_bad and latency. Both read the same counters.</a:t>
+            </a:r>
+          </a:p>
+        </p:txBody>
+      </p:sp>
+      <p:sp>
+        <p:nvSpPr>
+          <p:cNvPr id="56" name="TextBox 55"/>
+          <p:cNvSpPr txBox="1"/>
+          <p:nvPr/>
+        </p:nvSpPr>
+        <p:spPr>
+          <a:xfrm>
+            <a:off x="7955279" y="5669280"/>
+            <a:ext cx="3931920" cy="182880"/>
+          </a:xfrm>
+          <a:prstGeom prst="rect">
+            <a:avLst/>
+          </a:prstGeom>
+          <a:noFill/>
+        </p:spPr>
+        <p:txBody>
+          <a:bodyPr wrap="square" lIns="0" rIns="0" tIns="0" bIns="0" anchor="t">
+            <a:spAutoFit/>
+          </a:bodyPr>
+          <a:lstStyle/>
+          <a:p>
+            <a:pPr algn="l">
+              <a:lnSpc>
+                <a:spcPct val="100000"/>
+              </a:lnSpc>
+            </a:pPr>
+            <a:r>
+              <a:rPr sz="840" b="1">
+                <a:solidFill>
+                  <a:srgbClr val="7A2D5E"/>
+                </a:solidFill>
+                <a:latin typeface="Arial"/>
+              </a:rPr>
+              <a:t>CONCLUSION / NEXT</a:t>
+            </a:r>
+          </a:p>
+        </p:txBody>
+      </p:sp>
+      <p:sp>
+        <p:nvSpPr>
+          <p:cNvPr id="57" name="TextBox 56"/>
+          <p:cNvSpPr txBox="1"/>
+          <p:nvPr/>
+        </p:nvSpPr>
+        <p:spPr>
+          <a:xfrm>
+            <a:off x="7955279" y="5897880"/>
+            <a:ext cx="3931920" cy="566928"/>
+          </a:xfrm>
+          <a:prstGeom prst="rect">
+            <a:avLst/>
+          </a:prstGeom>
+          <a:noFill/>
+        </p:spPr>
+        <p:txBody>
+          <a:bodyPr wrap="square" lIns="0" rIns="0" tIns="0" bIns="0" anchor="t">
+            <a:spAutoFit/>
+          </a:bodyPr>
+          <a:lstStyle/>
+          <a:p>
+            <a:pPr algn="l">
+              <a:lnSpc>
+                <a:spcPct val="100000"/>
+              </a:lnSpc>
+            </a:pPr>
+            <a:r>
+              <a:rPr sz="800" b="0">
+                <a:solidFill>
+                  <a:srgbClr val="202020"/>
+                </a:solidFill>
+                <a:latin typeface="Times New Roman"/>
+              </a:rPr>
+              <a:t>One frame, two panes, one wire-readable account. Next: close RGMII TX hold margin; larger device for higher resolution.</a:t>
             </a:r>
           </a:p>
         </p:txBody>
       </p:sp>
       <p:cxnSp>
         <p:nvCxnSpPr>
-          <p:cNvPr id="57" name="Connector 56"/>
+          <p:cNvPr id="58" name="Connector 57"/>
           <p:cNvCxnSpPr/>
           <p:nvPr/>
         </p:nvCxnSpPr>
@@ -5375,7 +5410,7 @@
       </p:cxnSp>
       <p:sp>
         <p:nvSpPr>
-          <p:cNvPr id="58" name="TextBox 57"/>
+          <p:cNvPr id="59" name="TextBox 58"/>
           <p:cNvSpPr txBox="1"/>
           <p:nvPr/>
         </p:nvSpPr>
@@ -5414,7 +5449,7 @@
       </p:sp>
       <p:pic>
         <p:nvPicPr>
-          <p:cNvPr id="59" name="Picture 58" descr="amd_logo_black.png"/>
+          <p:cNvPr id="60" name="Picture 59" descr="amd_logo_black.png"/>
           <p:cNvPicPr>
             <a:picLocks noChangeAspect="1"/>
           </p:cNvPicPr>

</xml_diff>